<commit_message>
Restyle the deck and split the live summary from the printed instructions.
</commit_message>
<xml_diff>
--- a/docs/Wealth-Symposium-Activity.pptx
+++ b/docs/Wealth-Symposium-Activity.pptx
@@ -11,10 +11,6 @@
     <p:sldId id="259" r:id="rId10"/>
     <p:sldId id="260" r:id="rId11"/>
     <p:sldId id="261" r:id="rId12"/>
-    <p:sldId id="262" r:id="rId13"/>
-    <p:sldId id="263" r:id="rId14"/>
-    <p:sldId id="264" r:id="rId15"/>
-    <p:sldId id="265" r:id="rId16"/>
   </p:sldIdLst>
   <p:sldSz cx="12191695" cy="6858000" type="screen4x3"/>
   <p:notesSz cx="6858000" cy="9144000"/>
@@ -3093,7 +3089,7 @@
     <p:bg>
       <p:bgPr>
         <a:solidFill>
-          <a:srgbClr val="070B14"/>
+          <a:srgbClr val="F6F3FC"/>
         </a:solidFill>
         <a:effectLst/>
       </p:bgPr>
@@ -3113,15 +3109,15 @@
         </p:nvSpPr>
         <p:spPr>
           <a:xfrm>
-            <a:off x="-1097280" y="-1463040"/>
-            <a:ext cx="4754880" cy="4754880"/>
+            <a:off x="-1280160" y="-1645920"/>
+            <a:ext cx="5669280" cy="5669280"/>
           </a:xfrm>
           <a:prstGeom prst="ellipse">
             <a:avLst/>
           </a:prstGeom>
           <a:solidFill>
-            <a:srgbClr val="DB0011">
-              <a:alpha val="38000"/>
+            <a:srgbClr val="D9C6FF">
+              <a:alpha val="70000"/>
             </a:srgbClr>
           </a:solidFill>
           <a:ln>
@@ -3158,15 +3154,15 @@
         </p:nvSpPr>
         <p:spPr>
           <a:xfrm>
-            <a:off x="8595360" y="-1280160"/>
-            <a:ext cx="4206240" cy="4206240"/>
+            <a:off x="7498079" y="-1828800"/>
+            <a:ext cx="5852160" cy="5852160"/>
           </a:xfrm>
           <a:prstGeom prst="ellipse">
             <a:avLst/>
           </a:prstGeom>
           <a:solidFill>
-            <a:srgbClr val="5A8CFF">
-              <a:alpha val="28000"/>
+            <a:srgbClr val="F6C9E8">
+              <a:alpha val="75000"/>
             </a:srgbClr>
           </a:solidFill>
           <a:ln>
@@ -3203,15 +3199,15 @@
         </p:nvSpPr>
         <p:spPr>
           <a:xfrm>
-            <a:off x="7863840" y="4389120"/>
-            <a:ext cx="3840480" cy="3840480"/>
+            <a:off x="3840480" y="4206240"/>
+            <a:ext cx="4937760" cy="4937760"/>
           </a:xfrm>
           <a:prstGeom prst="ellipse">
             <a:avLst/>
           </a:prstGeom>
           <a:solidFill>
-            <a:srgbClr val="50DCB4">
-              <a:alpha val="16000"/>
+            <a:srgbClr val="C9D8FF">
+              <a:alpha val="55000"/>
             </a:srgbClr>
           </a:solidFill>
           <a:ln>
@@ -3248,8 +3244,8 @@
         </p:nvSpPr>
         <p:spPr>
           <a:xfrm>
-            <a:off x="685800" y="502920"/>
-            <a:ext cx="10058400" cy="320040"/>
+            <a:off x="731520" y="1554480"/>
+            <a:ext cx="7315200" cy="320040"/>
           </a:xfrm>
           <a:prstGeom prst="rect">
             <a:avLst/>
@@ -3264,7 +3260,7 @@
             <a:r>
               <a:rPr sz="1400" b="1">
                 <a:solidFill>
-                  <a:srgbClr val="FFB4BC"/>
+                  <a:srgbClr val="6B4EFF"/>
                 </a:solidFill>
                 <a:latin typeface="Calibri"/>
               </a:rPr>
@@ -3281,8 +3277,8 @@
         </p:nvSpPr>
         <p:spPr>
           <a:xfrm>
-            <a:off x="685800" y="1554480"/>
-            <a:ext cx="10789920" cy="1920240"/>
+            <a:off x="685800" y="1965960"/>
+            <a:ext cx="7315200" cy="2103120"/>
           </a:xfrm>
           <a:prstGeom prst="rect">
             <a:avLst/>
@@ -3297,7 +3293,7 @@
             <a:r>
               <a:rPr sz="6000" b="1">
                 <a:solidFill>
-                  <a:srgbClr val="F4F7FB"/>
+                  <a:srgbClr val="1E1B2E"/>
                 </a:solidFill>
                 <a:latin typeface="Calibri"/>
               </a:rPr>
@@ -3315,8 +3311,8 @@
         </p:nvSpPr>
         <p:spPr>
           <a:xfrm>
-            <a:off x="685800" y="4114800"/>
-            <a:ext cx="9692640" cy="1463040"/>
+            <a:off x="731520" y="4297680"/>
+            <a:ext cx="6400800" cy="457200"/>
           </a:xfrm>
           <a:prstGeom prst="rect">
             <a:avLst/>
@@ -3329,188 +3325,27 @@
           <a:p>
             <a:pPr algn="l"/>
             <a:r>
-              <a:rPr sz="2400" b="0">
-                <a:solidFill>
-                  <a:srgbClr val="B7C0D0"/>
+              <a:rPr sz="2600" b="0">
+                <a:solidFill>
+                  <a:srgbClr val="5C5870"/>
                 </a:solidFill>
                 <a:latin typeface="Calibri"/>
               </a:rPr>
-              <a:t>Ideate your agent. Thirty minutes. One laptop. One prototype.</a:t>
-            </a:r>
-          </a:p>
-        </p:txBody>
-      </p:sp>
-    </p:spTree>
-  </p:cSld>
-  <p:clrMapOvr>
-    <a:masterClrMapping/>
-  </p:clrMapOvr>
-</p:sld>
-</file>
-
-<file path=ppt/slides/slide10.xml><?xml version="1.0" encoding="utf-8"?>
-<p:sld xmlns:a="http://schemas.openxmlformats.org/drawingml/2006/main" xmlns:p="http://schemas.openxmlformats.org/presentationml/2006/main" xmlns:r="http://schemas.openxmlformats.org/officeDocument/2006/relationships">
-  <p:cSld>
-    <p:bg>
-      <p:bgPr>
-        <a:solidFill>
-          <a:srgbClr val="070B14"/>
-        </a:solidFill>
-        <a:effectLst/>
-      </p:bgPr>
-    </p:bg>
-    <p:spTree>
-      <p:nvGrpSpPr>
-        <p:cNvPr id="1" name=""/>
-        <p:cNvGrpSpPr/>
-        <p:nvPr/>
-      </p:nvGrpSpPr>
-      <p:grpSpPr/>
-      <p:sp>
-        <p:nvSpPr>
-          <p:cNvPr id="2" name="Oval 1"/>
-          <p:cNvSpPr/>
-          <p:nvPr/>
-        </p:nvSpPr>
-        <p:spPr>
-          <a:xfrm>
-            <a:off x="-1097280" y="-1463040"/>
-            <a:ext cx="4754880" cy="4754880"/>
-          </a:xfrm>
-          <a:prstGeom prst="ellipse">
-            <a:avLst/>
-          </a:prstGeom>
-          <a:solidFill>
-            <a:srgbClr val="DB0011">
-              <a:alpha val="38000"/>
-            </a:srgbClr>
-          </a:solidFill>
-          <a:ln>
-            <a:noFill/>
-          </a:ln>
-        </p:spPr>
-        <p:style>
-          <a:lnRef idx="1">
-            <a:schemeClr val="accent1"/>
-          </a:lnRef>
-          <a:fillRef idx="3">
-            <a:schemeClr val="accent1"/>
-          </a:fillRef>
-          <a:effectRef idx="2">
-            <a:schemeClr val="accent1"/>
-          </a:effectRef>
-          <a:fontRef idx="minor">
-            <a:schemeClr val="lt1"/>
-          </a:fontRef>
-        </p:style>
-        <p:txBody>
-          <a:bodyPr rtlCol="0" anchor="ctr"/>
-          <a:lstStyle/>
-          <a:p>
-            <a:pPr algn="ctr"/>
-          </a:p>
-        </p:txBody>
-      </p:sp>
-      <p:sp>
-        <p:nvSpPr>
-          <p:cNvPr id="3" name="Oval 2"/>
-          <p:cNvSpPr/>
-          <p:nvPr/>
-        </p:nvSpPr>
-        <p:spPr>
-          <a:xfrm>
-            <a:off x="8595360" y="-1280160"/>
-            <a:ext cx="4206240" cy="4206240"/>
-          </a:xfrm>
-          <a:prstGeom prst="ellipse">
-            <a:avLst/>
-          </a:prstGeom>
-          <a:solidFill>
-            <a:srgbClr val="5A8CFF">
-              <a:alpha val="28000"/>
-            </a:srgbClr>
-          </a:solidFill>
-          <a:ln>
-            <a:noFill/>
-          </a:ln>
-        </p:spPr>
-        <p:style>
-          <a:lnRef idx="1">
-            <a:schemeClr val="accent1"/>
-          </a:lnRef>
-          <a:fillRef idx="3">
-            <a:schemeClr val="accent1"/>
-          </a:fillRef>
-          <a:effectRef idx="2">
-            <a:schemeClr val="accent1"/>
-          </a:effectRef>
-          <a:fontRef idx="minor">
-            <a:schemeClr val="lt1"/>
-          </a:fontRef>
-        </p:style>
-        <p:txBody>
-          <a:bodyPr rtlCol="0" anchor="ctr"/>
-          <a:lstStyle/>
-          <a:p>
-            <a:pPr algn="ctr"/>
-          </a:p>
-        </p:txBody>
-      </p:sp>
-      <p:sp>
-        <p:nvSpPr>
-          <p:cNvPr id="4" name="Oval 3"/>
-          <p:cNvSpPr/>
-          <p:nvPr/>
-        </p:nvSpPr>
-        <p:spPr>
-          <a:xfrm>
-            <a:off x="7863840" y="4389120"/>
-            <a:ext cx="3840480" cy="3840480"/>
-          </a:xfrm>
-          <a:prstGeom prst="ellipse">
-            <a:avLst/>
-          </a:prstGeom>
-          <a:solidFill>
-            <a:srgbClr val="50DCB4">
-              <a:alpha val="16000"/>
-            </a:srgbClr>
-          </a:solidFill>
-          <a:ln>
-            <a:noFill/>
-          </a:ln>
-        </p:spPr>
-        <p:style>
-          <a:lnRef idx="1">
-            <a:schemeClr val="accent1"/>
-          </a:lnRef>
-          <a:fillRef idx="3">
-            <a:schemeClr val="accent1"/>
-          </a:fillRef>
-          <a:effectRef idx="2">
-            <a:schemeClr val="accent1"/>
-          </a:effectRef>
-          <a:fontRef idx="minor">
-            <a:schemeClr val="lt1"/>
-          </a:fontRef>
-        </p:style>
-        <p:txBody>
-          <a:bodyPr rtlCol="0" anchor="ctr"/>
-          <a:lstStyle/>
-          <a:p>
-            <a:pPr algn="ctr"/>
-          </a:p>
-        </p:txBody>
-      </p:sp>
-      <p:sp>
-        <p:nvSpPr>
-          <p:cNvPr id="5" name="TextBox 4"/>
+              <a:t>Ideate your agent</a:t>
+            </a:r>
+          </a:p>
+        </p:txBody>
+      </p:sp>
+      <p:sp>
+        <p:nvSpPr>
+          <p:cNvPr id="8" name="TextBox 7"/>
           <p:cNvSpPr txBox="1"/>
           <p:nvPr/>
         </p:nvSpPr>
         <p:spPr>
           <a:xfrm>
-            <a:off x="685800" y="502920"/>
-            <a:ext cx="10058400" cy="320040"/>
+            <a:off x="731520" y="5029200"/>
+            <a:ext cx="7315200" cy="365760"/>
           </a:xfrm>
           <a:prstGeom prst="rect">
             <a:avLst/>
@@ -3523,79 +3358,13 @@
           <a:p>
             <a:pPr algn="l"/>
             <a:r>
-              <a:rPr sz="1400" b="1">
-                <a:solidFill>
-                  <a:srgbClr val="FFB4BC"/>
+              <a:rPr sz="1800" b="0">
+                <a:solidFill>
+                  <a:srgbClr val="5C5870"/>
                 </a:solidFill>
                 <a:latin typeface="Calibri"/>
               </a:rPr>
-              <a:t>WEALTH SYMPOSIUM</a:t>
-            </a:r>
-          </a:p>
-        </p:txBody>
-      </p:sp>
-      <p:sp>
-        <p:nvSpPr>
-          <p:cNvPr id="6" name="TextBox 5"/>
-          <p:cNvSpPr txBox="1"/>
-          <p:nvPr/>
-        </p:nvSpPr>
-        <p:spPr>
-          <a:xfrm>
-            <a:off x="685800" y="1920240"/>
-            <a:ext cx="10789920" cy="1920240"/>
-          </a:xfrm>
-          <a:prstGeom prst="rect">
-            <a:avLst/>
-          </a:prstGeom>
-          <a:noFill/>
-        </p:spPr>
-        <p:txBody>
-          <a:bodyPr wrap="square"/>
-          <a:lstStyle/>
-          <a:p>
-            <a:pPr algn="l"/>
-            <a:r>
-              <a:rPr sz="6400" b="1">
-                <a:solidFill>
-                  <a:srgbClr val="F4F7FB"/>
-                </a:solidFill>
-                <a:latin typeface="Calibri"/>
-              </a:rPr>
-              <a:t>Start now.</a:t>
-            </a:r>
-          </a:p>
-        </p:txBody>
-      </p:sp>
-      <p:sp>
-        <p:nvSpPr>
-          <p:cNvPr id="7" name="TextBox 6"/>
-          <p:cNvSpPr txBox="1"/>
-          <p:nvPr/>
-        </p:nvSpPr>
-        <p:spPr>
-          <a:xfrm>
-            <a:off x="685800" y="3840480"/>
-            <a:ext cx="9692640" cy="1463040"/>
-          </a:xfrm>
-          <a:prstGeom prst="rect">
-            <a:avLst/>
-          </a:prstGeom>
-          <a:noFill/>
-        </p:spPr>
-        <p:txBody>
-          <a:bodyPr wrap="square"/>
-          <a:lstStyle/>
-          <a:p>
-            <a:pPr algn="l"/>
-            <a:r>
-              <a:rPr sz="2400" b="0">
-                <a:solidFill>
-                  <a:srgbClr val="B7C0D0"/>
-                </a:solidFill>
-                <a:latin typeface="Calibri"/>
-              </a:rPr>
-              <a:t>One leader. One laptop. The clock starts when you leave the cover.</a:t>
+              <a:t>We demo one round. Then every group does it.</a:t>
             </a:r>
           </a:p>
         </p:txBody>
@@ -3614,7 +3383,7 @@
     <p:bg>
       <p:bgPr>
         <a:solidFill>
-          <a:srgbClr val="070B14"/>
+          <a:srgbClr val="F6F3FC"/>
         </a:solidFill>
         <a:effectLst/>
       </p:bgPr>
@@ -3634,15 +3403,15 @@
         </p:nvSpPr>
         <p:spPr>
           <a:xfrm>
-            <a:off x="-1097280" y="-1463040"/>
-            <a:ext cx="4754880" cy="4754880"/>
+            <a:off x="-1280160" y="-1645920"/>
+            <a:ext cx="5669280" cy="5669280"/>
           </a:xfrm>
           <a:prstGeom prst="ellipse">
             <a:avLst/>
           </a:prstGeom>
           <a:solidFill>
-            <a:srgbClr val="DB0011">
-              <a:alpha val="38000"/>
+            <a:srgbClr val="D9C6FF">
+              <a:alpha val="70000"/>
             </a:srgbClr>
           </a:solidFill>
           <a:ln>
@@ -3679,15 +3448,15 @@
         </p:nvSpPr>
         <p:spPr>
           <a:xfrm>
-            <a:off x="8595360" y="-1280160"/>
-            <a:ext cx="4206240" cy="4206240"/>
+            <a:off x="7498079" y="-1828800"/>
+            <a:ext cx="5852160" cy="5852160"/>
           </a:xfrm>
           <a:prstGeom prst="ellipse">
             <a:avLst/>
           </a:prstGeom>
           <a:solidFill>
-            <a:srgbClr val="5A8CFF">
-              <a:alpha val="28000"/>
+            <a:srgbClr val="F6C9E8">
+              <a:alpha val="75000"/>
             </a:srgbClr>
           </a:solidFill>
           <a:ln>
@@ -3724,15 +3493,15 @@
         </p:nvSpPr>
         <p:spPr>
           <a:xfrm>
-            <a:off x="7863840" y="4389120"/>
-            <a:ext cx="3840480" cy="3840480"/>
+            <a:off x="3840480" y="4206240"/>
+            <a:ext cx="4937760" cy="4937760"/>
           </a:xfrm>
           <a:prstGeom prst="ellipse">
             <a:avLst/>
           </a:prstGeom>
           <a:solidFill>
-            <a:srgbClr val="50DCB4">
-              <a:alpha val="16000"/>
+            <a:srgbClr val="C9D8FF">
+              <a:alpha val="55000"/>
             </a:srgbClr>
           </a:solidFill>
           <a:ln>
@@ -3769,8 +3538,8 @@
         </p:nvSpPr>
         <p:spPr>
           <a:xfrm>
-            <a:off x="685800" y="502920"/>
-            <a:ext cx="10058400" cy="320040"/>
+            <a:off x="502920" y="256032"/>
+            <a:ext cx="5486400" cy="256032"/>
           </a:xfrm>
           <a:prstGeom prst="rect">
             <a:avLst/>
@@ -3783,13 +3552,13 @@
           <a:p>
             <a:pPr algn="l"/>
             <a:r>
-              <a:rPr sz="1400" b="1">
-                <a:solidFill>
-                  <a:srgbClr val="FFB4BC"/>
+              <a:rPr sz="1300" b="1">
+                <a:solidFill>
+                  <a:srgbClr val="6B4EFF"/>
                 </a:solidFill>
                 <a:latin typeface="Calibri"/>
               </a:rPr>
-              <a:t>BEFORE YOU START</a:t>
+              <a:t>THE ACTIVITY</a:t>
             </a:r>
           </a:p>
         </p:txBody>
@@ -3802,8 +3571,8 @@
         </p:nvSpPr>
         <p:spPr>
           <a:xfrm>
-            <a:off x="685800" y="1051560"/>
-            <a:ext cx="10789920" cy="1920240"/>
+            <a:off x="457200" y="502920"/>
+            <a:ext cx="10972800" cy="502920"/>
           </a:xfrm>
           <a:prstGeom prst="rect">
             <a:avLst/>
@@ -3816,27 +3585,74 @@
           <a:p>
             <a:pPr algn="l"/>
             <a:r>
-              <a:rPr sz="4800" b="1">
-                <a:solidFill>
-                  <a:srgbClr val="F4F7FB"/>
+              <a:rPr sz="3000" b="1">
+                <a:solidFill>
+                  <a:srgbClr val="1E1B2E"/>
                 </a:solidFill>
                 <a:latin typeface="Calibri"/>
               </a:rPr>
-              <a:t>Nominate a group leader.</a:t>
-            </a:r>
-          </a:p>
-        </p:txBody>
-      </p:sp>
-      <p:sp>
-        <p:nvSpPr>
-          <p:cNvPr id="7" name="TextBox 6"/>
+              <a:t>Thirty minutes. One laptop. Then you present.</a:t>
+            </a:r>
+          </a:p>
+        </p:txBody>
+      </p:sp>
+      <p:sp>
+        <p:nvSpPr>
+          <p:cNvPr id="7" name="Rounded Rectangle 6"/>
+          <p:cNvSpPr/>
+          <p:nvPr/>
+        </p:nvSpPr>
+        <p:spPr>
+          <a:xfrm>
+            <a:off x="411480" y="1325880"/>
+            <a:ext cx="2761488" cy="3246120"/>
+          </a:xfrm>
+          <a:prstGeom prst="roundRect">
+            <a:avLst>
+              <a:gd name="adj" fmla="val 8000"/>
+            </a:avLst>
+          </a:prstGeom>
+          <a:solidFill>
+            <a:srgbClr val="FFFFFF">
+              <a:alpha val="92000"/>
+            </a:srgbClr>
+          </a:solidFill>
+          <a:ln>
+            <a:noFill/>
+          </a:ln>
+        </p:spPr>
+        <p:style>
+          <a:lnRef idx="1">
+            <a:schemeClr val="accent1"/>
+          </a:lnRef>
+          <a:fillRef idx="3">
+            <a:schemeClr val="accent1"/>
+          </a:fillRef>
+          <a:effectRef idx="2">
+            <a:schemeClr val="accent1"/>
+          </a:effectRef>
+          <a:fontRef idx="minor">
+            <a:schemeClr val="lt1"/>
+          </a:fontRef>
+        </p:style>
+        <p:txBody>
+          <a:bodyPr rtlCol="0" anchor="ctr"/>
+          <a:lstStyle/>
+          <a:p>
+            <a:pPr algn="ctr"/>
+          </a:p>
+        </p:txBody>
+      </p:sp>
+      <p:sp>
+        <p:nvSpPr>
+          <p:cNvPr id="8" name="TextBox 7"/>
           <p:cNvSpPr txBox="1"/>
           <p:nvPr/>
         </p:nvSpPr>
         <p:spPr>
           <a:xfrm>
-            <a:off x="685800" y="3017520"/>
-            <a:ext cx="9692640" cy="1463040"/>
+            <a:off x="612648" y="1508760"/>
+            <a:ext cx="2377440" cy="292608"/>
           </a:xfrm>
           <a:prstGeom prst="rect">
             <a:avLst/>
@@ -3849,14 +3665,664 @@
           <a:p>
             <a:pPr algn="l"/>
             <a:r>
-              <a:rPr sz="2400" b="0">
-                <a:solidFill>
-                  <a:srgbClr val="B7C0D0"/>
+              <a:rPr sz="1400" b="1">
+                <a:solidFill>
+                  <a:srgbClr val="6B4EFF"/>
                 </a:solidFill>
                 <a:latin typeface="Calibri"/>
               </a:rPr>
-              <a:t>They drive the laptop. Everyone else talks.
-At the end, the group presents.</a:t>
+              <a:t>5 min</a:t>
+            </a:r>
+          </a:p>
+        </p:txBody>
+      </p:sp>
+      <p:sp>
+        <p:nvSpPr>
+          <p:cNvPr id="9" name="TextBox 8"/>
+          <p:cNvSpPr txBox="1"/>
+          <p:nvPr/>
+        </p:nvSpPr>
+        <p:spPr>
+          <a:xfrm>
+            <a:off x="612648" y="1920240"/>
+            <a:ext cx="2377440" cy="822960"/>
+          </a:xfrm>
+          <a:prstGeom prst="rect">
+            <a:avLst/>
+          </a:prstGeom>
+          <a:noFill/>
+        </p:spPr>
+        <p:txBody>
+          <a:bodyPr wrap="square"/>
+          <a:lstStyle/>
+          <a:p>
+            <a:pPr algn="l"/>
+            <a:r>
+              <a:rPr sz="2800" b="1">
+                <a:solidFill>
+                  <a:srgbClr val="1E1B2E"/>
+                </a:solidFill>
+                <a:latin typeface="Calibri"/>
+              </a:rPr>
+              <a:t>Painpoint</a:t>
+            </a:r>
+          </a:p>
+        </p:txBody>
+      </p:sp>
+      <p:sp>
+        <p:nvSpPr>
+          <p:cNvPr id="10" name="TextBox 9"/>
+          <p:cNvSpPr txBox="1"/>
+          <p:nvPr/>
+        </p:nvSpPr>
+        <p:spPr>
+          <a:xfrm>
+            <a:off x="612648" y="2926080"/>
+            <a:ext cx="2377440" cy="1280160"/>
+          </a:xfrm>
+          <a:prstGeom prst="rect">
+            <a:avLst/>
+          </a:prstGeom>
+          <a:noFill/>
+        </p:spPr>
+        <p:txBody>
+          <a:bodyPr wrap="square"/>
+          <a:lstStyle/>
+          <a:p>
+            <a:pPr algn="l"/>
+            <a:r>
+              <a:rPr sz="1600" b="0">
+                <a:solidFill>
+                  <a:srgbClr val="5C5870"/>
+                </a:solidFill>
+                <a:latin typeface="Calibri"/>
+              </a:rPr>
+              <a:t>Pick the one that hurts most, or write your own.</a:t>
+            </a:r>
+          </a:p>
+        </p:txBody>
+      </p:sp>
+      <p:sp>
+        <p:nvSpPr>
+          <p:cNvPr id="11" name="Rounded Rectangle 10"/>
+          <p:cNvSpPr/>
+          <p:nvPr/>
+        </p:nvSpPr>
+        <p:spPr>
+          <a:xfrm>
+            <a:off x="3337560" y="1325880"/>
+            <a:ext cx="2761488" cy="3246120"/>
+          </a:xfrm>
+          <a:prstGeom prst="roundRect">
+            <a:avLst>
+              <a:gd name="adj" fmla="val 8000"/>
+            </a:avLst>
+          </a:prstGeom>
+          <a:solidFill>
+            <a:srgbClr val="FFFFFF">
+              <a:alpha val="92000"/>
+            </a:srgbClr>
+          </a:solidFill>
+          <a:ln>
+            <a:noFill/>
+          </a:ln>
+        </p:spPr>
+        <p:style>
+          <a:lnRef idx="1">
+            <a:schemeClr val="accent1"/>
+          </a:lnRef>
+          <a:fillRef idx="3">
+            <a:schemeClr val="accent1"/>
+          </a:fillRef>
+          <a:effectRef idx="2">
+            <a:schemeClr val="accent1"/>
+          </a:effectRef>
+          <a:fontRef idx="minor">
+            <a:schemeClr val="lt1"/>
+          </a:fontRef>
+        </p:style>
+        <p:txBody>
+          <a:bodyPr rtlCol="0" anchor="ctr"/>
+          <a:lstStyle/>
+          <a:p>
+            <a:pPr algn="ctr"/>
+          </a:p>
+        </p:txBody>
+      </p:sp>
+      <p:sp>
+        <p:nvSpPr>
+          <p:cNvPr id="12" name="TextBox 11"/>
+          <p:cNvSpPr txBox="1"/>
+          <p:nvPr/>
+        </p:nvSpPr>
+        <p:spPr>
+          <a:xfrm>
+            <a:off x="3538728" y="1508760"/>
+            <a:ext cx="2377440" cy="292608"/>
+          </a:xfrm>
+          <a:prstGeom prst="rect">
+            <a:avLst/>
+          </a:prstGeom>
+          <a:noFill/>
+        </p:spPr>
+        <p:txBody>
+          <a:bodyPr wrap="square"/>
+          <a:lstStyle/>
+          <a:p>
+            <a:pPr algn="l"/>
+            <a:r>
+              <a:rPr sz="1400" b="1">
+                <a:solidFill>
+                  <a:srgbClr val="6B4EFF"/>
+                </a:solidFill>
+                <a:latin typeface="Calibri"/>
+              </a:rPr>
+              <a:t>5 min</a:t>
+            </a:r>
+          </a:p>
+        </p:txBody>
+      </p:sp>
+      <p:sp>
+        <p:nvSpPr>
+          <p:cNvPr id="13" name="TextBox 12"/>
+          <p:cNvSpPr txBox="1"/>
+          <p:nvPr/>
+        </p:nvSpPr>
+        <p:spPr>
+          <a:xfrm>
+            <a:off x="3538728" y="1920240"/>
+            <a:ext cx="2377440" cy="822960"/>
+          </a:xfrm>
+          <a:prstGeom prst="rect">
+            <a:avLst/>
+          </a:prstGeom>
+          <a:noFill/>
+        </p:spPr>
+        <p:txBody>
+          <a:bodyPr wrap="square"/>
+          <a:lstStyle/>
+          <a:p>
+            <a:pPr algn="l"/>
+            <a:r>
+              <a:rPr sz="2800" b="1">
+                <a:solidFill>
+                  <a:srgbClr val="1E1B2E"/>
+                </a:solidFill>
+                <a:latin typeface="Calibri"/>
+              </a:rPr>
+              <a:t>Idea brief</a:t>
+            </a:r>
+          </a:p>
+        </p:txBody>
+      </p:sp>
+      <p:sp>
+        <p:nvSpPr>
+          <p:cNvPr id="14" name="TextBox 13"/>
+          <p:cNvSpPr txBox="1"/>
+          <p:nvPr/>
+        </p:nvSpPr>
+        <p:spPr>
+          <a:xfrm>
+            <a:off x="3538728" y="2926080"/>
+            <a:ext cx="2377440" cy="1280160"/>
+          </a:xfrm>
+          <a:prstGeom prst="rect">
+            <a:avLst/>
+          </a:prstGeom>
+          <a:noFill/>
+        </p:spPr>
+        <p:txBody>
+          <a:bodyPr wrap="square"/>
+          <a:lstStyle/>
+          <a:p>
+            <a:pPr algn="l"/>
+            <a:r>
+              <a:rPr sz="1600" b="0">
+                <a:solidFill>
+                  <a:srgbClr val="5C5870"/>
+                </a:solidFill>
+                <a:latin typeface="Calibri"/>
+              </a:rPr>
+              <a:t>Name it. What it does. What you receive. The benefit.</a:t>
+            </a:r>
+          </a:p>
+        </p:txBody>
+      </p:sp>
+      <p:sp>
+        <p:nvSpPr>
+          <p:cNvPr id="15" name="Rounded Rectangle 14"/>
+          <p:cNvSpPr/>
+          <p:nvPr/>
+        </p:nvSpPr>
+        <p:spPr>
+          <a:xfrm>
+            <a:off x="6263640" y="1325880"/>
+            <a:ext cx="2761488" cy="3246120"/>
+          </a:xfrm>
+          <a:prstGeom prst="roundRect">
+            <a:avLst>
+              <a:gd name="adj" fmla="val 8000"/>
+            </a:avLst>
+          </a:prstGeom>
+          <a:solidFill>
+            <a:srgbClr val="FFFFFF">
+              <a:alpha val="92000"/>
+            </a:srgbClr>
+          </a:solidFill>
+          <a:ln>
+            <a:noFill/>
+          </a:ln>
+        </p:spPr>
+        <p:style>
+          <a:lnRef idx="1">
+            <a:schemeClr val="accent1"/>
+          </a:lnRef>
+          <a:fillRef idx="3">
+            <a:schemeClr val="accent1"/>
+          </a:fillRef>
+          <a:effectRef idx="2">
+            <a:schemeClr val="accent1"/>
+          </a:effectRef>
+          <a:fontRef idx="minor">
+            <a:schemeClr val="lt1"/>
+          </a:fontRef>
+        </p:style>
+        <p:txBody>
+          <a:bodyPr rtlCol="0" anchor="ctr"/>
+          <a:lstStyle/>
+          <a:p>
+            <a:pPr algn="ctr"/>
+          </a:p>
+        </p:txBody>
+      </p:sp>
+      <p:sp>
+        <p:nvSpPr>
+          <p:cNvPr id="16" name="TextBox 15"/>
+          <p:cNvSpPr txBox="1"/>
+          <p:nvPr/>
+        </p:nvSpPr>
+        <p:spPr>
+          <a:xfrm>
+            <a:off x="6464808" y="1508760"/>
+            <a:ext cx="2377440" cy="292608"/>
+          </a:xfrm>
+          <a:prstGeom prst="rect">
+            <a:avLst/>
+          </a:prstGeom>
+          <a:noFill/>
+        </p:spPr>
+        <p:txBody>
+          <a:bodyPr wrap="square"/>
+          <a:lstStyle/>
+          <a:p>
+            <a:pPr algn="l"/>
+            <a:r>
+              <a:rPr sz="1400" b="1">
+                <a:solidFill>
+                  <a:srgbClr val="6B4EFF"/>
+                </a:solidFill>
+                <a:latin typeface="Calibri"/>
+              </a:rPr>
+              <a:t>10 min</a:t>
+            </a:r>
+          </a:p>
+        </p:txBody>
+      </p:sp>
+      <p:sp>
+        <p:nvSpPr>
+          <p:cNvPr id="17" name="TextBox 16"/>
+          <p:cNvSpPr txBox="1"/>
+          <p:nvPr/>
+        </p:nvSpPr>
+        <p:spPr>
+          <a:xfrm>
+            <a:off x="6464808" y="1920240"/>
+            <a:ext cx="2377440" cy="822960"/>
+          </a:xfrm>
+          <a:prstGeom prst="rect">
+            <a:avLst/>
+          </a:prstGeom>
+          <a:noFill/>
+        </p:spPr>
+        <p:txBody>
+          <a:bodyPr wrap="square"/>
+          <a:lstStyle/>
+          <a:p>
+            <a:pPr algn="l"/>
+            <a:r>
+              <a:rPr sz="2800" b="1">
+                <a:solidFill>
+                  <a:srgbClr val="1E1B2E"/>
+                </a:solidFill>
+                <a:latin typeface="Calibri"/>
+              </a:rPr>
+              <a:t>3 screens</a:t>
+            </a:r>
+          </a:p>
+        </p:txBody>
+      </p:sp>
+      <p:sp>
+        <p:nvSpPr>
+          <p:cNvPr id="18" name="TextBox 17"/>
+          <p:cNvSpPr txBox="1"/>
+          <p:nvPr/>
+        </p:nvSpPr>
+        <p:spPr>
+          <a:xfrm>
+            <a:off x="6464808" y="2926080"/>
+            <a:ext cx="2377440" cy="1280160"/>
+          </a:xfrm>
+          <a:prstGeom prst="rect">
+            <a:avLst/>
+          </a:prstGeom>
+          <a:noFill/>
+        </p:spPr>
+        <p:txBody>
+          <a:bodyPr wrap="square"/>
+          <a:lstStyle/>
+          <a:p>
+            <a:pPr algn="l"/>
+            <a:r>
+              <a:rPr sz="1600" b="0">
+                <a:solidFill>
+                  <a:srgbClr val="5C5870"/>
+                </a:solidFill>
+                <a:latin typeface="Calibri"/>
+              </a:rPr>
+              <a:t>Write each step, then generate the screen.</a:t>
+            </a:r>
+          </a:p>
+        </p:txBody>
+      </p:sp>
+      <p:sp>
+        <p:nvSpPr>
+          <p:cNvPr id="19" name="Rounded Rectangle 18"/>
+          <p:cNvSpPr/>
+          <p:nvPr/>
+        </p:nvSpPr>
+        <p:spPr>
+          <a:xfrm>
+            <a:off x="9189720" y="1325880"/>
+            <a:ext cx="2761488" cy="3246120"/>
+          </a:xfrm>
+          <a:prstGeom prst="roundRect">
+            <a:avLst>
+              <a:gd name="adj" fmla="val 8000"/>
+            </a:avLst>
+          </a:prstGeom>
+          <a:solidFill>
+            <a:srgbClr val="FFFFFF">
+              <a:alpha val="92000"/>
+            </a:srgbClr>
+          </a:solidFill>
+          <a:ln>
+            <a:noFill/>
+          </a:ln>
+        </p:spPr>
+        <p:style>
+          <a:lnRef idx="1">
+            <a:schemeClr val="accent1"/>
+          </a:lnRef>
+          <a:fillRef idx="3">
+            <a:schemeClr val="accent1"/>
+          </a:fillRef>
+          <a:effectRef idx="2">
+            <a:schemeClr val="accent1"/>
+          </a:effectRef>
+          <a:fontRef idx="minor">
+            <a:schemeClr val="lt1"/>
+          </a:fontRef>
+        </p:style>
+        <p:txBody>
+          <a:bodyPr rtlCol="0" anchor="ctr"/>
+          <a:lstStyle/>
+          <a:p>
+            <a:pPr algn="ctr"/>
+          </a:p>
+        </p:txBody>
+      </p:sp>
+      <p:sp>
+        <p:nvSpPr>
+          <p:cNvPr id="20" name="TextBox 19"/>
+          <p:cNvSpPr txBox="1"/>
+          <p:nvPr/>
+        </p:nvSpPr>
+        <p:spPr>
+          <a:xfrm>
+            <a:off x="9390888" y="1508760"/>
+            <a:ext cx="2377440" cy="292608"/>
+          </a:xfrm>
+          <a:prstGeom prst="rect">
+            <a:avLst/>
+          </a:prstGeom>
+          <a:noFill/>
+        </p:spPr>
+        <p:txBody>
+          <a:bodyPr wrap="square"/>
+          <a:lstStyle/>
+          <a:p>
+            <a:pPr algn="l"/>
+            <a:r>
+              <a:rPr sz="1400" b="1">
+                <a:solidFill>
+                  <a:srgbClr val="6B4EFF"/>
+                </a:solidFill>
+                <a:latin typeface="Calibri"/>
+              </a:rPr>
+              <a:t>15 min</a:t>
+            </a:r>
+          </a:p>
+        </p:txBody>
+      </p:sp>
+      <p:sp>
+        <p:nvSpPr>
+          <p:cNvPr id="21" name="TextBox 20"/>
+          <p:cNvSpPr txBox="1"/>
+          <p:nvPr/>
+        </p:nvSpPr>
+        <p:spPr>
+          <a:xfrm>
+            <a:off x="9390888" y="1920240"/>
+            <a:ext cx="2377440" cy="822960"/>
+          </a:xfrm>
+          <a:prstGeom prst="rect">
+            <a:avLst/>
+          </a:prstGeom>
+          <a:noFill/>
+        </p:spPr>
+        <p:txBody>
+          <a:bodyPr wrap="square"/>
+          <a:lstStyle/>
+          <a:p>
+            <a:pPr algn="l"/>
+            <a:r>
+              <a:rPr sz="2800" b="1">
+                <a:solidFill>
+                  <a:srgbClr val="1E1B2E"/>
+                </a:solidFill>
+                <a:latin typeface="Calibri"/>
+              </a:rPr>
+              <a:t>Prototype</a:t>
+            </a:r>
+          </a:p>
+        </p:txBody>
+      </p:sp>
+      <p:sp>
+        <p:nvSpPr>
+          <p:cNvPr id="22" name="TextBox 21"/>
+          <p:cNvSpPr txBox="1"/>
+          <p:nvPr/>
+        </p:nvSpPr>
+        <p:spPr>
+          <a:xfrm>
+            <a:off x="9390888" y="2926080"/>
+            <a:ext cx="2377440" cy="1280160"/>
+          </a:xfrm>
+          <a:prstGeom prst="rect">
+            <a:avLst/>
+          </a:prstGeom>
+          <a:noFill/>
+        </p:spPr>
+        <p:txBody>
+          <a:bodyPr wrap="square"/>
+          <a:lstStyle/>
+          <a:p>
+            <a:pPr algn="l"/>
+            <a:r>
+              <a:rPr sz="1600" b="0">
+                <a:solidFill>
+                  <a:srgbClr val="5C5870"/>
+                </a:solidFill>
+                <a:latin typeface="Calibri"/>
+              </a:rPr>
+              <a:t>Make it clickable. One or two edits.</a:t>
+            </a:r>
+          </a:p>
+        </p:txBody>
+      </p:sp>
+      <p:sp>
+        <p:nvSpPr>
+          <p:cNvPr id="23" name="Rounded Rectangle 22"/>
+          <p:cNvSpPr/>
+          <p:nvPr/>
+        </p:nvSpPr>
+        <p:spPr>
+          <a:xfrm>
+            <a:off x="411480" y="4800600"/>
+            <a:ext cx="11338560" cy="1417320"/>
+          </a:xfrm>
+          <a:prstGeom prst="roundRect">
+            <a:avLst>
+              <a:gd name="adj" fmla="val 8000"/>
+            </a:avLst>
+          </a:prstGeom>
+          <a:solidFill>
+            <a:srgbClr val="FFFFFF">
+              <a:alpha val="92000"/>
+            </a:srgbClr>
+          </a:solidFill>
+          <a:ln>
+            <a:noFill/>
+          </a:ln>
+        </p:spPr>
+        <p:style>
+          <a:lnRef idx="1">
+            <a:schemeClr val="accent1"/>
+          </a:lnRef>
+          <a:fillRef idx="3">
+            <a:schemeClr val="accent1"/>
+          </a:fillRef>
+          <a:effectRef idx="2">
+            <a:schemeClr val="accent1"/>
+          </a:effectRef>
+          <a:fontRef idx="minor">
+            <a:schemeClr val="lt1"/>
+          </a:fontRef>
+        </p:style>
+        <p:txBody>
+          <a:bodyPr rtlCol="0" anchor="ctr"/>
+          <a:lstStyle/>
+          <a:p>
+            <a:pPr algn="ctr"/>
+          </a:p>
+        </p:txBody>
+      </p:sp>
+      <p:sp>
+        <p:nvSpPr>
+          <p:cNvPr id="24" name="TextBox 23"/>
+          <p:cNvSpPr txBox="1"/>
+          <p:nvPr/>
+        </p:nvSpPr>
+        <p:spPr>
+          <a:xfrm>
+            <a:off x="640080" y="4956048"/>
+            <a:ext cx="3657600" cy="292608"/>
+          </a:xfrm>
+          <a:prstGeom prst="rect">
+            <a:avLst/>
+          </a:prstGeom>
+          <a:noFill/>
+        </p:spPr>
+        <p:txBody>
+          <a:bodyPr wrap="square"/>
+          <a:lstStyle/>
+          <a:p>
+            <a:pPr algn="l"/>
+            <a:r>
+              <a:rPr sz="1400" b="1">
+                <a:solidFill>
+                  <a:srgbClr val="6B4EFF"/>
+                </a:solidFill>
+                <a:latin typeface="Calibri"/>
+              </a:rPr>
+              <a:t>Before you start</a:t>
+            </a:r>
+          </a:p>
+        </p:txBody>
+      </p:sp>
+      <p:sp>
+        <p:nvSpPr>
+          <p:cNvPr id="25" name="TextBox 24"/>
+          <p:cNvSpPr txBox="1"/>
+          <p:nvPr/>
+        </p:nvSpPr>
+        <p:spPr>
+          <a:xfrm>
+            <a:off x="640080" y="5257800"/>
+            <a:ext cx="6583680" cy="640080"/>
+          </a:xfrm>
+          <a:prstGeom prst="rect">
+            <a:avLst/>
+          </a:prstGeom>
+          <a:noFill/>
+        </p:spPr>
+        <p:txBody>
+          <a:bodyPr wrap="square"/>
+          <a:lstStyle/>
+          <a:p>
+            <a:pPr algn="l"/>
+            <a:r>
+              <a:rPr sz="1800" b="0">
+                <a:solidFill>
+                  <a:srgbClr val="1E1B2E"/>
+                </a:solidFill>
+                <a:latin typeface="Calibri"/>
+              </a:rPr>
+              <a:t>Nominate one leader. They drive the laptop. Everyone else decides.</a:t>
+            </a:r>
+          </a:p>
+        </p:txBody>
+      </p:sp>
+      <p:sp>
+        <p:nvSpPr>
+          <p:cNvPr id="26" name="TextBox 25"/>
+          <p:cNvSpPr txBox="1"/>
+          <p:nvPr/>
+        </p:nvSpPr>
+        <p:spPr>
+          <a:xfrm>
+            <a:off x="7498079" y="5029200"/>
+            <a:ext cx="3931920" cy="868680"/>
+          </a:xfrm>
+          <a:prstGeom prst="rect">
+            <a:avLst/>
+          </a:prstGeom>
+          <a:noFill/>
+        </p:spPr>
+        <p:txBody>
+          <a:bodyPr wrap="square"/>
+          <a:lstStyle/>
+          <a:p>
+            <a:pPr algn="l"/>
+            <a:r>
+              <a:rPr sz="1600" b="0">
+                <a:solidFill>
+                  <a:srgbClr val="5C5870"/>
+                </a:solidFill>
+                <a:latin typeface="Calibri"/>
+              </a:rPr>
+              <a:t>90 seconds to close
+painpoint · idea · prototype · benefit</a:t>
             </a:r>
           </a:p>
         </p:txBody>
@@ -3875,7 +4341,7 @@
     <p:bg>
       <p:bgPr>
         <a:solidFill>
-          <a:srgbClr val="070B14"/>
+          <a:srgbClr val="F6F3FC"/>
         </a:solidFill>
         <a:effectLst/>
       </p:bgPr>
@@ -3895,15 +4361,15 @@
         </p:nvSpPr>
         <p:spPr>
           <a:xfrm>
-            <a:off x="-1097280" y="-1463040"/>
-            <a:ext cx="4754880" cy="4754880"/>
+            <a:off x="-1463040" y="-1280160"/>
+            <a:ext cx="4023360" cy="4023360"/>
           </a:xfrm>
           <a:prstGeom prst="ellipse">
             <a:avLst/>
           </a:prstGeom>
           <a:solidFill>
-            <a:srgbClr val="DB0011">
-              <a:alpha val="38000"/>
+            <a:srgbClr val="E4D8FF">
+              <a:alpha val="80000"/>
             </a:srgbClr>
           </a:solidFill>
           <a:ln>
@@ -3940,15 +4406,15 @@
         </p:nvSpPr>
         <p:spPr>
           <a:xfrm>
-            <a:off x="8595360" y="-1280160"/>
-            <a:ext cx="4206240" cy="4206240"/>
+            <a:off x="9326880" y="4754880"/>
+            <a:ext cx="3291840" cy="3291840"/>
           </a:xfrm>
           <a:prstGeom prst="ellipse">
             <a:avLst/>
           </a:prstGeom>
           <a:solidFill>
-            <a:srgbClr val="5A8CFF">
-              <a:alpha val="28000"/>
+            <a:srgbClr val="F8D8EE">
+              <a:alpha val="80000"/>
             </a:srgbClr>
           </a:solidFill>
           <a:ln>
@@ -3979,21 +4445,122 @@
       </p:sp>
       <p:sp>
         <p:nvSpPr>
-          <p:cNvPr id="4" name="Oval 3"/>
+          <p:cNvPr id="4" name="TextBox 3"/>
+          <p:cNvSpPr txBox="1"/>
+          <p:nvPr/>
+        </p:nvSpPr>
+        <p:spPr>
+          <a:xfrm>
+            <a:off x="502920" y="292608"/>
+            <a:ext cx="7315200" cy="256032"/>
+          </a:xfrm>
+          <a:prstGeom prst="rect">
+            <a:avLst/>
+          </a:prstGeom>
+          <a:noFill/>
+        </p:spPr>
+        <p:txBody>
+          <a:bodyPr wrap="square"/>
+          <a:lstStyle/>
+          <a:p>
+            <a:pPr algn="l"/>
+            <a:r>
+              <a:rPr sz="1200" b="1">
+                <a:solidFill>
+                  <a:srgbClr val="6B4EFF"/>
+                </a:solidFill>
+                <a:latin typeface="Calibri"/>
+              </a:rPr>
+              <a:t>APPENDIX  ·  PRINT FOR THE DESK</a:t>
+            </a:r>
+          </a:p>
+        </p:txBody>
+      </p:sp>
+      <p:sp>
+        <p:nvSpPr>
+          <p:cNvPr id="5" name="TextBox 4"/>
+          <p:cNvSpPr txBox="1"/>
+          <p:nvPr/>
+        </p:nvSpPr>
+        <p:spPr>
+          <a:xfrm>
+            <a:off x="502920" y="621792"/>
+            <a:ext cx="7315200" cy="256032"/>
+          </a:xfrm>
+          <a:prstGeom prst="rect">
+            <a:avLst/>
+          </a:prstGeom>
+          <a:noFill/>
+        </p:spPr>
+        <p:txBody>
+          <a:bodyPr wrap="square"/>
+          <a:lstStyle/>
+          <a:p>
+            <a:pPr algn="l"/>
+            <a:r>
+              <a:rPr sz="1400" b="1">
+                <a:solidFill>
+                  <a:srgbClr val="6B4EFF"/>
+                </a:solidFill>
+                <a:latin typeface="Calibri"/>
+              </a:rPr>
+              <a:t>STEP 0  ·  INSIDE THE FIRST 5 MINUTES</a:t>
+            </a:r>
+          </a:p>
+        </p:txBody>
+      </p:sp>
+      <p:sp>
+        <p:nvSpPr>
+          <p:cNvPr id="6" name="TextBox 5"/>
+          <p:cNvSpPr txBox="1"/>
+          <p:nvPr/>
+        </p:nvSpPr>
+        <p:spPr>
+          <a:xfrm>
+            <a:off x="457200" y="868680"/>
+            <a:ext cx="10972800" cy="548640"/>
+          </a:xfrm>
+          <a:prstGeom prst="rect">
+            <a:avLst/>
+          </a:prstGeom>
+          <a:noFill/>
+        </p:spPr>
+        <p:txBody>
+          <a:bodyPr wrap="square"/>
+          <a:lstStyle/>
+          <a:p>
+            <a:pPr algn="l"/>
+            <a:r>
+              <a:rPr sz="3200" b="1">
+                <a:solidFill>
+                  <a:srgbClr val="1E1B2E"/>
+                </a:solidFill>
+                <a:latin typeface="Calibri"/>
+              </a:rPr>
+              <a:t>Choose the painpoint</a:t>
+            </a:r>
+          </a:p>
+        </p:txBody>
+      </p:sp>
+      <p:sp>
+        <p:nvSpPr>
+          <p:cNvPr id="7" name="Rounded Rectangle 6"/>
           <p:cNvSpPr/>
           <p:nvPr/>
         </p:nvSpPr>
         <p:spPr>
           <a:xfrm>
-            <a:off x="7863840" y="4389120"/>
-            <a:ext cx="3840480" cy="3840480"/>
-          </a:xfrm>
-          <a:prstGeom prst="ellipse">
-            <a:avLst/>
+            <a:off x="457200" y="1737360"/>
+            <a:ext cx="11247120" cy="4480560"/>
+          </a:xfrm>
+          <a:prstGeom prst="roundRect">
+            <a:avLst>
+              <a:gd name="adj" fmla="val 8000"/>
+            </a:avLst>
           </a:prstGeom>
           <a:solidFill>
-            <a:srgbClr val="50DCB4">
-              <a:alpha val="16000"/>
+            <a:srgbClr val="FFFFFF">
+              <a:alpha val="92000"/>
             </a:srgbClr>
           </a:solidFill>
           <a:ln>
@@ -4024,127 +4591,14 @@
       </p:sp>
       <p:sp>
         <p:nvSpPr>
-          <p:cNvPr id="5" name="TextBox 4"/>
-          <p:cNvSpPr txBox="1"/>
-          <p:nvPr/>
-        </p:nvSpPr>
-        <p:spPr>
-          <a:xfrm>
-            <a:off x="685800" y="502920"/>
-            <a:ext cx="10058400" cy="320040"/>
-          </a:xfrm>
-          <a:prstGeom prst="rect">
-            <a:avLst/>
-          </a:prstGeom>
-          <a:noFill/>
-        </p:spPr>
-        <p:txBody>
-          <a:bodyPr wrap="square"/>
-          <a:lstStyle/>
-          <a:p>
-            <a:pPr algn="l"/>
-            <a:r>
-              <a:rPr sz="1400" b="1">
-                <a:solidFill>
-                  <a:srgbClr val="FFB4BC"/>
-                </a:solidFill>
-                <a:latin typeface="Calibri"/>
-              </a:rPr>
-              <a:t>THIRTY MINUTES</a:t>
-            </a:r>
-          </a:p>
-        </p:txBody>
-      </p:sp>
-      <p:sp>
-        <p:nvSpPr>
-          <p:cNvPr id="6" name="TextBox 5"/>
-          <p:cNvSpPr txBox="1"/>
-          <p:nvPr/>
-        </p:nvSpPr>
-        <p:spPr>
-          <a:xfrm>
-            <a:off x="685800" y="868680"/>
-            <a:ext cx="10789920" cy="1920240"/>
-          </a:xfrm>
-          <a:prstGeom prst="rect">
-            <a:avLst/>
-          </a:prstGeom>
-          <a:noFill/>
-        </p:spPr>
-        <p:txBody>
-          <a:bodyPr wrap="square"/>
-          <a:lstStyle/>
-          <a:p>
-            <a:pPr algn="l"/>
-            <a:r>
-              <a:rPr sz="4000" b="1">
-                <a:solidFill>
-                  <a:srgbClr val="F4F7FB"/>
-                </a:solidFill>
-                <a:latin typeface="Calibri"/>
-              </a:rPr>
-              <a:t>Four steps.</a:t>
-            </a:r>
-          </a:p>
-        </p:txBody>
-      </p:sp>
-      <p:sp>
-        <p:nvSpPr>
-          <p:cNvPr id="7" name="Rounded Rectangle 6"/>
-          <p:cNvSpPr/>
-          <p:nvPr/>
-        </p:nvSpPr>
-        <p:spPr>
-          <a:xfrm>
-            <a:off x="685800" y="2148840"/>
-            <a:ext cx="5212080" cy="1691640"/>
-          </a:xfrm>
-          <a:prstGeom prst="roundRect">
-            <a:avLst>
-              <a:gd name="adj" fmla="val 12000"/>
-            </a:avLst>
-          </a:prstGeom>
-          <a:solidFill>
-            <a:srgbClr val="141C2C">
-              <a:alpha val="88000"/>
-            </a:srgbClr>
-          </a:solidFill>
-          <a:ln>
-            <a:noFill/>
-          </a:ln>
-        </p:spPr>
-        <p:style>
-          <a:lnRef idx="1">
-            <a:schemeClr val="accent1"/>
-          </a:lnRef>
-          <a:fillRef idx="3">
-            <a:schemeClr val="accent1"/>
-          </a:fillRef>
-          <a:effectRef idx="2">
-            <a:schemeClr val="accent1"/>
-          </a:effectRef>
-          <a:fontRef idx="minor">
-            <a:schemeClr val="lt1"/>
-          </a:fontRef>
-        </p:style>
-        <p:txBody>
-          <a:bodyPr rtlCol="0" anchor="ctr"/>
-          <a:lstStyle/>
-          <a:p>
-            <a:pPr algn="ctr"/>
-          </a:p>
-        </p:txBody>
-      </p:sp>
-      <p:sp>
-        <p:nvSpPr>
           <p:cNvPr id="8" name="TextBox 7"/>
           <p:cNvSpPr txBox="1"/>
           <p:nvPr/>
         </p:nvSpPr>
         <p:spPr>
           <a:xfrm>
-            <a:off x="941832" y="2295144"/>
-            <a:ext cx="4663440" cy="274320"/>
+            <a:off x="777240" y="2011680"/>
+            <a:ext cx="10607040" cy="3840480"/>
           </a:xfrm>
           <a:prstGeom prst="rect">
             <a:avLst/>
@@ -4152,522 +4606,88 @@
           <a:noFill/>
         </p:spPr>
         <p:txBody>
-          <a:bodyPr wrap="square"/>
-          <a:lstStyle/>
-          <a:p>
-            <a:pPr algn="l"/>
-            <a:r>
-              <a:rPr sz="1300" b="1">
-                <a:solidFill>
-                  <a:srgbClr val="FFB4BC"/>
+          <a:bodyPr wrap="square">
+            <a:spAutoFit/>
+          </a:bodyPr>
+          <a:lstStyle/>
+          <a:p>
+            <a:pPr>
+              <a:spcAft>
+                <a:spcPts val="1600"/>
+              </a:spcAft>
+            </a:pPr>
+            <a:r>
+              <a:rPr sz="2400">
+                <a:solidFill>
+                  <a:srgbClr val="1E1B2E"/>
                 </a:solidFill>
                 <a:latin typeface="Calibri"/>
               </a:rPr>
-              <a:t>5 MIN</a:t>
-            </a:r>
-          </a:p>
-        </p:txBody>
-      </p:sp>
-      <p:sp>
-        <p:nvSpPr>
-          <p:cNvPr id="9" name="TextBox 8"/>
-          <p:cNvSpPr txBox="1"/>
-          <p:nvPr/>
-        </p:nvSpPr>
-        <p:spPr>
-          <a:xfrm>
-            <a:off x="941832" y="2569464"/>
-            <a:ext cx="4663440" cy="420624"/>
-          </a:xfrm>
-          <a:prstGeom prst="rect">
-            <a:avLst/>
-          </a:prstGeom>
-          <a:noFill/>
-        </p:spPr>
-        <p:txBody>
-          <a:bodyPr wrap="square"/>
-          <a:lstStyle/>
-          <a:p>
-            <a:pPr algn="l"/>
-            <a:r>
-              <a:rPr sz="2400" b="1">
-                <a:solidFill>
-                  <a:srgbClr val="F4F7FB"/>
+              <a:t>1.  Nominate the person who will use the laptop. The others talk.</a:t>
+            </a:r>
+          </a:p>
+          <a:p>
+            <a:pPr>
+              <a:spcAft>
+                <a:spcPts val="1600"/>
+              </a:spcAft>
+            </a:pPr>
+            <a:r>
+              <a:rPr sz="2400">
+                <a:solidFill>
+                  <a:srgbClr val="1E1B2E"/>
                 </a:solidFill>
                 <a:latin typeface="Calibri"/>
               </a:rPr>
-              <a:t>0  Painpoint</a:t>
-            </a:r>
-          </a:p>
-        </p:txBody>
-      </p:sp>
-      <p:sp>
-        <p:nvSpPr>
-          <p:cNvPr id="10" name="TextBox 9"/>
-          <p:cNvSpPr txBox="1"/>
-          <p:nvPr/>
-        </p:nvSpPr>
-        <p:spPr>
-          <a:xfrm>
-            <a:off x="941832" y="3044952"/>
-            <a:ext cx="4663440" cy="640080"/>
-          </a:xfrm>
-          <a:prstGeom prst="rect">
-            <a:avLst/>
-          </a:prstGeom>
-          <a:noFill/>
-        </p:spPr>
-        <p:txBody>
-          <a:bodyPr wrap="square"/>
-          <a:lstStyle/>
-          <a:p>
-            <a:pPr algn="l"/>
-            <a:r>
-              <a:rPr sz="1600" b="0">
-                <a:solidFill>
-                  <a:srgbClr val="B7C0D0"/>
+              <a:t>2.  Read the nine cards. Pick the one the group feels most strongly.</a:t>
+            </a:r>
+          </a:p>
+          <a:p>
+            <a:pPr>
+              <a:spcAft>
+                <a:spcPts val="1600"/>
+              </a:spcAft>
+            </a:pPr>
+            <a:r>
+              <a:rPr sz="2400">
+                <a:solidFill>
+                  <a:srgbClr val="1E1B2E"/>
                 </a:solidFill>
                 <a:latin typeface="Calibri"/>
               </a:rPr>
-              <a:t>Pick the one that hurts most, or write your own.</a:t>
-            </a:r>
-          </a:p>
-        </p:txBody>
-      </p:sp>
-      <p:sp>
-        <p:nvSpPr>
-          <p:cNvPr id="11" name="Rounded Rectangle 10"/>
-          <p:cNvSpPr/>
-          <p:nvPr/>
-        </p:nvSpPr>
-        <p:spPr>
-          <a:xfrm>
-            <a:off x="6263640" y="2148840"/>
-            <a:ext cx="5212080" cy="1691640"/>
-          </a:xfrm>
-          <a:prstGeom prst="roundRect">
-            <a:avLst>
-              <a:gd name="adj" fmla="val 12000"/>
-            </a:avLst>
-          </a:prstGeom>
-          <a:solidFill>
-            <a:srgbClr val="141C2C">
-              <a:alpha val="88000"/>
-            </a:srgbClr>
-          </a:solidFill>
-          <a:ln>
-            <a:noFill/>
-          </a:ln>
-        </p:spPr>
-        <p:style>
-          <a:lnRef idx="1">
-            <a:schemeClr val="accent1"/>
-          </a:lnRef>
-          <a:fillRef idx="3">
-            <a:schemeClr val="accent1"/>
-          </a:fillRef>
-          <a:effectRef idx="2">
-            <a:schemeClr val="accent1"/>
-          </a:effectRef>
-          <a:fontRef idx="minor">
-            <a:schemeClr val="lt1"/>
-          </a:fontRef>
-        </p:style>
-        <p:txBody>
-          <a:bodyPr rtlCol="0" anchor="ctr"/>
-          <a:lstStyle/>
-          <a:p>
-            <a:pPr algn="ctr"/>
-          </a:p>
-        </p:txBody>
-      </p:sp>
-      <p:sp>
-        <p:nvSpPr>
-          <p:cNvPr id="12" name="TextBox 11"/>
-          <p:cNvSpPr txBox="1"/>
-          <p:nvPr/>
-        </p:nvSpPr>
-        <p:spPr>
-          <a:xfrm>
-            <a:off x="6519672" y="2295144"/>
-            <a:ext cx="4663440" cy="274320"/>
-          </a:xfrm>
-          <a:prstGeom prst="rect">
-            <a:avLst/>
-          </a:prstGeom>
-          <a:noFill/>
-        </p:spPr>
-        <p:txBody>
-          <a:bodyPr wrap="square"/>
-          <a:lstStyle/>
-          <a:p>
-            <a:pPr algn="l"/>
-            <a:r>
-              <a:rPr sz="1300" b="1">
-                <a:solidFill>
-                  <a:srgbClr val="FFB4BC"/>
+              <a:t>3.  Do not pick the one that merely sounds impressive.</a:t>
+            </a:r>
+          </a:p>
+          <a:p>
+            <a:pPr>
+              <a:spcAft>
+                <a:spcPts val="1600"/>
+              </a:spcAft>
+            </a:pPr>
+            <a:r>
+              <a:rPr sz="2400">
+                <a:solidFill>
+                  <a:srgbClr val="1E1B2E"/>
                 </a:solidFill>
                 <a:latin typeface="Calibri"/>
               </a:rPr>
-              <a:t>WITH THE 5 MIN</a:t>
-            </a:r>
-          </a:p>
-        </p:txBody>
-      </p:sp>
-      <p:sp>
-        <p:nvSpPr>
-          <p:cNvPr id="13" name="TextBox 12"/>
-          <p:cNvSpPr txBox="1"/>
-          <p:nvPr/>
-        </p:nvSpPr>
-        <p:spPr>
-          <a:xfrm>
-            <a:off x="6519672" y="2569464"/>
-            <a:ext cx="4663440" cy="420624"/>
-          </a:xfrm>
-          <a:prstGeom prst="rect">
-            <a:avLst/>
-          </a:prstGeom>
-          <a:noFill/>
-        </p:spPr>
-        <p:txBody>
-          <a:bodyPr wrap="square"/>
-          <a:lstStyle/>
-          <a:p>
-            <a:pPr algn="l"/>
-            <a:r>
-              <a:rPr sz="2400" b="1">
-                <a:solidFill>
-                  <a:srgbClr val="F4F7FB"/>
+              <a:t>4.  If none of them is yours, write your own in the long box at the bottom.</a:t>
+            </a:r>
+          </a:p>
+          <a:p>
+            <a:pPr>
+              <a:spcAft>
+                <a:spcPts val="1600"/>
+              </a:spcAft>
+            </a:pPr>
+            <a:r>
+              <a:rPr sz="2400">
+                <a:solidFill>
+                  <a:srgbClr val="1E1B2E"/>
                 </a:solidFill>
                 <a:latin typeface="Calibri"/>
               </a:rPr>
-              <a:t>1  Idea brief</a:t>
-            </a:r>
-          </a:p>
-        </p:txBody>
-      </p:sp>
-      <p:sp>
-        <p:nvSpPr>
-          <p:cNvPr id="14" name="TextBox 13"/>
-          <p:cNvSpPr txBox="1"/>
-          <p:nvPr/>
-        </p:nvSpPr>
-        <p:spPr>
-          <a:xfrm>
-            <a:off x="6519672" y="3044952"/>
-            <a:ext cx="4663440" cy="640080"/>
-          </a:xfrm>
-          <a:prstGeom prst="rect">
-            <a:avLst/>
-          </a:prstGeom>
-          <a:noFill/>
-        </p:spPr>
-        <p:txBody>
-          <a:bodyPr wrap="square"/>
-          <a:lstStyle/>
-          <a:p>
-            <a:pPr algn="l"/>
-            <a:r>
-              <a:rPr sz="1600" b="0">
-                <a:solidFill>
-                  <a:srgbClr val="B7C0D0"/>
-                </a:solidFill>
-                <a:latin typeface="Calibri"/>
-              </a:rPr>
-              <a:t>Name the agent. Say what it does for you.</a:t>
-            </a:r>
-          </a:p>
-        </p:txBody>
-      </p:sp>
-      <p:sp>
-        <p:nvSpPr>
-          <p:cNvPr id="15" name="Rounded Rectangle 14"/>
-          <p:cNvSpPr/>
-          <p:nvPr/>
-        </p:nvSpPr>
-        <p:spPr>
-          <a:xfrm>
-            <a:off x="685800" y="4023360"/>
-            <a:ext cx="5212080" cy="1691640"/>
-          </a:xfrm>
-          <a:prstGeom prst="roundRect">
-            <a:avLst>
-              <a:gd name="adj" fmla="val 12000"/>
-            </a:avLst>
-          </a:prstGeom>
-          <a:solidFill>
-            <a:srgbClr val="141C2C">
-              <a:alpha val="88000"/>
-            </a:srgbClr>
-          </a:solidFill>
-          <a:ln>
-            <a:noFill/>
-          </a:ln>
-        </p:spPr>
-        <p:style>
-          <a:lnRef idx="1">
-            <a:schemeClr val="accent1"/>
-          </a:lnRef>
-          <a:fillRef idx="3">
-            <a:schemeClr val="accent1"/>
-          </a:fillRef>
-          <a:effectRef idx="2">
-            <a:schemeClr val="accent1"/>
-          </a:effectRef>
-          <a:fontRef idx="minor">
-            <a:schemeClr val="lt1"/>
-          </a:fontRef>
-        </p:style>
-        <p:txBody>
-          <a:bodyPr rtlCol="0" anchor="ctr"/>
-          <a:lstStyle/>
-          <a:p>
-            <a:pPr algn="ctr"/>
-          </a:p>
-        </p:txBody>
-      </p:sp>
-      <p:sp>
-        <p:nvSpPr>
-          <p:cNvPr id="16" name="TextBox 15"/>
-          <p:cNvSpPr txBox="1"/>
-          <p:nvPr/>
-        </p:nvSpPr>
-        <p:spPr>
-          <a:xfrm>
-            <a:off x="941832" y="4169664"/>
-            <a:ext cx="4663440" cy="274320"/>
-          </a:xfrm>
-          <a:prstGeom prst="rect">
-            <a:avLst/>
-          </a:prstGeom>
-          <a:noFill/>
-        </p:spPr>
-        <p:txBody>
-          <a:bodyPr wrap="square"/>
-          <a:lstStyle/>
-          <a:p>
-            <a:pPr algn="l"/>
-            <a:r>
-              <a:rPr sz="1300" b="1">
-                <a:solidFill>
-                  <a:srgbClr val="FFB4BC"/>
-                </a:solidFill>
-                <a:latin typeface="Calibri"/>
-              </a:rPr>
-              <a:t>10 MIN</a:t>
-            </a:r>
-          </a:p>
-        </p:txBody>
-      </p:sp>
-      <p:sp>
-        <p:nvSpPr>
-          <p:cNvPr id="17" name="TextBox 16"/>
-          <p:cNvSpPr txBox="1"/>
-          <p:nvPr/>
-        </p:nvSpPr>
-        <p:spPr>
-          <a:xfrm>
-            <a:off x="941832" y="4443984"/>
-            <a:ext cx="4663440" cy="420624"/>
-          </a:xfrm>
-          <a:prstGeom prst="rect">
-            <a:avLst/>
-          </a:prstGeom>
-          <a:noFill/>
-        </p:spPr>
-        <p:txBody>
-          <a:bodyPr wrap="square"/>
-          <a:lstStyle/>
-          <a:p>
-            <a:pPr algn="l"/>
-            <a:r>
-              <a:rPr sz="2400" b="1">
-                <a:solidFill>
-                  <a:srgbClr val="F4F7FB"/>
-                </a:solidFill>
-                <a:latin typeface="Calibri"/>
-              </a:rPr>
-              <a:t>2  Three screens</a:t>
-            </a:r>
-          </a:p>
-        </p:txBody>
-      </p:sp>
-      <p:sp>
-        <p:nvSpPr>
-          <p:cNvPr id="18" name="TextBox 17"/>
-          <p:cNvSpPr txBox="1"/>
-          <p:nvPr/>
-        </p:nvSpPr>
-        <p:spPr>
-          <a:xfrm>
-            <a:off x="941832" y="4919472"/>
-            <a:ext cx="4663440" cy="640080"/>
-          </a:xfrm>
-          <a:prstGeom prst="rect">
-            <a:avLst/>
-          </a:prstGeom>
-          <a:noFill/>
-        </p:spPr>
-        <p:txBody>
-          <a:bodyPr wrap="square"/>
-          <a:lstStyle/>
-          <a:p>
-            <a:pPr algn="l"/>
-            <a:r>
-              <a:rPr sz="1600" b="0">
-                <a:solidFill>
-                  <a:srgbClr val="B7C0D0"/>
-                </a:solidFill>
-                <a:latin typeface="Calibri"/>
-              </a:rPr>
-              <a:t>Describe the journey, then generate each screen.</a:t>
-            </a:r>
-          </a:p>
-        </p:txBody>
-      </p:sp>
-      <p:sp>
-        <p:nvSpPr>
-          <p:cNvPr id="19" name="Rounded Rectangle 18"/>
-          <p:cNvSpPr/>
-          <p:nvPr/>
-        </p:nvSpPr>
-        <p:spPr>
-          <a:xfrm>
-            <a:off x="6263640" y="4023360"/>
-            <a:ext cx="5212080" cy="1691640"/>
-          </a:xfrm>
-          <a:prstGeom prst="roundRect">
-            <a:avLst>
-              <a:gd name="adj" fmla="val 12000"/>
-            </a:avLst>
-          </a:prstGeom>
-          <a:solidFill>
-            <a:srgbClr val="141C2C">
-              <a:alpha val="88000"/>
-            </a:srgbClr>
-          </a:solidFill>
-          <a:ln>
-            <a:noFill/>
-          </a:ln>
-        </p:spPr>
-        <p:style>
-          <a:lnRef idx="1">
-            <a:schemeClr val="accent1"/>
-          </a:lnRef>
-          <a:fillRef idx="3">
-            <a:schemeClr val="accent1"/>
-          </a:fillRef>
-          <a:effectRef idx="2">
-            <a:schemeClr val="accent1"/>
-          </a:effectRef>
-          <a:fontRef idx="minor">
-            <a:schemeClr val="lt1"/>
-          </a:fontRef>
-        </p:style>
-        <p:txBody>
-          <a:bodyPr rtlCol="0" anchor="ctr"/>
-          <a:lstStyle/>
-          <a:p>
-            <a:pPr algn="ctr"/>
-          </a:p>
-        </p:txBody>
-      </p:sp>
-      <p:sp>
-        <p:nvSpPr>
-          <p:cNvPr id="20" name="TextBox 19"/>
-          <p:cNvSpPr txBox="1"/>
-          <p:nvPr/>
-        </p:nvSpPr>
-        <p:spPr>
-          <a:xfrm>
-            <a:off x="6519672" y="4169664"/>
-            <a:ext cx="4663440" cy="274320"/>
-          </a:xfrm>
-          <a:prstGeom prst="rect">
-            <a:avLst/>
-          </a:prstGeom>
-          <a:noFill/>
-        </p:spPr>
-        <p:txBody>
-          <a:bodyPr wrap="square"/>
-          <a:lstStyle/>
-          <a:p>
-            <a:pPr algn="l"/>
-            <a:r>
-              <a:rPr sz="1300" b="1">
-                <a:solidFill>
-                  <a:srgbClr val="FFB4BC"/>
-                </a:solidFill>
-                <a:latin typeface="Calibri"/>
-              </a:rPr>
-              <a:t>15 MIN</a:t>
-            </a:r>
-          </a:p>
-        </p:txBody>
-      </p:sp>
-      <p:sp>
-        <p:nvSpPr>
-          <p:cNvPr id="21" name="TextBox 20"/>
-          <p:cNvSpPr txBox="1"/>
-          <p:nvPr/>
-        </p:nvSpPr>
-        <p:spPr>
-          <a:xfrm>
-            <a:off x="6519672" y="4443984"/>
-            <a:ext cx="4663440" cy="420624"/>
-          </a:xfrm>
-          <a:prstGeom prst="rect">
-            <a:avLst/>
-          </a:prstGeom>
-          <a:noFill/>
-        </p:spPr>
-        <p:txBody>
-          <a:bodyPr wrap="square"/>
-          <a:lstStyle/>
-          <a:p>
-            <a:pPr algn="l"/>
-            <a:r>
-              <a:rPr sz="2400" b="1">
-                <a:solidFill>
-                  <a:srgbClr val="F4F7FB"/>
-                </a:solidFill>
-                <a:latin typeface="Calibri"/>
-              </a:rPr>
-              <a:t>3  Prototype</a:t>
-            </a:r>
-          </a:p>
-        </p:txBody>
-      </p:sp>
-      <p:sp>
-        <p:nvSpPr>
-          <p:cNvPr id="22" name="TextBox 21"/>
-          <p:cNvSpPr txBox="1"/>
-          <p:nvPr/>
-        </p:nvSpPr>
-        <p:spPr>
-          <a:xfrm>
-            <a:off x="6519672" y="4919472"/>
-            <a:ext cx="4663440" cy="640080"/>
-          </a:xfrm>
-          <a:prstGeom prst="rect">
-            <a:avLst/>
-          </a:prstGeom>
-          <a:noFill/>
-        </p:spPr>
-        <p:txBody>
-          <a:bodyPr wrap="square"/>
-          <a:lstStyle/>
-          <a:p>
-            <a:pPr algn="l"/>
-            <a:r>
-              <a:rPr sz="1600" b="0">
-                <a:solidFill>
-                  <a:srgbClr val="B7C0D0"/>
-                </a:solidFill>
-                <a:latin typeface="Calibri"/>
-              </a:rPr>
-              <a:t>Make it clickable. One or two edits. Then present.</a:t>
+              <a:t>5.  Press Next. The same five minutes also cover the idea brief.</a:t>
             </a:r>
           </a:p>
         </p:txBody>
@@ -4686,7 +4706,7 @@
     <p:bg>
       <p:bgPr>
         <a:solidFill>
-          <a:srgbClr val="070B14"/>
+          <a:srgbClr val="F6F3FC"/>
         </a:solidFill>
         <a:effectLst/>
       </p:bgPr>
@@ -4706,15 +4726,15 @@
         </p:nvSpPr>
         <p:spPr>
           <a:xfrm>
-            <a:off x="-1097280" y="-1463040"/>
-            <a:ext cx="4754880" cy="4754880"/>
+            <a:off x="-1463040" y="-1280160"/>
+            <a:ext cx="4023360" cy="4023360"/>
           </a:xfrm>
           <a:prstGeom prst="ellipse">
             <a:avLst/>
           </a:prstGeom>
           <a:solidFill>
-            <a:srgbClr val="DB0011">
-              <a:alpha val="38000"/>
+            <a:srgbClr val="E4D8FF">
+              <a:alpha val="80000"/>
             </a:srgbClr>
           </a:solidFill>
           <a:ln>
@@ -4751,15 +4771,15 @@
         </p:nvSpPr>
         <p:spPr>
           <a:xfrm>
-            <a:off x="8595360" y="-1280160"/>
-            <a:ext cx="4206240" cy="4206240"/>
+            <a:off x="9326880" y="4754880"/>
+            <a:ext cx="3291840" cy="3291840"/>
           </a:xfrm>
           <a:prstGeom prst="ellipse">
             <a:avLst/>
           </a:prstGeom>
           <a:solidFill>
-            <a:srgbClr val="5A8CFF">
-              <a:alpha val="28000"/>
+            <a:srgbClr val="F8D8EE">
+              <a:alpha val="80000"/>
             </a:srgbClr>
           </a:solidFill>
           <a:ln>
@@ -4790,21 +4810,122 @@
       </p:sp>
       <p:sp>
         <p:nvSpPr>
-          <p:cNvPr id="4" name="Oval 3"/>
+          <p:cNvPr id="4" name="TextBox 3"/>
+          <p:cNvSpPr txBox="1"/>
+          <p:nvPr/>
+        </p:nvSpPr>
+        <p:spPr>
+          <a:xfrm>
+            <a:off x="502920" y="292608"/>
+            <a:ext cx="7315200" cy="256032"/>
+          </a:xfrm>
+          <a:prstGeom prst="rect">
+            <a:avLst/>
+          </a:prstGeom>
+          <a:noFill/>
+        </p:spPr>
+        <p:txBody>
+          <a:bodyPr wrap="square"/>
+          <a:lstStyle/>
+          <a:p>
+            <a:pPr algn="l"/>
+            <a:r>
+              <a:rPr sz="1200" b="1">
+                <a:solidFill>
+                  <a:srgbClr val="6B4EFF"/>
+                </a:solidFill>
+                <a:latin typeface="Calibri"/>
+              </a:rPr>
+              <a:t>APPENDIX  ·  PRINT FOR THE DESK</a:t>
+            </a:r>
+          </a:p>
+        </p:txBody>
+      </p:sp>
+      <p:sp>
+        <p:nvSpPr>
+          <p:cNvPr id="5" name="TextBox 4"/>
+          <p:cNvSpPr txBox="1"/>
+          <p:nvPr/>
+        </p:nvSpPr>
+        <p:spPr>
+          <a:xfrm>
+            <a:off x="502920" y="621792"/>
+            <a:ext cx="7315200" cy="256032"/>
+          </a:xfrm>
+          <a:prstGeom prst="rect">
+            <a:avLst/>
+          </a:prstGeom>
+          <a:noFill/>
+        </p:spPr>
+        <p:txBody>
+          <a:bodyPr wrap="square"/>
+          <a:lstStyle/>
+          <a:p>
+            <a:pPr algn="l"/>
+            <a:r>
+              <a:rPr sz="1400" b="1">
+                <a:solidFill>
+                  <a:srgbClr val="6B4EFF"/>
+                </a:solidFill>
+                <a:latin typeface="Calibri"/>
+              </a:rPr>
+              <a:t>STEP 1  ·  STILL INSIDE THE FIRST 5 MINUTES</a:t>
+            </a:r>
+          </a:p>
+        </p:txBody>
+      </p:sp>
+      <p:sp>
+        <p:nvSpPr>
+          <p:cNvPr id="6" name="TextBox 5"/>
+          <p:cNvSpPr txBox="1"/>
+          <p:nvPr/>
+        </p:nvSpPr>
+        <p:spPr>
+          <a:xfrm>
+            <a:off x="457200" y="868680"/>
+            <a:ext cx="10972800" cy="548640"/>
+          </a:xfrm>
+          <a:prstGeom prst="rect">
+            <a:avLst/>
+          </a:prstGeom>
+          <a:noFill/>
+        </p:spPr>
+        <p:txBody>
+          <a:bodyPr wrap="square"/>
+          <a:lstStyle/>
+          <a:p>
+            <a:pPr algn="l"/>
+            <a:r>
+              <a:rPr sz="3200" b="1">
+                <a:solidFill>
+                  <a:srgbClr val="1E1B2E"/>
+                </a:solidFill>
+                <a:latin typeface="Calibri"/>
+              </a:rPr>
+              <a:t>Write the idea brief</a:t>
+            </a:r>
+          </a:p>
+        </p:txBody>
+      </p:sp>
+      <p:sp>
+        <p:nvSpPr>
+          <p:cNvPr id="7" name="Rounded Rectangle 6"/>
           <p:cNvSpPr/>
           <p:nvPr/>
         </p:nvSpPr>
         <p:spPr>
           <a:xfrm>
-            <a:off x="7863840" y="4389120"/>
-            <a:ext cx="3840480" cy="3840480"/>
-          </a:xfrm>
-          <a:prstGeom prst="ellipse">
-            <a:avLst/>
+            <a:off x="457200" y="1737360"/>
+            <a:ext cx="11247120" cy="4480560"/>
+          </a:xfrm>
+          <a:prstGeom prst="roundRect">
+            <a:avLst>
+              <a:gd name="adj" fmla="val 8000"/>
+            </a:avLst>
           </a:prstGeom>
           <a:solidFill>
-            <a:srgbClr val="50DCB4">
-              <a:alpha val="16000"/>
+            <a:srgbClr val="FFFFFF">
+              <a:alpha val="92000"/>
             </a:srgbClr>
           </a:solidFill>
           <a:ln>
@@ -4835,14 +4956,14 @@
       </p:sp>
       <p:sp>
         <p:nvSpPr>
-          <p:cNvPr id="5" name="TextBox 4"/>
+          <p:cNvPr id="8" name="TextBox 7"/>
           <p:cNvSpPr txBox="1"/>
           <p:nvPr/>
         </p:nvSpPr>
         <p:spPr>
           <a:xfrm>
-            <a:off x="685800" y="502920"/>
-            <a:ext cx="10058400" cy="320040"/>
+            <a:off x="777240" y="1965960"/>
+            <a:ext cx="10607040" cy="4023360"/>
           </a:xfrm>
           <a:prstGeom prst="rect">
             <a:avLst/>
@@ -4850,84 +4971,104 @@
           <a:noFill/>
         </p:spPr>
         <p:txBody>
-          <a:bodyPr wrap="square"/>
-          <a:lstStyle/>
-          <a:p>
-            <a:pPr algn="l"/>
-            <a:r>
-              <a:rPr sz="1400" b="1">
-                <a:solidFill>
-                  <a:srgbClr val="FFB4BC"/>
+          <a:bodyPr wrap="square">
+            <a:spAutoFit/>
+          </a:bodyPr>
+          <a:lstStyle/>
+          <a:p>
+            <a:pPr>
+              <a:spcAft>
+                <a:spcPts val="1200"/>
+              </a:spcAft>
+            </a:pPr>
+            <a:r>
+              <a:rPr sz="2200">
+                <a:solidFill>
+                  <a:srgbClr val="1E1B2E"/>
                 </a:solidFill>
                 <a:latin typeface="Calibri"/>
               </a:rPr>
-              <a:t>STEP 0  ·  5 MINUTES, SHARED WITH THE BRIEF</a:t>
-            </a:r>
-          </a:p>
-        </p:txBody>
-      </p:sp>
-      <p:sp>
-        <p:nvSpPr>
-          <p:cNvPr id="6" name="TextBox 5"/>
-          <p:cNvSpPr txBox="1"/>
-          <p:nvPr/>
-        </p:nvSpPr>
-        <p:spPr>
-          <a:xfrm>
-            <a:off x="685800" y="1051560"/>
-            <a:ext cx="10789920" cy="1920240"/>
-          </a:xfrm>
-          <a:prstGeom prst="rect">
-            <a:avLst/>
-          </a:prstGeom>
-          <a:noFill/>
-        </p:spPr>
-        <p:txBody>
-          <a:bodyPr wrap="square"/>
-          <a:lstStyle/>
-          <a:p>
-            <a:pPr algn="l"/>
-            <a:r>
-              <a:rPr sz="4800" b="1">
-                <a:solidFill>
-                  <a:srgbClr val="F4F7FB"/>
+              <a:t>The painpoint is already there. Leave it.</a:t>
+            </a:r>
+          </a:p>
+          <a:p>
+            <a:pPr>
+              <a:spcAft>
+                <a:spcPts val="1200"/>
+              </a:spcAft>
+            </a:pPr>
+            <a:r>
+              <a:rPr sz="2200">
+                <a:solidFill>
+                  <a:srgbClr val="1E1B2E"/>
                 </a:solidFill>
                 <a:latin typeface="Calibri"/>
               </a:rPr>
-              <a:t>Which painpoint is yours?</a:t>
-            </a:r>
-          </a:p>
-        </p:txBody>
-      </p:sp>
-      <p:sp>
-        <p:nvSpPr>
-          <p:cNvPr id="7" name="TextBox 6"/>
-          <p:cNvSpPr txBox="1"/>
-          <p:nvPr/>
-        </p:nvSpPr>
-        <p:spPr>
-          <a:xfrm>
-            <a:off x="685800" y="3200400"/>
-            <a:ext cx="9692640" cy="1463040"/>
-          </a:xfrm>
-          <a:prstGeom prst="rect">
-            <a:avLst/>
-          </a:prstGeom>
-          <a:noFill/>
-        </p:spPr>
-        <p:txBody>
-          <a:bodyPr wrap="square"/>
-          <a:lstStyle/>
-          <a:p>
-            <a:pPr algn="l"/>
-            <a:r>
-              <a:rPr sz="2400" b="0">
-                <a:solidFill>
-                  <a:srgbClr val="B7C0D0"/>
+              <a:t>Name your agent. Short enough to say out loud, for example EDD guru.</a:t>
+            </a:r>
+          </a:p>
+          <a:p>
+            <a:pPr>
+              <a:spcAft>
+                <a:spcPts val="1200"/>
+              </a:spcAft>
+            </a:pPr>
+            <a:r>
+              <a:rPr sz="2200">
+                <a:solidFill>
+                  <a:srgbClr val="1E1B2E"/>
                 </a:solidFill>
                 <a:latin typeface="Calibri"/>
               </a:rPr>
-              <a:t>Pick the card the group feels most strongly. If none of them is yours, write your own along the bottom.</a:t>
+              <a:t>What exactly is the agent doing as your assistant?</a:t>
+            </a:r>
+          </a:p>
+          <a:p>
+            <a:pPr>
+              <a:spcAft>
+                <a:spcPts val="1200"/>
+              </a:spcAft>
+            </a:pPr>
+            <a:r>
+              <a:rPr sz="2200">
+                <a:solidFill>
+                  <a:srgbClr val="1E1B2E"/>
+                </a:solidFill>
+                <a:latin typeface="Calibri"/>
+              </a:rPr>
+              <a:t>As the RM, what do you expect to see and receive?</a:t>
+            </a:r>
+          </a:p>
+          <a:p>
+            <a:pPr>
+              <a:spcAft>
+                <a:spcPts val="1200"/>
+              </a:spcAft>
+            </a:pPr>
+            <a:r>
+              <a:rPr sz="2200">
+                <a:solidFill>
+                  <a:srgbClr val="1E1B2E"/>
+                </a:solidFill>
+                <a:latin typeface="Calibri"/>
+              </a:rPr>
+              <a:t>What is the benefit for you, or for the client?</a:t>
+            </a:r>
+          </a:p>
+          <a:p>
+            <a:pPr>
+              <a:spcAft>
+                <a:spcPts val="1200"/>
+              </a:spcAft>
+            </a:pPr>
+            <a:r>
+              <a:rPr sz="2200">
+                <a:solidFill>
+                  <a:srgbClr val="1E1B2E"/>
+                </a:solidFill>
+                <a:latin typeface="Calibri"/>
+              </a:rPr>
+              <a:t>Click a box if you want help. Empty: Get some inspiration. Written: Refine prompt.</a:t>
             </a:r>
           </a:p>
         </p:txBody>
@@ -4946,7 +5087,7 @@
     <p:bg>
       <p:bgPr>
         <a:solidFill>
-          <a:srgbClr val="070B14"/>
+          <a:srgbClr val="F6F3FC"/>
         </a:solidFill>
         <a:effectLst/>
       </p:bgPr>
@@ -4966,15 +5107,15 @@
         </p:nvSpPr>
         <p:spPr>
           <a:xfrm>
-            <a:off x="-1097280" y="-1463040"/>
-            <a:ext cx="4754880" cy="4754880"/>
+            <a:off x="-1463040" y="-1280160"/>
+            <a:ext cx="4023360" cy="4023360"/>
           </a:xfrm>
           <a:prstGeom prst="ellipse">
             <a:avLst/>
           </a:prstGeom>
           <a:solidFill>
-            <a:srgbClr val="DB0011">
-              <a:alpha val="38000"/>
+            <a:srgbClr val="E4D8FF">
+              <a:alpha val="80000"/>
             </a:srgbClr>
           </a:solidFill>
           <a:ln>
@@ -5011,15 +5152,15 @@
         </p:nvSpPr>
         <p:spPr>
           <a:xfrm>
-            <a:off x="8595360" y="-1280160"/>
-            <a:ext cx="4206240" cy="4206240"/>
+            <a:off x="9326880" y="4754880"/>
+            <a:ext cx="3291840" cy="3291840"/>
           </a:xfrm>
           <a:prstGeom prst="ellipse">
             <a:avLst/>
           </a:prstGeom>
           <a:solidFill>
-            <a:srgbClr val="5A8CFF">
-              <a:alpha val="28000"/>
+            <a:srgbClr val="F8D8EE">
+              <a:alpha val="80000"/>
             </a:srgbClr>
           </a:solidFill>
           <a:ln>
@@ -5050,21 +5191,122 @@
       </p:sp>
       <p:sp>
         <p:nvSpPr>
-          <p:cNvPr id="4" name="Oval 3"/>
+          <p:cNvPr id="4" name="TextBox 3"/>
+          <p:cNvSpPr txBox="1"/>
+          <p:nvPr/>
+        </p:nvSpPr>
+        <p:spPr>
+          <a:xfrm>
+            <a:off x="502920" y="292608"/>
+            <a:ext cx="7315200" cy="256032"/>
+          </a:xfrm>
+          <a:prstGeom prst="rect">
+            <a:avLst/>
+          </a:prstGeom>
+          <a:noFill/>
+        </p:spPr>
+        <p:txBody>
+          <a:bodyPr wrap="square"/>
+          <a:lstStyle/>
+          <a:p>
+            <a:pPr algn="l"/>
+            <a:r>
+              <a:rPr sz="1200" b="1">
+                <a:solidFill>
+                  <a:srgbClr val="6B4EFF"/>
+                </a:solidFill>
+                <a:latin typeface="Calibri"/>
+              </a:rPr>
+              <a:t>APPENDIX  ·  PRINT FOR THE DESK</a:t>
+            </a:r>
+          </a:p>
+        </p:txBody>
+      </p:sp>
+      <p:sp>
+        <p:nvSpPr>
+          <p:cNvPr id="5" name="TextBox 4"/>
+          <p:cNvSpPr txBox="1"/>
+          <p:nvPr/>
+        </p:nvSpPr>
+        <p:spPr>
+          <a:xfrm>
+            <a:off x="502920" y="621792"/>
+            <a:ext cx="7315200" cy="256032"/>
+          </a:xfrm>
+          <a:prstGeom prst="rect">
+            <a:avLst/>
+          </a:prstGeom>
+          <a:noFill/>
+        </p:spPr>
+        <p:txBody>
+          <a:bodyPr wrap="square"/>
+          <a:lstStyle/>
+          <a:p>
+            <a:pPr algn="l"/>
+            <a:r>
+              <a:rPr sz="1400" b="1">
+                <a:solidFill>
+                  <a:srgbClr val="6B4EFF"/>
+                </a:solidFill>
+                <a:latin typeface="Calibri"/>
+              </a:rPr>
+              <a:t>STEP 2  ·  10 MINUTES</a:t>
+            </a:r>
+          </a:p>
+        </p:txBody>
+      </p:sp>
+      <p:sp>
+        <p:nvSpPr>
+          <p:cNvPr id="6" name="TextBox 5"/>
+          <p:cNvSpPr txBox="1"/>
+          <p:nvPr/>
+        </p:nvSpPr>
+        <p:spPr>
+          <a:xfrm>
+            <a:off x="457200" y="868680"/>
+            <a:ext cx="10972800" cy="548640"/>
+          </a:xfrm>
+          <a:prstGeom prst="rect">
+            <a:avLst/>
+          </a:prstGeom>
+          <a:noFill/>
+        </p:spPr>
+        <p:txBody>
+          <a:bodyPr wrap="square"/>
+          <a:lstStyle/>
+          <a:p>
+            <a:pPr algn="l"/>
+            <a:r>
+              <a:rPr sz="3200" b="1">
+                <a:solidFill>
+                  <a:srgbClr val="1E1B2E"/>
+                </a:solidFill>
+                <a:latin typeface="Calibri"/>
+              </a:rPr>
+              <a:t>Design three screens</a:t>
+            </a:r>
+          </a:p>
+        </p:txBody>
+      </p:sp>
+      <p:sp>
+        <p:nvSpPr>
+          <p:cNvPr id="7" name="Rounded Rectangle 6"/>
           <p:cNvSpPr/>
           <p:nvPr/>
         </p:nvSpPr>
         <p:spPr>
           <a:xfrm>
-            <a:off x="7863840" y="4389120"/>
-            <a:ext cx="3840480" cy="3840480"/>
-          </a:xfrm>
-          <a:prstGeom prst="ellipse">
-            <a:avLst/>
+            <a:off x="457200" y="1737360"/>
+            <a:ext cx="11247120" cy="4480560"/>
+          </a:xfrm>
+          <a:prstGeom prst="roundRect">
+            <a:avLst>
+              <a:gd name="adj" fmla="val 8000"/>
+            </a:avLst>
           </a:prstGeom>
           <a:solidFill>
-            <a:srgbClr val="50DCB4">
-              <a:alpha val="16000"/>
+            <a:srgbClr val="FFFFFF">
+              <a:alpha val="92000"/>
             </a:srgbClr>
           </a:solidFill>
           <a:ln>
@@ -5095,134 +5337,14 @@
       </p:sp>
       <p:sp>
         <p:nvSpPr>
-          <p:cNvPr id="5" name="TextBox 4"/>
-          <p:cNvSpPr txBox="1"/>
-          <p:nvPr/>
-        </p:nvSpPr>
-        <p:spPr>
-          <a:xfrm>
-            <a:off x="685800" y="502920"/>
-            <a:ext cx="10058400" cy="320040"/>
-          </a:xfrm>
-          <a:prstGeom prst="rect">
-            <a:avLst/>
-          </a:prstGeom>
-          <a:noFill/>
-        </p:spPr>
-        <p:txBody>
-          <a:bodyPr wrap="square"/>
-          <a:lstStyle/>
-          <a:p>
-            <a:pPr algn="l"/>
-            <a:r>
-              <a:rPr sz="1400" b="1">
-                <a:solidFill>
-                  <a:srgbClr val="FFB4BC"/>
-                </a:solidFill>
-                <a:latin typeface="Calibri"/>
-              </a:rPr>
-              <a:t>STEP 1  ·  STILL INSIDE THE 5 MINUTES</a:t>
-            </a:r>
-          </a:p>
-        </p:txBody>
-      </p:sp>
-      <p:sp>
-        <p:nvSpPr>
-          <p:cNvPr id="6" name="TextBox 5"/>
-          <p:cNvSpPr txBox="1"/>
-          <p:nvPr/>
-        </p:nvSpPr>
-        <p:spPr>
-          <a:xfrm>
-            <a:off x="685800" y="868680"/>
-            <a:ext cx="10789920" cy="1920240"/>
-          </a:xfrm>
-          <a:prstGeom prst="rect">
-            <a:avLst/>
-          </a:prstGeom>
-          <a:noFill/>
-        </p:spPr>
-        <p:txBody>
-          <a:bodyPr wrap="square"/>
-          <a:lstStyle/>
-          <a:p>
-            <a:pPr algn="l"/>
-            <a:r>
-              <a:rPr sz="4000" b="1">
-                <a:solidFill>
-                  <a:srgbClr val="F4F7FB"/>
-                </a:solidFill>
-                <a:latin typeface="Calibri"/>
-              </a:rPr>
-              <a:t>Write the idea brief.</a:t>
-            </a:r>
-          </a:p>
-        </p:txBody>
-      </p:sp>
-      <p:sp>
-        <p:nvSpPr>
-          <p:cNvPr id="7" name="Rounded Rectangle 6"/>
-          <p:cNvSpPr/>
-          <p:nvPr/>
-        </p:nvSpPr>
-        <p:spPr>
-          <a:xfrm>
-            <a:off x="685800" y="2148840"/>
-            <a:ext cx="566928" cy="566928"/>
-          </a:xfrm>
-          <a:prstGeom prst="roundRect">
-            <a:avLst>
-              <a:gd name="adj" fmla="val 20000"/>
-            </a:avLst>
-          </a:prstGeom>
-          <a:solidFill>
-            <a:srgbClr val="DB0011"/>
-          </a:solidFill>
-          <a:ln>
-            <a:noFill/>
-          </a:ln>
-        </p:spPr>
-        <p:style>
-          <a:lnRef idx="1">
-            <a:schemeClr val="accent1"/>
-          </a:lnRef>
-          <a:fillRef idx="3">
-            <a:schemeClr val="accent1"/>
-          </a:fillRef>
-          <a:effectRef idx="2">
-            <a:schemeClr val="accent1"/>
-          </a:effectRef>
-          <a:fontRef idx="minor">
-            <a:schemeClr val="lt1"/>
-          </a:fontRef>
-        </p:style>
-        <p:txBody>
-          <a:bodyPr rtlCol="0" anchor="ctr" wrap="none"/>
-          <a:lstStyle/>
-          <a:p>
-            <a:pPr algn="ctr"/>
-            <a:r>
-              <a:rPr sz="2000" b="1">
-                <a:solidFill>
-                  <a:srgbClr val="F4F7FB"/>
-                </a:solidFill>
-                <a:latin typeface="Calibri"/>
-              </a:rPr>
-              <a:t>1</a:t>
-            </a:r>
-          </a:p>
-        </p:txBody>
-      </p:sp>
-      <p:sp>
-        <p:nvSpPr>
           <p:cNvPr id="8" name="TextBox 7"/>
           <p:cNvSpPr txBox="1"/>
           <p:nvPr/>
         </p:nvSpPr>
         <p:spPr>
           <a:xfrm>
-            <a:off x="1463040" y="2221992"/>
-            <a:ext cx="9601200" cy="457200"/>
+            <a:off x="777240" y="1965960"/>
+            <a:ext cx="10607040" cy="4023360"/>
           </a:xfrm>
           <a:prstGeom prst="rect">
             <a:avLst/>
@@ -5230,279 +5352,104 @@
           <a:noFill/>
         </p:spPr>
         <p:txBody>
-          <a:bodyPr wrap="square"/>
-          <a:lstStyle/>
-          <a:p>
-            <a:pPr algn="l"/>
-            <a:r>
-              <a:rPr sz="2600" b="0">
-                <a:solidFill>
-                  <a:srgbClr val="F4F7FB"/>
+          <a:bodyPr wrap="square">
+            <a:spAutoFit/>
+          </a:bodyPr>
+          <a:lstStyle/>
+          <a:p>
+            <a:pPr>
+              <a:spcAft>
+                <a:spcPts val="1200"/>
+              </a:spcAft>
+            </a:pPr>
+            <a:r>
+              <a:rPr sz="2200">
+                <a:solidFill>
+                  <a:srgbClr val="1E1B2E"/>
                 </a:solidFill>
                 <a:latin typeface="Calibri"/>
               </a:rPr>
-              <a:t>Name your agent. Short, like EDD guru.</a:t>
-            </a:r>
-          </a:p>
-        </p:txBody>
-      </p:sp>
-      <p:sp>
-        <p:nvSpPr>
-          <p:cNvPr id="9" name="Rounded Rectangle 8"/>
-          <p:cNvSpPr/>
-          <p:nvPr/>
-        </p:nvSpPr>
-        <p:spPr>
-          <a:xfrm>
-            <a:off x="685800" y="3108960"/>
-            <a:ext cx="566928" cy="566928"/>
-          </a:xfrm>
-          <a:prstGeom prst="roundRect">
-            <a:avLst>
-              <a:gd name="adj" fmla="val 20000"/>
-            </a:avLst>
-          </a:prstGeom>
-          <a:solidFill>
-            <a:srgbClr val="DB0011"/>
-          </a:solidFill>
-          <a:ln>
-            <a:noFill/>
-          </a:ln>
-        </p:spPr>
-        <p:style>
-          <a:lnRef idx="1">
-            <a:schemeClr val="accent1"/>
-          </a:lnRef>
-          <a:fillRef idx="3">
-            <a:schemeClr val="accent1"/>
-          </a:fillRef>
-          <a:effectRef idx="2">
-            <a:schemeClr val="accent1"/>
-          </a:effectRef>
-          <a:fontRef idx="minor">
-            <a:schemeClr val="lt1"/>
-          </a:fontRef>
-        </p:style>
-        <p:txBody>
-          <a:bodyPr rtlCol="0" anchor="ctr" wrap="none"/>
-          <a:lstStyle/>
-          <a:p>
-            <a:pPr algn="ctr"/>
-            <a:r>
-              <a:rPr sz="2000" b="1">
-                <a:solidFill>
-                  <a:srgbClr val="F4F7FB"/>
+              <a:t>Think of three steps, in order. What the assistant does, and what you then see.</a:t>
+            </a:r>
+          </a:p>
+          <a:p>
+            <a:pPr>
+              <a:spcAft>
+                <a:spcPts val="1200"/>
+              </a:spcAft>
+            </a:pPr>
+            <a:r>
+              <a:rPr sz="2200">
+                <a:solidFill>
+                  <a:srgbClr val="1E1B2E"/>
                 </a:solidFill>
                 <a:latin typeface="Calibri"/>
               </a:rPr>
-              <a:t>2</a:t>
-            </a:r>
-          </a:p>
-        </p:txBody>
-      </p:sp>
-      <p:sp>
-        <p:nvSpPr>
-          <p:cNvPr id="10" name="TextBox 9"/>
-          <p:cNvSpPr txBox="1"/>
-          <p:nvPr/>
-        </p:nvSpPr>
-        <p:spPr>
-          <a:xfrm>
-            <a:off x="1463040" y="3182112"/>
-            <a:ext cx="9601200" cy="457200"/>
-          </a:xfrm>
-          <a:prstGeom prst="rect">
-            <a:avLst/>
-          </a:prstGeom>
-          <a:noFill/>
-        </p:spPr>
-        <p:txBody>
-          <a:bodyPr wrap="square"/>
-          <a:lstStyle/>
-          <a:p>
-            <a:pPr algn="l"/>
-            <a:r>
-              <a:rPr sz="2600" b="0">
-                <a:solidFill>
-                  <a:srgbClr val="F4F7FB"/>
+              <a:t>Write one or two sentences in Screen 1 prompt, Screen 2 prompt, and Screen 3 prompt.</a:t>
+            </a:r>
+          </a:p>
+          <a:p>
+            <a:pPr>
+              <a:spcAft>
+                <a:spcPts val="1200"/>
+              </a:spcAft>
+            </a:pPr>
+            <a:r>
+              <a:rPr sz="2200">
+                <a:solidFill>
+                  <a:srgbClr val="1E1B2E"/>
                 </a:solidFill>
                 <a:latin typeface="Calibri"/>
               </a:rPr>
-              <a:t>What is the agent doing for you?</a:t>
-            </a:r>
-          </a:p>
-        </p:txBody>
-      </p:sp>
-      <p:sp>
-        <p:nvSpPr>
-          <p:cNvPr id="11" name="Rounded Rectangle 10"/>
-          <p:cNvSpPr/>
-          <p:nvPr/>
-        </p:nvSpPr>
-        <p:spPr>
-          <a:xfrm>
-            <a:off x="685800" y="4069080"/>
-            <a:ext cx="566928" cy="566928"/>
-          </a:xfrm>
-          <a:prstGeom prst="roundRect">
-            <a:avLst>
-              <a:gd name="adj" fmla="val 20000"/>
-            </a:avLst>
-          </a:prstGeom>
-          <a:solidFill>
-            <a:srgbClr val="DB0011"/>
-          </a:solidFill>
-          <a:ln>
-            <a:noFill/>
-          </a:ln>
-        </p:spPr>
-        <p:style>
-          <a:lnRef idx="1">
-            <a:schemeClr val="accent1"/>
-          </a:lnRef>
-          <a:fillRef idx="3">
-            <a:schemeClr val="accent1"/>
-          </a:fillRef>
-          <a:effectRef idx="2">
-            <a:schemeClr val="accent1"/>
-          </a:effectRef>
-          <a:fontRef idx="minor">
-            <a:schemeClr val="lt1"/>
-          </a:fontRef>
-        </p:style>
-        <p:txBody>
-          <a:bodyPr rtlCol="0" anchor="ctr" wrap="none"/>
-          <a:lstStyle/>
-          <a:p>
-            <a:pPr algn="ctr"/>
-            <a:r>
-              <a:rPr sz="2000" b="1">
-                <a:solidFill>
-                  <a:srgbClr val="F4F7FB"/>
+              <a:t>Press Generate screen on the empty picture.</a:t>
+            </a:r>
+          </a:p>
+          <a:p>
+            <a:pPr>
+              <a:spcAft>
+                <a:spcPts val="1200"/>
+              </a:spcAft>
+            </a:pPr>
+            <a:r>
+              <a:rPr sz="2200">
+                <a:solidFill>
+                  <a:srgbClr val="1E1B2E"/>
                 </a:solidFill>
                 <a:latin typeface="Calibri"/>
               </a:rPr>
-              <a:t>3</a:t>
-            </a:r>
-          </a:p>
-        </p:txBody>
-      </p:sp>
-      <p:sp>
-        <p:nvSpPr>
-          <p:cNvPr id="12" name="TextBox 11"/>
-          <p:cNvSpPr txBox="1"/>
-          <p:nvPr/>
-        </p:nvSpPr>
-        <p:spPr>
-          <a:xfrm>
-            <a:off x="1463040" y="4142232"/>
-            <a:ext cx="9601200" cy="457200"/>
-          </a:xfrm>
-          <a:prstGeom prst="rect">
-            <a:avLst/>
-          </a:prstGeom>
-          <a:noFill/>
-        </p:spPr>
-        <p:txBody>
-          <a:bodyPr wrap="square"/>
-          <a:lstStyle/>
-          <a:p>
-            <a:pPr algn="l"/>
-            <a:r>
-              <a:rPr sz="2600" b="0">
-                <a:solidFill>
-                  <a:srgbClr val="F4F7FB"/>
+              <a:t>When a picture is there, hover it for Generate screen again and full screen.</a:t>
+            </a:r>
+          </a:p>
+          <a:p>
+            <a:pPr>
+              <a:spcAft>
+                <a:spcPts val="1200"/>
+              </a:spcAft>
+            </a:pPr>
+            <a:r>
+              <a:rPr sz="2200">
+                <a:solidFill>
+                  <a:srgbClr val="1E1B2E"/>
                 </a:solidFill>
                 <a:latin typeface="Calibri"/>
               </a:rPr>
-              <a:t>What do you expect to see and receive?</a:t>
-            </a:r>
-          </a:p>
-        </p:txBody>
-      </p:sp>
-      <p:sp>
-        <p:nvSpPr>
-          <p:cNvPr id="13" name="Rounded Rectangle 12"/>
-          <p:cNvSpPr/>
-          <p:nvPr/>
-        </p:nvSpPr>
-        <p:spPr>
-          <a:xfrm>
-            <a:off x="685800" y="5029200"/>
-            <a:ext cx="566928" cy="566928"/>
-          </a:xfrm>
-          <a:prstGeom prst="roundRect">
-            <a:avLst>
-              <a:gd name="adj" fmla="val 20000"/>
-            </a:avLst>
-          </a:prstGeom>
-          <a:solidFill>
-            <a:srgbClr val="DB0011"/>
-          </a:solidFill>
-          <a:ln>
-            <a:noFill/>
-          </a:ln>
-        </p:spPr>
-        <p:style>
-          <a:lnRef idx="1">
-            <a:schemeClr val="accent1"/>
-          </a:lnRef>
-          <a:fillRef idx="3">
-            <a:schemeClr val="accent1"/>
-          </a:fillRef>
-          <a:effectRef idx="2">
-            <a:schemeClr val="accent1"/>
-          </a:effectRef>
-          <a:fontRef idx="minor">
-            <a:schemeClr val="lt1"/>
-          </a:fontRef>
-        </p:style>
-        <p:txBody>
-          <a:bodyPr rtlCol="0" anchor="ctr" wrap="none"/>
-          <a:lstStyle/>
-          <a:p>
-            <a:pPr algn="ctr"/>
-            <a:r>
-              <a:rPr sz="2000" b="1">
-                <a:solidFill>
-                  <a:srgbClr val="F4F7FB"/>
+              <a:t>Nothing written yet: Get some inspiration drafts all three prompts.</a:t>
+            </a:r>
+          </a:p>
+          <a:p>
+            <a:pPr>
+              <a:spcAft>
+                <a:spcPts val="1200"/>
+              </a:spcAft>
+            </a:pPr>
+            <a:r>
+              <a:rPr sz="2200">
+                <a:solidFill>
+                  <a:srgbClr val="1E1B2E"/>
                 </a:solidFill>
                 <a:latin typeface="Calibri"/>
               </a:rPr>
-              <a:t>4</a:t>
-            </a:r>
-          </a:p>
-        </p:txBody>
-      </p:sp>
-      <p:sp>
-        <p:nvSpPr>
-          <p:cNvPr id="14" name="TextBox 13"/>
-          <p:cNvSpPr txBox="1"/>
-          <p:nvPr/>
-        </p:nvSpPr>
-        <p:spPr>
-          <a:xfrm>
-            <a:off x="1463040" y="5102352"/>
-            <a:ext cx="9601200" cy="457200"/>
-          </a:xfrm>
-          <a:prstGeom prst="rect">
-            <a:avLst/>
-          </a:prstGeom>
-          <a:noFill/>
-        </p:spPr>
-        <p:txBody>
-          <a:bodyPr wrap="square"/>
-          <a:lstStyle/>
-          <a:p>
-            <a:pPr algn="l"/>
-            <a:r>
-              <a:rPr sz="2600" b="0">
-                <a:solidFill>
-                  <a:srgbClr val="F4F7FB"/>
-                </a:solidFill>
-                <a:latin typeface="Calibri"/>
-              </a:rPr>
-              <a:t>What changes for you, or for the client?</a:t>
+              <a:t>A prompt with text: the assistant refines only that screen.</a:t>
             </a:r>
           </a:p>
         </p:txBody>
@@ -5521,7 +5468,7 @@
     <p:bg>
       <p:bgPr>
         <a:solidFill>
-          <a:srgbClr val="070B14"/>
+          <a:srgbClr val="F6F3FC"/>
         </a:solidFill>
         <a:effectLst/>
       </p:bgPr>
@@ -5541,15 +5488,15 @@
         </p:nvSpPr>
         <p:spPr>
           <a:xfrm>
-            <a:off x="-1097280" y="-1463040"/>
-            <a:ext cx="4754880" cy="4754880"/>
+            <a:off x="-1463040" y="-1280160"/>
+            <a:ext cx="4023360" cy="4023360"/>
           </a:xfrm>
           <a:prstGeom prst="ellipse">
             <a:avLst/>
           </a:prstGeom>
           <a:solidFill>
-            <a:srgbClr val="DB0011">
-              <a:alpha val="38000"/>
+            <a:srgbClr val="E4D8FF">
+              <a:alpha val="80000"/>
             </a:srgbClr>
           </a:solidFill>
           <a:ln>
@@ -5586,15 +5533,15 @@
         </p:nvSpPr>
         <p:spPr>
           <a:xfrm>
-            <a:off x="8595360" y="-1280160"/>
-            <a:ext cx="4206240" cy="4206240"/>
+            <a:off x="9326880" y="4754880"/>
+            <a:ext cx="3291840" cy="3291840"/>
           </a:xfrm>
           <a:prstGeom prst="ellipse">
             <a:avLst/>
           </a:prstGeom>
           <a:solidFill>
-            <a:srgbClr val="5A8CFF">
-              <a:alpha val="28000"/>
+            <a:srgbClr val="F8D8EE">
+              <a:alpha val="80000"/>
             </a:srgbClr>
           </a:solidFill>
           <a:ln>
@@ -5625,21 +5572,122 @@
       </p:sp>
       <p:sp>
         <p:nvSpPr>
-          <p:cNvPr id="4" name="Oval 3"/>
+          <p:cNvPr id="4" name="TextBox 3"/>
+          <p:cNvSpPr txBox="1"/>
+          <p:nvPr/>
+        </p:nvSpPr>
+        <p:spPr>
+          <a:xfrm>
+            <a:off x="502920" y="292608"/>
+            <a:ext cx="7315200" cy="256032"/>
+          </a:xfrm>
+          <a:prstGeom prst="rect">
+            <a:avLst/>
+          </a:prstGeom>
+          <a:noFill/>
+        </p:spPr>
+        <p:txBody>
+          <a:bodyPr wrap="square"/>
+          <a:lstStyle/>
+          <a:p>
+            <a:pPr algn="l"/>
+            <a:r>
+              <a:rPr sz="1200" b="1">
+                <a:solidFill>
+                  <a:srgbClr val="6B4EFF"/>
+                </a:solidFill>
+                <a:latin typeface="Calibri"/>
+              </a:rPr>
+              <a:t>APPENDIX  ·  PRINT FOR THE DESK</a:t>
+            </a:r>
+          </a:p>
+        </p:txBody>
+      </p:sp>
+      <p:sp>
+        <p:nvSpPr>
+          <p:cNvPr id="5" name="TextBox 4"/>
+          <p:cNvSpPr txBox="1"/>
+          <p:nvPr/>
+        </p:nvSpPr>
+        <p:spPr>
+          <a:xfrm>
+            <a:off x="502920" y="621792"/>
+            <a:ext cx="7315200" cy="256032"/>
+          </a:xfrm>
+          <a:prstGeom prst="rect">
+            <a:avLst/>
+          </a:prstGeom>
+          <a:noFill/>
+        </p:spPr>
+        <p:txBody>
+          <a:bodyPr wrap="square"/>
+          <a:lstStyle/>
+          <a:p>
+            <a:pPr algn="l"/>
+            <a:r>
+              <a:rPr sz="1400" b="1">
+                <a:solidFill>
+                  <a:srgbClr val="6B4EFF"/>
+                </a:solidFill>
+                <a:latin typeface="Calibri"/>
+              </a:rPr>
+              <a:t>STEP 3  ·  15 MINUTES</a:t>
+            </a:r>
+          </a:p>
+        </p:txBody>
+      </p:sp>
+      <p:sp>
+        <p:nvSpPr>
+          <p:cNvPr id="6" name="TextBox 5"/>
+          <p:cNvSpPr txBox="1"/>
+          <p:nvPr/>
+        </p:nvSpPr>
+        <p:spPr>
+          <a:xfrm>
+            <a:off x="457200" y="868680"/>
+            <a:ext cx="10972800" cy="548640"/>
+          </a:xfrm>
+          <a:prstGeom prst="rect">
+            <a:avLst/>
+          </a:prstGeom>
+          <a:noFill/>
+        </p:spPr>
+        <p:txBody>
+          <a:bodyPr wrap="square"/>
+          <a:lstStyle/>
+          <a:p>
+            <a:pPr algn="l"/>
+            <a:r>
+              <a:rPr sz="3200" b="1">
+                <a:solidFill>
+                  <a:srgbClr val="1E1B2E"/>
+                </a:solidFill>
+                <a:latin typeface="Calibri"/>
+              </a:rPr>
+              <a:t>Build it, then present</a:t>
+            </a:r>
+          </a:p>
+        </p:txBody>
+      </p:sp>
+      <p:sp>
+        <p:nvSpPr>
+          <p:cNvPr id="7" name="Rounded Rectangle 6"/>
           <p:cNvSpPr/>
           <p:nvPr/>
         </p:nvSpPr>
         <p:spPr>
           <a:xfrm>
-            <a:off x="7863840" y="4389120"/>
-            <a:ext cx="3840480" cy="3840480"/>
-          </a:xfrm>
-          <a:prstGeom prst="ellipse">
-            <a:avLst/>
+            <a:off x="457200" y="1691640"/>
+            <a:ext cx="6903720" cy="4526280"/>
+          </a:xfrm>
+          <a:prstGeom prst="roundRect">
+            <a:avLst>
+              <a:gd name="adj" fmla="val 8000"/>
+            </a:avLst>
           </a:prstGeom>
           <a:solidFill>
-            <a:srgbClr val="50DCB4">
-              <a:alpha val="16000"/>
+            <a:srgbClr val="FFFFFF">
+              <a:alpha val="92000"/>
             </a:srgbClr>
           </a:solidFill>
           <a:ln>
@@ -5670,14 +5718,14 @@
       </p:sp>
       <p:sp>
         <p:nvSpPr>
-          <p:cNvPr id="5" name="TextBox 4"/>
+          <p:cNvPr id="8" name="TextBox 7"/>
           <p:cNvSpPr txBox="1"/>
           <p:nvPr/>
         </p:nvSpPr>
         <p:spPr>
           <a:xfrm>
-            <a:off x="685800" y="502920"/>
-            <a:ext cx="10058400" cy="320040"/>
+            <a:off x="731520" y="1874519"/>
+            <a:ext cx="6217920" cy="365760"/>
           </a:xfrm>
           <a:prstGeom prst="rect">
             <a:avLst/>
@@ -5690,27 +5738,27 @@
           <a:p>
             <a:pPr algn="l"/>
             <a:r>
-              <a:rPr sz="1400" b="1">
-                <a:solidFill>
-                  <a:srgbClr val="FFB4BC"/>
+              <a:rPr sz="2000" b="1">
+                <a:solidFill>
+                  <a:srgbClr val="6B4EFF"/>
                 </a:solidFill>
                 <a:latin typeface="Calibri"/>
               </a:rPr>
-              <a:t>STEP 2  ·  10 MINUTES</a:t>
-            </a:r>
-          </a:p>
-        </p:txBody>
-      </p:sp>
-      <p:sp>
-        <p:nvSpPr>
-          <p:cNvPr id="6" name="TextBox 5"/>
+              <a:t>Prototype</a:t>
+            </a:r>
+          </a:p>
+        </p:txBody>
+      </p:sp>
+      <p:sp>
+        <p:nvSpPr>
+          <p:cNvPr id="9" name="TextBox 8"/>
           <p:cNvSpPr txBox="1"/>
           <p:nvPr/>
         </p:nvSpPr>
         <p:spPr>
           <a:xfrm>
-            <a:off x="685800" y="1051560"/>
-            <a:ext cx="10789920" cy="1920240"/>
+            <a:off x="731520" y="2377440"/>
+            <a:ext cx="6309360" cy="3291840"/>
           </a:xfrm>
           <a:prstGeom prst="rect">
             <a:avLst/>
@@ -5718,98 +5766,79 @@
           <a:noFill/>
         </p:spPr>
         <p:txBody>
-          <a:bodyPr wrap="square"/>
-          <a:lstStyle/>
-          <a:p>
-            <a:pPr algn="l"/>
-            <a:r>
-              <a:rPr sz="4800" b="1">
-                <a:solidFill>
-                  <a:srgbClr val="F4F7FB"/>
+          <a:bodyPr wrap="square">
+            <a:spAutoFit/>
+          </a:bodyPr>
+          <a:lstStyle/>
+          <a:p>
+            <a:pPr>
+              <a:spcAft>
+                <a:spcPts val="1200"/>
+              </a:spcAft>
+            </a:pPr>
+            <a:r>
+              <a:rPr sz="2000">
+                <a:solidFill>
+                  <a:srgbClr val="1E1B2E"/>
                 </a:solidFill>
                 <a:latin typeface="Calibri"/>
               </a:rPr>
-              <a:t>Design three screens.</a:t>
-            </a:r>
-          </a:p>
-        </p:txBody>
-      </p:sp>
-      <p:sp>
-        <p:nvSpPr>
-          <p:cNvPr id="7" name="TextBox 6"/>
-          <p:cNvSpPr txBox="1"/>
-          <p:nvPr/>
-        </p:nvSpPr>
-        <p:spPr>
-          <a:xfrm>
-            <a:off x="685800" y="3108960"/>
-            <a:ext cx="9692640" cy="1463040"/>
-          </a:xfrm>
-          <a:prstGeom prst="rect">
-            <a:avLst/>
-          </a:prstGeom>
-          <a:noFill/>
-        </p:spPr>
-        <p:txBody>
-          <a:bodyPr wrap="square"/>
-          <a:lstStyle/>
-          <a:p>
-            <a:pPr algn="l"/>
-            <a:r>
-              <a:rPr sz="2400" b="0">
-                <a:solidFill>
-                  <a:srgbClr val="B7C0D0"/>
+              <a:t>Generate the prototype. It builds one screen at a time.</a:t>
+            </a:r>
+          </a:p>
+          <a:p>
+            <a:pPr>
+              <a:spcAft>
+                <a:spcPts val="1200"/>
+              </a:spcAft>
+            </a:pPr>
+            <a:r>
+              <a:rPr sz="2000">
+                <a:solidFill>
+                  <a:srgbClr val="1E1B2E"/>
                 </a:solidFill>
                 <a:latin typeface="Calibri"/>
               </a:rPr>
-              <a:t>Imagine you are directing the story. Write one or two sentences for each step, then press Generate screen. The AI assistant only helps with the screen you have open.</a:t>
-            </a:r>
-          </a:p>
-        </p:txBody>
-      </p:sp>
-    </p:spTree>
-  </p:cSld>
-  <p:clrMapOvr>
-    <a:masterClrMapping/>
-  </p:clrMapOvr>
-</p:sld>
-</file>
-
-<file path=ppt/slides/slide7.xml><?xml version="1.0" encoding="utf-8"?>
-<p:sld xmlns:a="http://schemas.openxmlformats.org/drawingml/2006/main" xmlns:p="http://schemas.openxmlformats.org/presentationml/2006/main" xmlns:r="http://schemas.openxmlformats.org/officeDocument/2006/relationships">
-  <p:cSld>
-    <p:bg>
-      <p:bgPr>
-        <a:solidFill>
-          <a:srgbClr val="070B14"/>
-        </a:solidFill>
-        <a:effectLst/>
-      </p:bgPr>
-    </p:bg>
-    <p:spTree>
-      <p:nvGrpSpPr>
-        <p:cNvPr id="1" name=""/>
-        <p:cNvGrpSpPr/>
-        <p:nvPr/>
-      </p:nvGrpSpPr>
-      <p:grpSpPr/>
-      <p:sp>
-        <p:nvSpPr>
-          <p:cNvPr id="2" name="Oval 1"/>
+              <a:t>Make one or two changes. Use Refine screen.</a:t>
+            </a:r>
+          </a:p>
+          <a:p>
+            <a:pPr>
+              <a:spcAft>
+                <a:spcPts val="1200"/>
+              </a:spcAft>
+            </a:pPr>
+            <a:r>
+              <a:rPr sz="2000">
+                <a:solidFill>
+                  <a:srgbClr val="1E1B2E"/>
+                </a:solidFill>
+                <a:latin typeface="Calibri"/>
+              </a:rPr>
+              <a:t>When all three are done, go back to Screen 1.</a:t>
+            </a:r>
+          </a:p>
+        </p:txBody>
+      </p:sp>
+      <p:sp>
+        <p:nvSpPr>
+          <p:cNvPr id="10" name="Rounded Rectangle 9"/>
           <p:cNvSpPr/>
           <p:nvPr/>
         </p:nvSpPr>
         <p:spPr>
           <a:xfrm>
-            <a:off x="-1097280" y="-1463040"/>
-            <a:ext cx="4754880" cy="4754880"/>
-          </a:xfrm>
-          <a:prstGeom prst="ellipse">
-            <a:avLst/>
+            <a:off x="7543800" y="1691640"/>
+            <a:ext cx="4160520" cy="4526280"/>
+          </a:xfrm>
+          <a:prstGeom prst="roundRect">
+            <a:avLst>
+              <a:gd name="adj" fmla="val 8000"/>
+            </a:avLst>
           </a:prstGeom>
           <a:solidFill>
-            <a:srgbClr val="DB0011">
-              <a:alpha val="38000"/>
+            <a:srgbClr val="FFFFFF">
+              <a:alpha val="92000"/>
             </a:srgbClr>
           </a:solidFill>
           <a:ln>
@@ -5840,104 +5869,14 @@
       </p:sp>
       <p:sp>
         <p:nvSpPr>
-          <p:cNvPr id="3" name="Oval 2"/>
-          <p:cNvSpPr/>
-          <p:nvPr/>
-        </p:nvSpPr>
-        <p:spPr>
-          <a:xfrm>
-            <a:off x="8595360" y="-1280160"/>
-            <a:ext cx="4206240" cy="4206240"/>
-          </a:xfrm>
-          <a:prstGeom prst="ellipse">
-            <a:avLst/>
-          </a:prstGeom>
-          <a:solidFill>
-            <a:srgbClr val="5A8CFF">
-              <a:alpha val="28000"/>
-            </a:srgbClr>
-          </a:solidFill>
-          <a:ln>
-            <a:noFill/>
-          </a:ln>
-        </p:spPr>
-        <p:style>
-          <a:lnRef idx="1">
-            <a:schemeClr val="accent1"/>
-          </a:lnRef>
-          <a:fillRef idx="3">
-            <a:schemeClr val="accent1"/>
-          </a:fillRef>
-          <a:effectRef idx="2">
-            <a:schemeClr val="accent1"/>
-          </a:effectRef>
-          <a:fontRef idx="minor">
-            <a:schemeClr val="lt1"/>
-          </a:fontRef>
-        </p:style>
-        <p:txBody>
-          <a:bodyPr rtlCol="0" anchor="ctr"/>
-          <a:lstStyle/>
-          <a:p>
-            <a:pPr algn="ctr"/>
-          </a:p>
-        </p:txBody>
-      </p:sp>
-      <p:sp>
-        <p:nvSpPr>
-          <p:cNvPr id="4" name="Oval 3"/>
-          <p:cNvSpPr/>
-          <p:nvPr/>
-        </p:nvSpPr>
-        <p:spPr>
-          <a:xfrm>
-            <a:off x="7863840" y="4389120"/>
-            <a:ext cx="3840480" cy="3840480"/>
-          </a:xfrm>
-          <a:prstGeom prst="ellipse">
-            <a:avLst/>
-          </a:prstGeom>
-          <a:solidFill>
-            <a:srgbClr val="50DCB4">
-              <a:alpha val="16000"/>
-            </a:srgbClr>
-          </a:solidFill>
-          <a:ln>
-            <a:noFill/>
-          </a:ln>
-        </p:spPr>
-        <p:style>
-          <a:lnRef idx="1">
-            <a:schemeClr val="accent1"/>
-          </a:lnRef>
-          <a:fillRef idx="3">
-            <a:schemeClr val="accent1"/>
-          </a:fillRef>
-          <a:effectRef idx="2">
-            <a:schemeClr val="accent1"/>
-          </a:effectRef>
-          <a:fontRef idx="minor">
-            <a:schemeClr val="lt1"/>
-          </a:fontRef>
-        </p:style>
-        <p:txBody>
-          <a:bodyPr rtlCol="0" anchor="ctr"/>
-          <a:lstStyle/>
-          <a:p>
-            <a:pPr algn="ctr"/>
-          </a:p>
-        </p:txBody>
-      </p:sp>
-      <p:sp>
-        <p:nvSpPr>
-          <p:cNvPr id="5" name="TextBox 4"/>
+          <p:cNvPr id="11" name="TextBox 10"/>
           <p:cNvSpPr txBox="1"/>
           <p:nvPr/>
         </p:nvSpPr>
         <p:spPr>
           <a:xfrm>
-            <a:off x="685800" y="502920"/>
-            <a:ext cx="10058400" cy="320040"/>
+            <a:off x="7772400" y="1874519"/>
+            <a:ext cx="3657600" cy="365760"/>
           </a:xfrm>
           <a:prstGeom prst="rect">
             <a:avLst/>
@@ -5950,796 +5889,13 @@
           <a:p>
             <a:pPr algn="l"/>
             <a:r>
-              <a:rPr sz="1400" b="1">
-                <a:solidFill>
-                  <a:srgbClr val="FFB4BC"/>
+              <a:rPr sz="2000" b="1">
+                <a:solidFill>
+                  <a:srgbClr val="6B4EFF"/>
                 </a:solidFill>
                 <a:latin typeface="Calibri"/>
               </a:rPr>
-              <a:t>STEP 3  ·  15 MINUTES</a:t>
-            </a:r>
-          </a:p>
-        </p:txBody>
-      </p:sp>
-      <p:sp>
-        <p:nvSpPr>
-          <p:cNvPr id="6" name="TextBox 5"/>
-          <p:cNvSpPr txBox="1"/>
-          <p:nvPr/>
-        </p:nvSpPr>
-        <p:spPr>
-          <a:xfrm>
-            <a:off x="685800" y="1051560"/>
-            <a:ext cx="10789920" cy="1920240"/>
-          </a:xfrm>
-          <a:prstGeom prst="rect">
-            <a:avLst/>
-          </a:prstGeom>
-          <a:noFill/>
-        </p:spPr>
-        <p:txBody>
-          <a:bodyPr wrap="square"/>
-          <a:lstStyle/>
-          <a:p>
-            <a:pPr algn="l"/>
-            <a:r>
-              <a:rPr sz="4800" b="1">
-                <a:solidFill>
-                  <a:srgbClr val="F4F7FB"/>
-                </a:solidFill>
-                <a:latin typeface="Calibri"/>
-              </a:rPr>
-              <a:t>Build the prototype.</a:t>
-            </a:r>
-          </a:p>
-        </p:txBody>
-      </p:sp>
-      <p:sp>
-        <p:nvSpPr>
-          <p:cNvPr id="7" name="TextBox 6"/>
-          <p:cNvSpPr txBox="1"/>
-          <p:nvPr/>
-        </p:nvSpPr>
-        <p:spPr>
-          <a:xfrm>
-            <a:off x="685800" y="3108960"/>
-            <a:ext cx="9692640" cy="1463040"/>
-          </a:xfrm>
-          <a:prstGeom prst="rect">
-            <a:avLst/>
-          </a:prstGeom>
-          <a:noFill/>
-        </p:spPr>
-        <p:txBody>
-          <a:bodyPr wrap="square"/>
-          <a:lstStyle/>
-          <a:p>
-            <a:pPr algn="l"/>
-            <a:r>
-              <a:rPr sz="2400" b="0">
-                <a:solidFill>
-                  <a:srgbClr val="B7C0D0"/>
-                </a:solidFill>
-                <a:latin typeface="Calibri"/>
-              </a:rPr>
-              <a:t>Generate it, then make one or two changes. That is enough. When the three screens are done, go back to Screen 1.</a:t>
-            </a:r>
-          </a:p>
-        </p:txBody>
-      </p:sp>
-    </p:spTree>
-  </p:cSld>
-  <p:clrMapOvr>
-    <a:masterClrMapping/>
-  </p:clrMapOvr>
-</p:sld>
-</file>
-
-<file path=ppt/slides/slide8.xml><?xml version="1.0" encoding="utf-8"?>
-<p:sld xmlns:a="http://schemas.openxmlformats.org/drawingml/2006/main" xmlns:p="http://schemas.openxmlformats.org/presentationml/2006/main" xmlns:r="http://schemas.openxmlformats.org/officeDocument/2006/relationships">
-  <p:cSld>
-    <p:bg>
-      <p:bgPr>
-        <a:solidFill>
-          <a:srgbClr val="070B14"/>
-        </a:solidFill>
-        <a:effectLst/>
-      </p:bgPr>
-    </p:bg>
-    <p:spTree>
-      <p:nvGrpSpPr>
-        <p:cNvPr id="1" name=""/>
-        <p:cNvGrpSpPr/>
-        <p:nvPr/>
-      </p:nvGrpSpPr>
-      <p:grpSpPr/>
-      <p:sp>
-        <p:nvSpPr>
-          <p:cNvPr id="2" name="Oval 1"/>
-          <p:cNvSpPr/>
-          <p:nvPr/>
-        </p:nvSpPr>
-        <p:spPr>
-          <a:xfrm>
-            <a:off x="-1097280" y="-1463040"/>
-            <a:ext cx="4754880" cy="4754880"/>
-          </a:xfrm>
-          <a:prstGeom prst="ellipse">
-            <a:avLst/>
-          </a:prstGeom>
-          <a:solidFill>
-            <a:srgbClr val="DB0011">
-              <a:alpha val="38000"/>
-            </a:srgbClr>
-          </a:solidFill>
-          <a:ln>
-            <a:noFill/>
-          </a:ln>
-        </p:spPr>
-        <p:style>
-          <a:lnRef idx="1">
-            <a:schemeClr val="accent1"/>
-          </a:lnRef>
-          <a:fillRef idx="3">
-            <a:schemeClr val="accent1"/>
-          </a:fillRef>
-          <a:effectRef idx="2">
-            <a:schemeClr val="accent1"/>
-          </a:effectRef>
-          <a:fontRef idx="minor">
-            <a:schemeClr val="lt1"/>
-          </a:fontRef>
-        </p:style>
-        <p:txBody>
-          <a:bodyPr rtlCol="0" anchor="ctr"/>
-          <a:lstStyle/>
-          <a:p>
-            <a:pPr algn="ctr"/>
-          </a:p>
-        </p:txBody>
-      </p:sp>
-      <p:sp>
-        <p:nvSpPr>
-          <p:cNvPr id="3" name="Oval 2"/>
-          <p:cNvSpPr/>
-          <p:nvPr/>
-        </p:nvSpPr>
-        <p:spPr>
-          <a:xfrm>
-            <a:off x="8595360" y="-1280160"/>
-            <a:ext cx="4206240" cy="4206240"/>
-          </a:xfrm>
-          <a:prstGeom prst="ellipse">
-            <a:avLst/>
-          </a:prstGeom>
-          <a:solidFill>
-            <a:srgbClr val="5A8CFF">
-              <a:alpha val="28000"/>
-            </a:srgbClr>
-          </a:solidFill>
-          <a:ln>
-            <a:noFill/>
-          </a:ln>
-        </p:spPr>
-        <p:style>
-          <a:lnRef idx="1">
-            <a:schemeClr val="accent1"/>
-          </a:lnRef>
-          <a:fillRef idx="3">
-            <a:schemeClr val="accent1"/>
-          </a:fillRef>
-          <a:effectRef idx="2">
-            <a:schemeClr val="accent1"/>
-          </a:effectRef>
-          <a:fontRef idx="minor">
-            <a:schemeClr val="lt1"/>
-          </a:fontRef>
-        </p:style>
-        <p:txBody>
-          <a:bodyPr rtlCol="0" anchor="ctr"/>
-          <a:lstStyle/>
-          <a:p>
-            <a:pPr algn="ctr"/>
-          </a:p>
-        </p:txBody>
-      </p:sp>
-      <p:sp>
-        <p:nvSpPr>
-          <p:cNvPr id="4" name="Oval 3"/>
-          <p:cNvSpPr/>
-          <p:nvPr/>
-        </p:nvSpPr>
-        <p:spPr>
-          <a:xfrm>
-            <a:off x="7863840" y="4389120"/>
-            <a:ext cx="3840480" cy="3840480"/>
-          </a:xfrm>
-          <a:prstGeom prst="ellipse">
-            <a:avLst/>
-          </a:prstGeom>
-          <a:solidFill>
-            <a:srgbClr val="50DCB4">
-              <a:alpha val="16000"/>
-            </a:srgbClr>
-          </a:solidFill>
-          <a:ln>
-            <a:noFill/>
-          </a:ln>
-        </p:spPr>
-        <p:style>
-          <a:lnRef idx="1">
-            <a:schemeClr val="accent1"/>
-          </a:lnRef>
-          <a:fillRef idx="3">
-            <a:schemeClr val="accent1"/>
-          </a:fillRef>
-          <a:effectRef idx="2">
-            <a:schemeClr val="accent1"/>
-          </a:effectRef>
-          <a:fontRef idx="minor">
-            <a:schemeClr val="lt1"/>
-          </a:fontRef>
-        </p:style>
-        <p:txBody>
-          <a:bodyPr rtlCol="0" anchor="ctr"/>
-          <a:lstStyle/>
-          <a:p>
-            <a:pPr algn="ctr"/>
-          </a:p>
-        </p:txBody>
-      </p:sp>
-      <p:sp>
-        <p:nvSpPr>
-          <p:cNvPr id="5" name="TextBox 4"/>
-          <p:cNvSpPr txBox="1"/>
-          <p:nvPr/>
-        </p:nvSpPr>
-        <p:spPr>
-          <a:xfrm>
-            <a:off x="685800" y="502920"/>
-            <a:ext cx="10058400" cy="320040"/>
-          </a:xfrm>
-          <a:prstGeom prst="rect">
-            <a:avLst/>
-          </a:prstGeom>
-          <a:noFill/>
-        </p:spPr>
-        <p:txBody>
-          <a:bodyPr wrap="square"/>
-          <a:lstStyle/>
-          <a:p>
-            <a:pPr algn="l"/>
-            <a:r>
-              <a:rPr sz="1400" b="1">
-                <a:solidFill>
-                  <a:srgbClr val="FFB4BC"/>
-                </a:solidFill>
-                <a:latin typeface="Calibri"/>
-              </a:rPr>
-              <a:t>THE PANEL ON THE RIGHT</a:t>
-            </a:r>
-          </a:p>
-        </p:txBody>
-      </p:sp>
-      <p:sp>
-        <p:nvSpPr>
-          <p:cNvPr id="6" name="TextBox 5"/>
-          <p:cNvSpPr txBox="1"/>
-          <p:nvPr/>
-        </p:nvSpPr>
-        <p:spPr>
-          <a:xfrm>
-            <a:off x="685800" y="1051560"/>
-            <a:ext cx="10789920" cy="1920240"/>
-          </a:xfrm>
-          <a:prstGeom prst="rect">
-            <a:avLst/>
-          </a:prstGeom>
-          <a:noFill/>
-        </p:spPr>
-        <p:txBody>
-          <a:bodyPr wrap="square"/>
-          <a:lstStyle/>
-          <a:p>
-            <a:pPr algn="l"/>
-            <a:r>
-              <a:rPr sz="4800" b="1">
-                <a:solidFill>
-                  <a:srgbClr val="F4F7FB"/>
-                </a:solidFill>
-                <a:latin typeface="Calibri"/>
-              </a:rPr>
-              <a:t>Use the AI assistant.</a:t>
-            </a:r>
-          </a:p>
-        </p:txBody>
-      </p:sp>
-      <p:sp>
-        <p:nvSpPr>
-          <p:cNvPr id="7" name="TextBox 6"/>
-          <p:cNvSpPr txBox="1"/>
-          <p:nvPr/>
-        </p:nvSpPr>
-        <p:spPr>
-          <a:xfrm>
-            <a:off x="685800" y="3017520"/>
-            <a:ext cx="9692640" cy="1463040"/>
-          </a:xfrm>
-          <a:prstGeom prst="rect">
-            <a:avLst/>
-          </a:prstGeom>
-          <a:noFill/>
-        </p:spPr>
-        <p:txBody>
-          <a:bodyPr wrap="square"/>
-          <a:lstStyle/>
-          <a:p>
-            <a:pPr algn="l"/>
-            <a:r>
-              <a:rPr sz="2400" b="0">
-                <a:solidFill>
-                  <a:srgbClr val="B7C0D0"/>
-                </a:solidFill>
-                <a:latin typeface="Calibri"/>
-              </a:rPr>
-              <a:t>Nothing written yet: Get some inspiration.
-Something already there: Refine.
-It changes only the box you selected.</a:t>
-            </a:r>
-          </a:p>
-        </p:txBody>
-      </p:sp>
-    </p:spTree>
-  </p:cSld>
-  <p:clrMapOvr>
-    <a:masterClrMapping/>
-  </p:clrMapOvr>
-</p:sld>
-</file>
-
-<file path=ppt/slides/slide9.xml><?xml version="1.0" encoding="utf-8"?>
-<p:sld xmlns:a="http://schemas.openxmlformats.org/drawingml/2006/main" xmlns:p="http://schemas.openxmlformats.org/presentationml/2006/main" xmlns:r="http://schemas.openxmlformats.org/officeDocument/2006/relationships">
-  <p:cSld>
-    <p:bg>
-      <p:bgPr>
-        <a:solidFill>
-          <a:srgbClr val="070B14"/>
-        </a:solidFill>
-        <a:effectLst/>
-      </p:bgPr>
-    </p:bg>
-    <p:spTree>
-      <p:nvGrpSpPr>
-        <p:cNvPr id="1" name=""/>
-        <p:cNvGrpSpPr/>
-        <p:nvPr/>
-      </p:nvGrpSpPr>
-      <p:grpSpPr/>
-      <p:sp>
-        <p:nvSpPr>
-          <p:cNvPr id="2" name="Oval 1"/>
-          <p:cNvSpPr/>
-          <p:nvPr/>
-        </p:nvSpPr>
-        <p:spPr>
-          <a:xfrm>
-            <a:off x="-1097280" y="-1463040"/>
-            <a:ext cx="4754880" cy="4754880"/>
-          </a:xfrm>
-          <a:prstGeom prst="ellipse">
-            <a:avLst/>
-          </a:prstGeom>
-          <a:solidFill>
-            <a:srgbClr val="DB0011">
-              <a:alpha val="38000"/>
-            </a:srgbClr>
-          </a:solidFill>
-          <a:ln>
-            <a:noFill/>
-          </a:ln>
-        </p:spPr>
-        <p:style>
-          <a:lnRef idx="1">
-            <a:schemeClr val="accent1"/>
-          </a:lnRef>
-          <a:fillRef idx="3">
-            <a:schemeClr val="accent1"/>
-          </a:fillRef>
-          <a:effectRef idx="2">
-            <a:schemeClr val="accent1"/>
-          </a:effectRef>
-          <a:fontRef idx="minor">
-            <a:schemeClr val="lt1"/>
-          </a:fontRef>
-        </p:style>
-        <p:txBody>
-          <a:bodyPr rtlCol="0" anchor="ctr"/>
-          <a:lstStyle/>
-          <a:p>
-            <a:pPr algn="ctr"/>
-          </a:p>
-        </p:txBody>
-      </p:sp>
-      <p:sp>
-        <p:nvSpPr>
-          <p:cNvPr id="3" name="Oval 2"/>
-          <p:cNvSpPr/>
-          <p:nvPr/>
-        </p:nvSpPr>
-        <p:spPr>
-          <a:xfrm>
-            <a:off x="8595360" y="-1280160"/>
-            <a:ext cx="4206240" cy="4206240"/>
-          </a:xfrm>
-          <a:prstGeom prst="ellipse">
-            <a:avLst/>
-          </a:prstGeom>
-          <a:solidFill>
-            <a:srgbClr val="5A8CFF">
-              <a:alpha val="28000"/>
-            </a:srgbClr>
-          </a:solidFill>
-          <a:ln>
-            <a:noFill/>
-          </a:ln>
-        </p:spPr>
-        <p:style>
-          <a:lnRef idx="1">
-            <a:schemeClr val="accent1"/>
-          </a:lnRef>
-          <a:fillRef idx="3">
-            <a:schemeClr val="accent1"/>
-          </a:fillRef>
-          <a:effectRef idx="2">
-            <a:schemeClr val="accent1"/>
-          </a:effectRef>
-          <a:fontRef idx="minor">
-            <a:schemeClr val="lt1"/>
-          </a:fontRef>
-        </p:style>
-        <p:txBody>
-          <a:bodyPr rtlCol="0" anchor="ctr"/>
-          <a:lstStyle/>
-          <a:p>
-            <a:pPr algn="ctr"/>
-          </a:p>
-        </p:txBody>
-      </p:sp>
-      <p:sp>
-        <p:nvSpPr>
-          <p:cNvPr id="4" name="Oval 3"/>
-          <p:cNvSpPr/>
-          <p:nvPr/>
-        </p:nvSpPr>
-        <p:spPr>
-          <a:xfrm>
-            <a:off x="7863840" y="4389120"/>
-            <a:ext cx="3840480" cy="3840480"/>
-          </a:xfrm>
-          <a:prstGeom prst="ellipse">
-            <a:avLst/>
-          </a:prstGeom>
-          <a:solidFill>
-            <a:srgbClr val="50DCB4">
-              <a:alpha val="16000"/>
-            </a:srgbClr>
-          </a:solidFill>
-          <a:ln>
-            <a:noFill/>
-          </a:ln>
-        </p:spPr>
-        <p:style>
-          <a:lnRef idx="1">
-            <a:schemeClr val="accent1"/>
-          </a:lnRef>
-          <a:fillRef idx="3">
-            <a:schemeClr val="accent1"/>
-          </a:fillRef>
-          <a:effectRef idx="2">
-            <a:schemeClr val="accent1"/>
-          </a:effectRef>
-          <a:fontRef idx="minor">
-            <a:schemeClr val="lt1"/>
-          </a:fontRef>
-        </p:style>
-        <p:txBody>
-          <a:bodyPr rtlCol="0" anchor="ctr"/>
-          <a:lstStyle/>
-          <a:p>
-            <a:pPr algn="ctr"/>
-          </a:p>
-        </p:txBody>
-      </p:sp>
-      <p:sp>
-        <p:nvSpPr>
-          <p:cNvPr id="5" name="TextBox 4"/>
-          <p:cNvSpPr txBox="1"/>
-          <p:nvPr/>
-        </p:nvSpPr>
-        <p:spPr>
-          <a:xfrm>
-            <a:off x="685800" y="502920"/>
-            <a:ext cx="10058400" cy="320040"/>
-          </a:xfrm>
-          <a:prstGeom prst="rect">
-            <a:avLst/>
-          </a:prstGeom>
-          <a:noFill/>
-        </p:spPr>
-        <p:txBody>
-          <a:bodyPr wrap="square"/>
-          <a:lstStyle/>
-          <a:p>
-            <a:pPr algn="l"/>
-            <a:r>
-              <a:rPr sz="1400" b="1">
-                <a:solidFill>
-                  <a:srgbClr val="FFB4BC"/>
-                </a:solidFill>
-                <a:latin typeface="Calibri"/>
-              </a:rPr>
-              <a:t>90 SECONDS</a:t>
-            </a:r>
-          </a:p>
-        </p:txBody>
-      </p:sp>
-      <p:sp>
-        <p:nvSpPr>
-          <p:cNvPr id="6" name="TextBox 5"/>
-          <p:cNvSpPr txBox="1"/>
-          <p:nvPr/>
-        </p:nvSpPr>
-        <p:spPr>
-          <a:xfrm>
-            <a:off x="685800" y="868680"/>
-            <a:ext cx="10789920" cy="1920240"/>
-          </a:xfrm>
-          <a:prstGeom prst="rect">
-            <a:avLst/>
-          </a:prstGeom>
-          <a:noFill/>
-        </p:spPr>
-        <p:txBody>
-          <a:bodyPr wrap="square"/>
-          <a:lstStyle/>
-          <a:p>
-            <a:pPr algn="l"/>
-            <a:r>
-              <a:rPr sz="4000" b="1">
-                <a:solidFill>
-                  <a:srgbClr val="F4F7FB"/>
-                </a:solidFill>
-                <a:latin typeface="Calibri"/>
-              </a:rPr>
-              <a:t>Present to the room.</a:t>
-            </a:r>
-          </a:p>
-        </p:txBody>
-      </p:sp>
-      <p:sp>
-        <p:nvSpPr>
-          <p:cNvPr id="7" name="Rounded Rectangle 6"/>
-          <p:cNvSpPr/>
-          <p:nvPr/>
-        </p:nvSpPr>
-        <p:spPr>
-          <a:xfrm>
-            <a:off x="685800" y="2148840"/>
-            <a:ext cx="566928" cy="566928"/>
-          </a:xfrm>
-          <a:prstGeom prst="roundRect">
-            <a:avLst>
-              <a:gd name="adj" fmla="val 20000"/>
-            </a:avLst>
-          </a:prstGeom>
-          <a:solidFill>
-            <a:srgbClr val="DB0011"/>
-          </a:solidFill>
-          <a:ln>
-            <a:noFill/>
-          </a:ln>
-        </p:spPr>
-        <p:style>
-          <a:lnRef idx="1">
-            <a:schemeClr val="accent1"/>
-          </a:lnRef>
-          <a:fillRef idx="3">
-            <a:schemeClr val="accent1"/>
-          </a:fillRef>
-          <a:effectRef idx="2">
-            <a:schemeClr val="accent1"/>
-          </a:effectRef>
-          <a:fontRef idx="minor">
-            <a:schemeClr val="lt1"/>
-          </a:fontRef>
-        </p:style>
-        <p:txBody>
-          <a:bodyPr rtlCol="0" anchor="ctr" wrap="none"/>
-          <a:lstStyle/>
-          <a:p>
-            <a:pPr algn="ctr"/>
-            <a:r>
-              <a:rPr sz="2000" b="1">
-                <a:solidFill>
-                  <a:srgbClr val="F4F7FB"/>
-                </a:solidFill>
-                <a:latin typeface="Calibri"/>
-              </a:rPr>
-              <a:t>1</a:t>
-            </a:r>
-          </a:p>
-        </p:txBody>
-      </p:sp>
-      <p:sp>
-        <p:nvSpPr>
-          <p:cNvPr id="8" name="TextBox 7"/>
-          <p:cNvSpPr txBox="1"/>
-          <p:nvPr/>
-        </p:nvSpPr>
-        <p:spPr>
-          <a:xfrm>
-            <a:off x="1463040" y="2221992"/>
-            <a:ext cx="9601200" cy="457200"/>
-          </a:xfrm>
-          <a:prstGeom prst="rect">
-            <a:avLst/>
-          </a:prstGeom>
-          <a:noFill/>
-        </p:spPr>
-        <p:txBody>
-          <a:bodyPr wrap="square"/>
-          <a:lstStyle/>
-          <a:p>
-            <a:pPr algn="l"/>
-            <a:r>
-              <a:rPr sz="2600" b="0">
-                <a:solidFill>
-                  <a:srgbClr val="F4F7FB"/>
-                </a:solidFill>
-                <a:latin typeface="Calibri"/>
-              </a:rPr>
-              <a:t>Your group painpoint</a:t>
-            </a:r>
-          </a:p>
-        </p:txBody>
-      </p:sp>
-      <p:sp>
-        <p:nvSpPr>
-          <p:cNvPr id="9" name="Rounded Rectangle 8"/>
-          <p:cNvSpPr/>
-          <p:nvPr/>
-        </p:nvSpPr>
-        <p:spPr>
-          <a:xfrm>
-            <a:off x="685800" y="3108960"/>
-            <a:ext cx="566928" cy="566928"/>
-          </a:xfrm>
-          <a:prstGeom prst="roundRect">
-            <a:avLst>
-              <a:gd name="adj" fmla="val 20000"/>
-            </a:avLst>
-          </a:prstGeom>
-          <a:solidFill>
-            <a:srgbClr val="DB0011"/>
-          </a:solidFill>
-          <a:ln>
-            <a:noFill/>
-          </a:ln>
-        </p:spPr>
-        <p:style>
-          <a:lnRef idx="1">
-            <a:schemeClr val="accent1"/>
-          </a:lnRef>
-          <a:fillRef idx="3">
-            <a:schemeClr val="accent1"/>
-          </a:fillRef>
-          <a:effectRef idx="2">
-            <a:schemeClr val="accent1"/>
-          </a:effectRef>
-          <a:fontRef idx="minor">
-            <a:schemeClr val="lt1"/>
-          </a:fontRef>
-        </p:style>
-        <p:txBody>
-          <a:bodyPr rtlCol="0" anchor="ctr" wrap="none"/>
-          <a:lstStyle/>
-          <a:p>
-            <a:pPr algn="ctr"/>
-            <a:r>
-              <a:rPr sz="2000" b="1">
-                <a:solidFill>
-                  <a:srgbClr val="F4F7FB"/>
-                </a:solidFill>
-                <a:latin typeface="Calibri"/>
-              </a:rPr>
-              <a:t>2</a:t>
-            </a:r>
-          </a:p>
-        </p:txBody>
-      </p:sp>
-      <p:sp>
-        <p:nvSpPr>
-          <p:cNvPr id="10" name="TextBox 9"/>
-          <p:cNvSpPr txBox="1"/>
-          <p:nvPr/>
-        </p:nvSpPr>
-        <p:spPr>
-          <a:xfrm>
-            <a:off x="1463040" y="3182112"/>
-            <a:ext cx="9601200" cy="457200"/>
-          </a:xfrm>
-          <a:prstGeom prst="rect">
-            <a:avLst/>
-          </a:prstGeom>
-          <a:noFill/>
-        </p:spPr>
-        <p:txBody>
-          <a:bodyPr wrap="square"/>
-          <a:lstStyle/>
-          <a:p>
-            <a:pPr algn="l"/>
-            <a:r>
-              <a:rPr sz="2600" b="0">
-                <a:solidFill>
-                  <a:srgbClr val="F4F7FB"/>
-                </a:solidFill>
-                <a:latin typeface="Calibri"/>
-              </a:rPr>
-              <a:t>Your agent idea</a:t>
-            </a:r>
-          </a:p>
-        </p:txBody>
-      </p:sp>
-      <p:sp>
-        <p:nvSpPr>
-          <p:cNvPr id="11" name="Rounded Rectangle 10"/>
-          <p:cNvSpPr/>
-          <p:nvPr/>
-        </p:nvSpPr>
-        <p:spPr>
-          <a:xfrm>
-            <a:off x="685800" y="4069080"/>
-            <a:ext cx="566928" cy="566928"/>
-          </a:xfrm>
-          <a:prstGeom prst="roundRect">
-            <a:avLst>
-              <a:gd name="adj" fmla="val 20000"/>
-            </a:avLst>
-          </a:prstGeom>
-          <a:solidFill>
-            <a:srgbClr val="DB0011"/>
-          </a:solidFill>
-          <a:ln>
-            <a:noFill/>
-          </a:ln>
-        </p:spPr>
-        <p:style>
-          <a:lnRef idx="1">
-            <a:schemeClr val="accent1"/>
-          </a:lnRef>
-          <a:fillRef idx="3">
-            <a:schemeClr val="accent1"/>
-          </a:fillRef>
-          <a:effectRef idx="2">
-            <a:schemeClr val="accent1"/>
-          </a:effectRef>
-          <a:fontRef idx="minor">
-            <a:schemeClr val="lt1"/>
-          </a:fontRef>
-        </p:style>
-        <p:txBody>
-          <a:bodyPr rtlCol="0" anchor="ctr" wrap="none"/>
-          <a:lstStyle/>
-          <a:p>
-            <a:pPr algn="ctr"/>
-            <a:r>
-              <a:rPr sz="2000" b="1">
-                <a:solidFill>
-                  <a:srgbClr val="F4F7FB"/>
-                </a:solidFill>
-                <a:latin typeface="Calibri"/>
-              </a:rPr>
-              <a:t>3</a:t>
+              <a:t>90 seconds</a:t>
             </a:r>
           </a:p>
         </p:txBody>
@@ -6752,8 +5908,8 @@
         </p:nvSpPr>
         <p:spPr>
           <a:xfrm>
-            <a:off x="1463040" y="4142232"/>
-            <a:ext cx="9601200" cy="457200"/>
+            <a:off x="7772400" y="2468880"/>
+            <a:ext cx="3657600" cy="2926080"/>
           </a:xfrm>
           <a:prstGeom prst="rect">
             <a:avLst/>
@@ -6761,105 +5917,72 @@
           <a:noFill/>
         </p:spPr>
         <p:txBody>
-          <a:bodyPr wrap="square"/>
-          <a:lstStyle/>
-          <a:p>
-            <a:pPr algn="l"/>
-            <a:r>
-              <a:rPr sz="2600" b="0">
-                <a:solidFill>
-                  <a:srgbClr val="F4F7FB"/>
+          <a:bodyPr wrap="square">
+            <a:spAutoFit/>
+          </a:bodyPr>
+          <a:lstStyle/>
+          <a:p>
+            <a:pPr>
+              <a:spcAft>
+                <a:spcPts val="1400"/>
+              </a:spcAft>
+            </a:pPr>
+            <a:r>
+              <a:rPr sz="2200">
+                <a:solidFill>
+                  <a:srgbClr val="1E1B2E"/>
                 </a:solidFill>
                 <a:latin typeface="Calibri"/>
               </a:rPr>
-              <a:t>Walk through the prototype</a:t>
-            </a:r>
-          </a:p>
-        </p:txBody>
-      </p:sp>
-      <p:sp>
-        <p:nvSpPr>
-          <p:cNvPr id="13" name="Rounded Rectangle 12"/>
-          <p:cNvSpPr/>
-          <p:nvPr/>
-        </p:nvSpPr>
-        <p:spPr>
-          <a:xfrm>
-            <a:off x="685800" y="5029200"/>
-            <a:ext cx="566928" cy="566928"/>
-          </a:xfrm>
-          <a:prstGeom prst="roundRect">
-            <a:avLst>
-              <a:gd name="adj" fmla="val 20000"/>
-            </a:avLst>
-          </a:prstGeom>
-          <a:solidFill>
-            <a:srgbClr val="DB0011"/>
-          </a:solidFill>
-          <a:ln>
-            <a:noFill/>
-          </a:ln>
-        </p:spPr>
-        <p:style>
-          <a:lnRef idx="1">
-            <a:schemeClr val="accent1"/>
-          </a:lnRef>
-          <a:fillRef idx="3">
-            <a:schemeClr val="accent1"/>
-          </a:fillRef>
-          <a:effectRef idx="2">
-            <a:schemeClr val="accent1"/>
-          </a:effectRef>
-          <a:fontRef idx="minor">
-            <a:schemeClr val="lt1"/>
-          </a:fontRef>
-        </p:style>
-        <p:txBody>
-          <a:bodyPr rtlCol="0" anchor="ctr" wrap="none"/>
-          <a:lstStyle/>
-          <a:p>
-            <a:pPr algn="ctr"/>
-            <a:r>
-              <a:rPr sz="2000" b="1">
-                <a:solidFill>
-                  <a:srgbClr val="F4F7FB"/>
+              <a:t>1  Your painpoint</a:t>
+            </a:r>
+          </a:p>
+          <a:p>
+            <a:pPr>
+              <a:spcAft>
+                <a:spcPts val="1400"/>
+              </a:spcAft>
+            </a:pPr>
+            <a:r>
+              <a:rPr sz="2200">
+                <a:solidFill>
+                  <a:srgbClr val="1E1B2E"/>
                 </a:solidFill>
                 <a:latin typeface="Calibri"/>
               </a:rPr>
-              <a:t>4</a:t>
-            </a:r>
-          </a:p>
-        </p:txBody>
-      </p:sp>
-      <p:sp>
-        <p:nvSpPr>
-          <p:cNvPr id="14" name="TextBox 13"/>
-          <p:cNvSpPr txBox="1"/>
-          <p:nvPr/>
-        </p:nvSpPr>
-        <p:spPr>
-          <a:xfrm>
-            <a:off x="1463040" y="5102352"/>
-            <a:ext cx="9601200" cy="457200"/>
-          </a:xfrm>
-          <a:prstGeom prst="rect">
-            <a:avLst/>
-          </a:prstGeom>
-          <a:noFill/>
-        </p:spPr>
-        <p:txBody>
-          <a:bodyPr wrap="square"/>
-          <a:lstStyle/>
-          <a:p>
-            <a:pPr algn="l"/>
-            <a:r>
-              <a:rPr sz="2600" b="0">
-                <a:solidFill>
-                  <a:srgbClr val="F4F7FB"/>
+              <a:t>2  Your agent idea</a:t>
+            </a:r>
+          </a:p>
+          <a:p>
+            <a:pPr>
+              <a:spcAft>
+                <a:spcPts val="1400"/>
+              </a:spcAft>
+            </a:pPr>
+            <a:r>
+              <a:rPr sz="2200">
+                <a:solidFill>
+                  <a:srgbClr val="1E1B2E"/>
                 </a:solidFill>
                 <a:latin typeface="Calibri"/>
               </a:rPr>
-              <a:t>The key benefit, as the close</a:t>
+              <a:t>3  Walk the prototype</a:t>
+            </a:r>
+          </a:p>
+          <a:p>
+            <a:pPr>
+              <a:spcAft>
+                <a:spcPts val="1400"/>
+              </a:spcAft>
+            </a:pPr>
+            <a:r>
+              <a:rPr sz="2200">
+                <a:solidFill>
+                  <a:srgbClr val="1E1B2E"/>
+                </a:solidFill>
+                <a:latin typeface="Calibri"/>
+              </a:rPr>
+              <a:t>4  The key benefit</a:t>
             </a:r>
           </a:p>
         </p:txBody>

</xml_diff>

<commit_message>
Redraw the cover as the activity concept, not the timetable.
</commit_message>
<xml_diff>
--- a/docs/Wealth-Symposium-Activity.pptx
+++ b/docs/Wealth-Symposium-Activity.pptx
@@ -351,7 +351,7 @@
             <a:pPr/>
             <a:r>
               <a:rPr lang="en" dirty="0"/>
-              <a:t>Welcome them, then say we will demo one round together. After that, every group does the same thing on their own laptop. Point to the four times on the right so they can see the half hour before you open the tool.</a:t>
+              <a:t>Welcome them with the idea, not the timetable. The half hour turns a pain the group actually feels into an assistant they direct, and then into something they can stand up and show. Say you will demo one round, and then every group does the same thing. The times are on the next slide.</a:t>
             </a:r>
           </a:p>
         </p:txBody>
@@ -1192,16 +1192,16 @@
       </p:grpSpPr>
       <p:grpSp>
         <p:nvGrpSpPr>
-          <p:cNvPr id="7" name="title-block"/>
+          <p:cNvPr id="5" name="title-block"/>
           <p:cNvGrpSpPr/>
           <p:nvPr/>
         </p:nvGrpSpPr>
         <p:grpSpPr>
           <a:xfrm>
-            <a:off x="594360" y="1860550"/>
-            <a:ext cx="4701946" cy="2752344"/>
-            <a:chOff x="594360" y="1860550"/>
-            <a:chExt cx="4701946" cy="2752344"/>
+            <a:off x="518160" y="355600"/>
+            <a:ext cx="4134960" cy="1248918"/>
+            <a:chOff x="518160" y="355600"/>
+            <a:chExt cx="4134960" cy="1248918"/>
           </a:xfrm>
         </p:grpSpPr>
         <p:sp>
@@ -1212,7 +1212,7 @@
           </p:nvSpPr>
           <p:spPr>
             <a:xfrm>
-              <a:off x="603504" y="1860550"/>
+              <a:off x="527304" y="355600"/>
               <a:ext cx="1568150" cy="234696"/>
             </a:xfrm>
             <a:prstGeom prst="rect">
@@ -1252,8 +1252,8 @@
           </p:nvSpPr>
           <p:spPr>
             <a:xfrm>
-              <a:off x="594360" y="2406650"/>
-              <a:ext cx="2116807" cy="586740"/>
+              <a:off x="518160" y="673100"/>
+              <a:ext cx="4134960" cy="586740"/>
             </a:xfrm>
             <a:prstGeom prst="rect">
               <a:avLst/>
@@ -1279,7 +1279,7 @@
                   <a:ea typeface="+mn-ea"/>
                   <a:cs typeface="+mn-cs"/>
                 </a:rPr>
-                <a:t>AI Powered,</a:t>
+                <a:t>AI Powered, Human Led</a:t>
               </a:r>
             </a:p>
           </p:txBody>
@@ -1292,47 +1292,7 @@
           </p:nvSpPr>
           <p:spPr>
             <a:xfrm>
-              <a:off x="594360" y="2901950"/>
-              <a:ext cx="1955605" cy="586740"/>
-            </a:xfrm>
-            <a:prstGeom prst="rect">
-              <a:avLst/>
-            </a:prstGeom>
-            <a:noFill/>
-            <a:ln>
-              <a:noFill/>
-            </a:ln>
-          </p:spPr>
-          <p:txBody>
-            <a:bodyPr wrap="none" lIns="0" tIns="0" rIns="0" bIns="0" anchor="t" anchorCtr="0">
-              <a:spAutoFit/>
-            </a:bodyPr>
-            <a:lstStyle/>
-            <a:p>
-              <a:pPr algn="l"/>
-              <a:r>
-                <a:rPr lang="en" sz="3000" b="1" dirty="0">
-                  <a:solidFill>
-                    <a:schemeClr val="dk1"/>
-                  </a:solidFill>
-                  <a:latin typeface="+mn-lt"/>
-                  <a:ea typeface="+mn-ea"/>
-                  <a:cs typeface="+mn-cs"/>
-                </a:rPr>
-                <a:t>Human Led</a:t>
-              </a:r>
-            </a:p>
-          </p:txBody>
-        </p:sp>
-        <p:sp>
-          <p:nvSpPr>
-            <p:cNvPr id="5" name="TextBox 5"/>
-            <p:cNvSpPr txBox="1"/>
-            <p:nvPr/>
-          </p:nvSpPr>
-          <p:spPr>
-            <a:xfrm>
-              <a:off x="598932" y="3651250"/>
+              <a:off x="522732" y="1193800"/>
               <a:ext cx="2064585" cy="410718"/>
             </a:xfrm>
             <a:prstGeom prst="rect">
@@ -1364,75 +1324,35 @@
             </a:p>
           </p:txBody>
         </p:sp>
-        <p:sp>
-          <p:nvSpPr>
-            <p:cNvPr id="6" name="TextBox 6"/>
-            <p:cNvSpPr txBox="1"/>
-            <p:nvPr/>
-          </p:nvSpPr>
-          <p:spPr>
-            <a:xfrm>
-              <a:off x="600456" y="4260850"/>
-              <a:ext cx="4695850" cy="352044"/>
-            </a:xfrm>
-            <a:prstGeom prst="rect">
-              <a:avLst/>
-            </a:prstGeom>
-            <a:noFill/>
-            <a:ln>
-              <a:noFill/>
-            </a:ln>
-          </p:spPr>
-          <p:txBody>
-            <a:bodyPr wrap="none" lIns="0" tIns="0" rIns="0" bIns="0" anchor="t" anchorCtr="0">
-              <a:spAutoFit/>
-            </a:bodyPr>
-            <a:lstStyle/>
-            <a:p>
-              <a:pPr algn="l"/>
-              <a:r>
-                <a:rPr lang="en" sz="1800" dirty="0">
-                  <a:solidFill>
-                    <a:schemeClr val="dk1"/>
-                  </a:solidFill>
-                  <a:latin typeface="+mn-lt"/>
-                  <a:ea typeface="+mn-ea"/>
-                  <a:cs typeface="+mn-cs"/>
-                </a:rPr>
-                <a:t>We demo one round. Then every group does it.</a:t>
-              </a:r>
-            </a:p>
-          </p:txBody>
-        </p:sp>
       </p:grpSp>
       <p:grpSp>
         <p:nvGrpSpPr>
-          <p:cNvPr id="36" name="journey"/>
+          <p:cNvPr id="36" name="transformation"/>
           <p:cNvGrpSpPr/>
           <p:nvPr/>
         </p:nvGrpSpPr>
         <p:grpSpPr>
           <a:xfrm>
-            <a:off x="7620000" y="1485900"/>
-            <a:ext cx="3790950" cy="3714750"/>
-            <a:chOff x="7620000" y="1485900"/>
-            <a:chExt cx="3790950" cy="3714750"/>
+            <a:off x="533400" y="2000250"/>
+            <a:ext cx="11182350" cy="3276600"/>
+            <a:chOff x="533400" y="2000250"/>
+            <a:chExt cx="11182350" cy="3276600"/>
           </a:xfrm>
         </p:grpSpPr>
         <p:sp>
           <p:nvSpPr>
-            <p:cNvPr id="8" name="Rectangle 8"/>
+            <p:cNvPr id="6" name="Rectangle 6"/>
             <p:cNvSpPr/>
             <p:nvPr/>
           </p:nvSpPr>
           <p:spPr>
             <a:xfrm>
-              <a:off x="7696200" y="1600200"/>
-              <a:ext cx="3714750" cy="742950"/>
+              <a:off x="628650" y="2133600"/>
+              <a:ext cx="3238500" cy="3143250"/>
             </a:xfrm>
             <a:prstGeom prst="roundRect">
               <a:avLst>
-                <a:gd name="adj" fmla="val 28205"/>
+                <a:gd name="adj" fmla="val 6667"/>
               </a:avLst>
             </a:prstGeom>
             <a:solidFill>
@@ -1447,18 +1367,18 @@
         </p:sp>
         <p:sp>
           <p:nvSpPr>
-            <p:cNvPr id="9" name="Rectangle 9"/>
+            <p:cNvPr id="7" name="Rectangle 7"/>
             <p:cNvSpPr/>
             <p:nvPr/>
           </p:nvSpPr>
           <p:spPr>
             <a:xfrm>
-              <a:off x="7620000" y="1485900"/>
-              <a:ext cx="3714750" cy="742950"/>
+              <a:off x="533400" y="2000250"/>
+              <a:ext cx="3238500" cy="3143250"/>
             </a:xfrm>
             <a:prstGeom prst="roundRect">
               <a:avLst>
-                <a:gd name="adj" fmla="val 28205"/>
+                <a:gd name="adj" fmla="val 6667"/>
               </a:avLst>
             </a:prstGeom>
             <a:solidFill>
@@ -1478,28 +1398,28 @@
         </p:sp>
         <p:grpSp>
           <p:nvGrpSpPr>
-            <p:cNvPr id="12" name="Group 12"/>
+            <p:cNvPr id="10" name="Group 10"/>
             <p:cNvGrpSpPr/>
             <p:nvPr/>
           </p:nvGrpSpPr>
           <p:grpSpPr>
             <a:xfrm>
-              <a:off x="7848005" y="1719858"/>
-              <a:ext cx="325040" cy="275034"/>
-              <a:chOff x="7848005" y="1719858"/>
-              <a:chExt cx="325040" cy="275034"/>
+              <a:off x="1809750" y="2343150"/>
+              <a:ext cx="495300" cy="419100"/>
+              <a:chOff x="1809750" y="2343150"/>
+              <a:chExt cx="495300" cy="419100"/>
             </a:xfrm>
           </p:grpSpPr>
           <p:sp>
             <p:nvSpPr>
-              <p:cNvPr id="10" name="Freeform 10"/>
+              <p:cNvPr id="8" name="Freeform 8"/>
               <p:cNvSpPr/>
               <p:nvPr/>
             </p:nvSpPr>
             <p:spPr>
               <a:xfrm>
-                <a:off x="7860506" y="1782365"/>
-                <a:ext cx="250030" cy="200024"/>
+                <a:off x="1828800" y="2438400"/>
+                <a:ext cx="381000" cy="304800"/>
               </a:xfrm>
               <a:custGeom>
                 <a:avLst/>
@@ -1508,41 +1428,41 @@
                 <a:cxnLst/>
                 <a:rect l="l" t="t" r="r" b="b"/>
                 <a:pathLst>
-                  <a:path w="250030" h="200024">
+                  <a:path w="381000" h="304800">
                     <a:moveTo>
-                      <a:pt x="250030" y="12502"/>
+                      <a:pt x="381000" y="19050"/>
                     </a:moveTo>
                     <a:lnTo>
-                      <a:pt x="250030" y="187523"/>
-                    </a:lnTo>
-                    <a:cubicBezTo>
-                      <a:pt x="250030" y="194427"/>
-                      <a:pt x="244433" y="200024"/>
-                      <a:pt x="237529" y="200024"/>
-                    </a:cubicBezTo>
-                    <a:lnTo>
-                      <a:pt x="12502" y="200024"/>
-                    </a:lnTo>
-                    <a:cubicBezTo>
-                      <a:pt x="5597" y="200024"/>
-                      <a:pt x="0" y="194427"/>
-                      <a:pt x="0" y="187523"/>
-                    </a:cubicBezTo>
-                    <a:lnTo>
-                      <a:pt x="0" y="12502"/>
-                    </a:lnTo>
-                    <a:cubicBezTo>
-                      <a:pt x="0" y="5597"/>
-                      <a:pt x="5597" y="0"/>
-                      <a:pt x="12502" y="0"/>
-                    </a:cubicBezTo>
-                    <a:lnTo>
-                      <a:pt x="237529" y="0"/>
-                    </a:lnTo>
-                    <a:cubicBezTo>
-                      <a:pt x="244433" y="0"/>
-                      <a:pt x="250030" y="5597"/>
-                      <a:pt x="250030" y="12502"/>
+                      <a:pt x="381000" y="285750"/>
+                    </a:lnTo>
+                    <a:cubicBezTo>
+                      <a:pt x="381000" y="296271"/>
+                      <a:pt x="372471" y="304800"/>
+                      <a:pt x="361950" y="304800"/>
+                    </a:cubicBezTo>
+                    <a:lnTo>
+                      <a:pt x="19050" y="304800"/>
+                    </a:lnTo>
+                    <a:cubicBezTo>
+                      <a:pt x="8529" y="304800"/>
+                      <a:pt x="0" y="296271"/>
+                      <a:pt x="0" y="285750"/>
+                    </a:cubicBezTo>
+                    <a:lnTo>
+                      <a:pt x="0" y="19050"/>
+                    </a:lnTo>
+                    <a:cubicBezTo>
+                      <a:pt x="0" y="8529"/>
+                      <a:pt x="8529" y="0"/>
+                      <a:pt x="19050" y="0"/>
+                    </a:cubicBezTo>
+                    <a:lnTo>
+                      <a:pt x="361950" y="0"/>
+                    </a:lnTo>
+                    <a:cubicBezTo>
+                      <a:pt x="372471" y="0"/>
+                      <a:pt x="381000" y="8529"/>
+                      <a:pt x="381000" y="19050"/>
                     </a:cubicBezTo>
                     <a:close/>
                   </a:path>
@@ -1560,14 +1480,14 @@
           </p:sp>
           <p:sp>
             <p:nvSpPr>
-              <p:cNvPr id="11" name="Freeform 11"/>
+              <p:cNvPr id="9" name="Freeform 9"/>
               <p:cNvSpPr/>
               <p:nvPr/>
             </p:nvSpPr>
             <p:spPr>
               <a:xfrm>
-                <a:off x="7848005" y="1719858"/>
-                <a:ext cx="325040" cy="275034"/>
+                <a:off x="1809750" y="2343150"/>
+                <a:ext cx="495300" cy="419100"/>
               </a:xfrm>
               <a:custGeom>
                 <a:avLst/>
@@ -1576,98 +1496,98 @@
                 <a:cxnLst/>
                 <a:rect l="l" t="t" r="r" b="b"/>
                 <a:pathLst>
-                  <a:path w="325040" h="275034">
+                  <a:path w="495300" h="419100">
                     <a:moveTo>
-                      <a:pt x="250030" y="50006"/>
+                      <a:pt x="381000" y="76200"/>
                     </a:moveTo>
                     <a:lnTo>
-                      <a:pt x="25003" y="50006"/>
-                    </a:lnTo>
-                    <a:cubicBezTo>
-                      <a:pt x="11194" y="50006"/>
-                      <a:pt x="0" y="61200"/>
-                      <a:pt x="0" y="75009"/>
-                    </a:cubicBezTo>
-                    <a:lnTo>
-                      <a:pt x="0" y="250030"/>
-                    </a:lnTo>
-                    <a:cubicBezTo>
-                      <a:pt x="0" y="263839"/>
-                      <a:pt x="11194" y="275034"/>
-                      <a:pt x="25003" y="275034"/>
-                    </a:cubicBezTo>
-                    <a:lnTo>
-                      <a:pt x="250030" y="275034"/>
-                    </a:lnTo>
-                    <a:cubicBezTo>
-                      <a:pt x="263839" y="275034"/>
-                      <a:pt x="275034" y="263839"/>
-                      <a:pt x="275034" y="250030"/>
-                    </a:cubicBezTo>
-                    <a:lnTo>
-                      <a:pt x="275034" y="75009"/>
-                    </a:lnTo>
-                    <a:cubicBezTo>
-                      <a:pt x="275034" y="61200"/>
-                      <a:pt x="263839" y="50006"/>
-                      <a:pt x="250030" y="50006"/>
+                      <a:pt x="38100" y="76200"/>
+                    </a:lnTo>
+                    <a:cubicBezTo>
+                      <a:pt x="17058" y="76200"/>
+                      <a:pt x="0" y="93258"/>
+                      <a:pt x="0" y="114300"/>
+                    </a:cubicBezTo>
+                    <a:lnTo>
+                      <a:pt x="0" y="381000"/>
+                    </a:lnTo>
+                    <a:cubicBezTo>
+                      <a:pt x="0" y="402042"/>
+                      <a:pt x="17058" y="419100"/>
+                      <a:pt x="38100" y="419100"/>
+                    </a:cubicBezTo>
+                    <a:lnTo>
+                      <a:pt x="381000" y="419100"/>
+                    </a:lnTo>
+                    <a:cubicBezTo>
+                      <a:pt x="402042" y="419100"/>
+                      <a:pt x="419100" y="402042"/>
+                      <a:pt x="419100" y="381000"/>
+                    </a:cubicBezTo>
+                    <a:lnTo>
+                      <a:pt x="419100" y="114300"/>
+                    </a:lnTo>
+                    <a:cubicBezTo>
+                      <a:pt x="419100" y="93258"/>
+                      <a:pt x="402042" y="76200"/>
+                      <a:pt x="381000" y="76200"/>
                     </a:cubicBezTo>
                     <a:close/>
                     <a:moveTo>
-                      <a:pt x="250030" y="250030"/>
+                      <a:pt x="381000" y="381000"/>
                     </a:moveTo>
                     <a:lnTo>
-                      <a:pt x="25003" y="250030"/>
-                    </a:lnTo>
-                    <a:lnTo>
-                      <a:pt x="25003" y="75009"/>
-                    </a:lnTo>
-                    <a:lnTo>
-                      <a:pt x="250030" y="75009"/>
-                    </a:lnTo>
-                    <a:lnTo>
-                      <a:pt x="250030" y="250030"/>
+                      <a:pt x="38100" y="381000"/>
+                    </a:lnTo>
+                    <a:lnTo>
+                      <a:pt x="38100" y="114300"/>
+                    </a:lnTo>
+                    <a:lnTo>
+                      <a:pt x="381000" y="114300"/>
+                    </a:lnTo>
+                    <a:lnTo>
+                      <a:pt x="381000" y="381000"/>
                     </a:lnTo>
                     <a:close/>
                     <a:moveTo>
-                      <a:pt x="325040" y="25003"/>
+                      <a:pt x="495300" y="38100"/>
                     </a:moveTo>
                     <a:lnTo>
-                      <a:pt x="325040" y="212526"/>
-                    </a:lnTo>
-                    <a:cubicBezTo>
-                      <a:pt x="325040" y="219430"/>
-                      <a:pt x="319443" y="225027"/>
-                      <a:pt x="312538" y="225027"/>
-                    </a:cubicBezTo>
-                    <a:cubicBezTo>
-                      <a:pt x="305634" y="225027"/>
-                      <a:pt x="300037" y="219430"/>
-                      <a:pt x="300037" y="212526"/>
-                    </a:cubicBezTo>
-                    <a:lnTo>
-                      <a:pt x="300037" y="25003"/>
-                    </a:lnTo>
-                    <a:lnTo>
-                      <a:pt x="62508" y="25003"/>
-                    </a:lnTo>
-                    <a:cubicBezTo>
-                      <a:pt x="55603" y="25003"/>
-                      <a:pt x="50006" y="19406"/>
-                      <a:pt x="50006" y="12502"/>
-                    </a:cubicBezTo>
-                    <a:cubicBezTo>
-                      <a:pt x="50006" y="5597"/>
-                      <a:pt x="55603" y="0"/>
-                      <a:pt x="62508" y="0"/>
-                    </a:cubicBezTo>
-                    <a:lnTo>
-                      <a:pt x="300037" y="0"/>
-                    </a:lnTo>
-                    <a:cubicBezTo>
-                      <a:pt x="313845" y="0"/>
-                      <a:pt x="325040" y="11194"/>
-                      <a:pt x="325040" y="25003"/>
+                      <a:pt x="495300" y="323850"/>
+                    </a:lnTo>
+                    <a:cubicBezTo>
+                      <a:pt x="495300" y="334371"/>
+                      <a:pt x="486771" y="342900"/>
+                      <a:pt x="476250" y="342900"/>
+                    </a:cubicBezTo>
+                    <a:cubicBezTo>
+                      <a:pt x="465729" y="342900"/>
+                      <a:pt x="457200" y="334371"/>
+                      <a:pt x="457200" y="323850"/>
+                    </a:cubicBezTo>
+                    <a:lnTo>
+                      <a:pt x="457200" y="38100"/>
+                    </a:lnTo>
+                    <a:lnTo>
+                      <a:pt x="95250" y="38100"/>
+                    </a:lnTo>
+                    <a:cubicBezTo>
+                      <a:pt x="84729" y="38100"/>
+                      <a:pt x="76200" y="29571"/>
+                      <a:pt x="76200" y="19050"/>
+                    </a:cubicBezTo>
+                    <a:cubicBezTo>
+                      <a:pt x="76200" y="8529"/>
+                      <a:pt x="84729" y="0"/>
+                      <a:pt x="95250" y="0"/>
+                    </a:cubicBezTo>
+                    <a:lnTo>
+                      <a:pt x="457200" y="0"/>
+                    </a:lnTo>
+                    <a:cubicBezTo>
+                      <a:pt x="478242" y="0"/>
+                      <a:pt x="495300" y="17058"/>
+                      <a:pt x="495300" y="38100"/>
                     </a:cubicBezTo>
                     <a:close/>
                   </a:path>
@@ -1684,14 +1604,14 @@
         </p:grpSp>
         <p:sp>
           <p:nvSpPr>
-            <p:cNvPr id="13" name="TextBox 13"/>
+            <p:cNvPr id="11" name="TextBox 11"/>
             <p:cNvSpPr txBox="1"/>
             <p:nvPr/>
           </p:nvSpPr>
           <p:spPr>
             <a:xfrm>
-              <a:off x="8356854" y="1651000"/>
-              <a:ext cx="444408" cy="234696"/>
+              <a:off x="1927024" y="3098800"/>
+              <a:ext cx="451253" cy="234696"/>
             </a:xfrm>
             <a:prstGeom prst="rect">
               <a:avLst/>
@@ -1707,7 +1627,7 @@
             </a:bodyPr>
             <a:lstStyle/>
             <a:p>
-              <a:pPr algn="l"/>
+              <a:pPr algn="ctr"/>
               <a:r>
                 <a:rPr lang="en" sz="1200" b="1" dirty="0">
                   <a:solidFill>
@@ -1717,21 +1637,21 @@
                   <a:ea typeface="+mn-ea"/>
                   <a:cs typeface="+mn-cs"/>
                 </a:rPr>
-                <a:t>5 MIN</a:t>
+                <a:t>FROM</a:t>
               </a:r>
             </a:p>
           </p:txBody>
         </p:sp>
         <p:sp>
           <p:nvSpPr>
-            <p:cNvPr id="14" name="TextBox 14"/>
+            <p:cNvPr id="12" name="TextBox 12"/>
             <p:cNvSpPr txBox="1"/>
             <p:nvPr/>
           </p:nvSpPr>
           <p:spPr>
             <a:xfrm>
-              <a:off x="8353806" y="1822450"/>
-              <a:ext cx="996379" cy="352044"/>
+              <a:off x="1259569" y="3422650"/>
+              <a:ext cx="1786162" cy="410718"/>
             </a:xfrm>
             <a:prstGeom prst="rect">
               <a:avLst/>
@@ -1747,9 +1667,9 @@
             </a:bodyPr>
             <a:lstStyle/>
             <a:p>
-              <a:pPr algn="l"/>
+              <a:pPr algn="ctr"/>
               <a:r>
-                <a:rPr lang="en" sz="1800" b="1" dirty="0">
+                <a:rPr lang="en" sz="2100" b="1" dirty="0">
                   <a:solidFill>
                     <a:schemeClr val="dk1"/>
                   </a:solidFill>
@@ -1757,25 +1677,224 @@
                   <a:ea typeface="+mn-ea"/>
                   <a:cs typeface="+mn-cs"/>
                 </a:rPr>
-                <a:t>Painpoint</a:t>
+                <a:t>A pain you feel</a:t>
               </a:r>
             </a:p>
           </p:txBody>
         </p:sp>
         <p:sp>
           <p:nvSpPr>
-            <p:cNvPr id="15" name="Rectangle 15"/>
-            <p:cNvSpPr/>
+            <p:cNvPr id="13" name="TextBox 13"/>
+            <p:cNvSpPr txBox="1"/>
             <p:nvPr/>
           </p:nvSpPr>
           <p:spPr>
             <a:xfrm>
-              <a:off x="7696200" y="2552700"/>
-              <a:ext cx="3714750" cy="742950"/>
+              <a:off x="963837" y="3879850"/>
+              <a:ext cx="2377627" cy="352044"/>
+            </a:xfrm>
+            <a:prstGeom prst="rect">
+              <a:avLst/>
+            </a:prstGeom>
+            <a:noFill/>
+            <a:ln>
+              <a:noFill/>
+            </a:ln>
+          </p:spPr>
+          <p:txBody>
+            <a:bodyPr wrap="none" lIns="0" tIns="0" rIns="0" bIns="0" anchor="t" anchorCtr="0">
+              <a:spAutoFit/>
+            </a:bodyPr>
+            <a:lstStyle/>
+            <a:p>
+              <a:pPr algn="ctr"/>
+              <a:r>
+                <a:rPr lang="en" sz="1800" dirty="0">
+                  <a:solidFill>
+                    <a:schemeClr val="accent5"/>
+                  </a:solidFill>
+                  <a:latin typeface="+mn-lt"/>
+                  <a:ea typeface="+mn-ea"/>
+                  <a:cs typeface="+mn-cs"/>
+                </a:rPr>
+                <a:t>Not the impressive one.</a:t>
+              </a:r>
+            </a:p>
+          </p:txBody>
+        </p:sp>
+        <p:grpSp>
+          <p:nvGrpSpPr>
+            <p:cNvPr id="16" name="Group 16"/>
+            <p:cNvGrpSpPr/>
+            <p:nvPr/>
+          </p:nvGrpSpPr>
+          <p:grpSpPr>
+            <a:xfrm>
+              <a:off x="3971925" y="3404240"/>
+              <a:ext cx="285759" cy="240019"/>
+              <a:chOff x="3971925" y="3404240"/>
+              <a:chExt cx="285759" cy="240019"/>
+            </a:xfrm>
+          </p:grpSpPr>
+          <p:sp>
+            <p:nvSpPr>
+              <p:cNvPr id="14" name="Freeform 14"/>
+              <p:cNvSpPr/>
+              <p:nvPr/>
+            </p:nvSpPr>
+            <p:spPr>
+              <a:xfrm>
+                <a:off x="4138612" y="3417094"/>
+                <a:ext cx="107156" cy="214312"/>
+              </a:xfrm>
+              <a:custGeom>
+                <a:avLst/>
+                <a:gdLst/>
+                <a:ahLst/>
+                <a:cxnLst/>
+                <a:rect l="l" t="t" r="r" b="b"/>
+                <a:pathLst>
+                  <a:path w="107156" h="214312">
+                    <a:moveTo>
+                      <a:pt x="107156" y="107156"/>
+                    </a:moveTo>
+                    <a:lnTo>
+                      <a:pt x="0" y="214312"/>
+                    </a:lnTo>
+                    <a:lnTo>
+                      <a:pt x="0" y="0"/>
+                    </a:lnTo>
+                    <a:close/>
+                  </a:path>
+                </a:pathLst>
+              </a:custGeom>
+              <a:solidFill>
+                <a:schemeClr val="accent1">
+                  <a:alpha val="20000"/>
+                </a:schemeClr>
+              </a:solidFill>
+              <a:ln>
+                <a:noFill/>
+              </a:ln>
+            </p:spPr>
+          </p:sp>
+          <p:sp>
+            <p:nvSpPr>
+              <p:cNvPr id="15" name="Freeform 15"/>
+              <p:cNvSpPr/>
+              <p:nvPr/>
+            </p:nvSpPr>
+            <p:spPr>
+              <a:xfrm>
+                <a:off x="3971925" y="3404240"/>
+                <a:ext cx="285759" cy="240019"/>
+              </a:xfrm>
+              <a:custGeom>
+                <a:avLst/>
+                <a:gdLst/>
+                <a:ahLst/>
+                <a:cxnLst/>
+                <a:rect l="l" t="t" r="r" b="b"/>
+                <a:pathLst>
+                  <a:path w="285759" h="240019">
+                    <a:moveTo>
+                      <a:pt x="282267" y="111586"/>
+                    </a:moveTo>
+                    <a:lnTo>
+                      <a:pt x="175111" y="4430"/>
+                    </a:lnTo>
+                    <a:cubicBezTo>
+                      <a:pt x="171706" y="1020"/>
+                      <a:pt x="166581" y="0"/>
+                      <a:pt x="162130" y="1844"/>
+                    </a:cubicBezTo>
+                    <a:cubicBezTo>
+                      <a:pt x="157678" y="3689"/>
+                      <a:pt x="154777" y="8035"/>
+                      <a:pt x="154781" y="12853"/>
+                    </a:cubicBezTo>
+                    <a:lnTo>
+                      <a:pt x="154781" y="108103"/>
+                    </a:lnTo>
+                    <a:lnTo>
+                      <a:pt x="11906" y="108103"/>
+                    </a:lnTo>
+                    <a:cubicBezTo>
+                      <a:pt x="5331" y="108103"/>
+                      <a:pt x="0" y="113434"/>
+                      <a:pt x="0" y="120010"/>
+                    </a:cubicBezTo>
+                    <a:cubicBezTo>
+                      <a:pt x="0" y="126585"/>
+                      <a:pt x="5331" y="131916"/>
+                      <a:pt x="11906" y="131916"/>
+                    </a:cubicBezTo>
+                    <a:lnTo>
+                      <a:pt x="154781" y="131916"/>
+                    </a:lnTo>
+                    <a:lnTo>
+                      <a:pt x="154781" y="227166"/>
+                    </a:lnTo>
+                    <a:cubicBezTo>
+                      <a:pt x="154777" y="231984"/>
+                      <a:pt x="157678" y="236330"/>
+                      <a:pt x="162130" y="238175"/>
+                    </a:cubicBezTo>
+                    <a:cubicBezTo>
+                      <a:pt x="166581" y="240019"/>
+                      <a:pt x="171706" y="238999"/>
+                      <a:pt x="175111" y="235589"/>
+                    </a:cubicBezTo>
+                    <a:lnTo>
+                      <a:pt x="282267" y="128433"/>
+                    </a:lnTo>
+                    <a:cubicBezTo>
+                      <a:pt x="284503" y="126200"/>
+                      <a:pt x="285759" y="123170"/>
+                      <a:pt x="285759" y="120010"/>
+                    </a:cubicBezTo>
+                    <a:cubicBezTo>
+                      <a:pt x="285759" y="116849"/>
+                      <a:pt x="284503" y="113819"/>
+                      <a:pt x="282267" y="111586"/>
+                    </a:cubicBezTo>
+                    <a:close/>
+                    <a:moveTo>
+                      <a:pt x="178594" y="198427"/>
+                    </a:moveTo>
+                    <a:lnTo>
+                      <a:pt x="178594" y="41592"/>
+                    </a:lnTo>
+                    <a:lnTo>
+                      <a:pt x="257011" y="120010"/>
+                    </a:lnTo>
+                    <a:close/>
+                  </a:path>
+                </a:pathLst>
+              </a:custGeom>
+              <a:solidFill>
+                <a:schemeClr val="accent1"/>
+              </a:solidFill>
+              <a:ln>
+                <a:noFill/>
+              </a:ln>
+            </p:spPr>
+          </p:sp>
+        </p:grpSp>
+        <p:sp>
+          <p:nvSpPr>
+            <p:cNvPr id="17" name="Rectangle 17"/>
+            <p:cNvSpPr/>
+            <p:nvPr/>
+          </p:nvSpPr>
+          <p:spPr>
+            <a:xfrm>
+              <a:off x="4552950" y="2133600"/>
+              <a:ext cx="3238500" cy="3143250"/>
             </a:xfrm>
             <a:prstGeom prst="roundRect">
               <a:avLst>
-                <a:gd name="adj" fmla="val 28205"/>
+                <a:gd name="adj" fmla="val 6667"/>
               </a:avLst>
             </a:prstGeom>
             <a:solidFill>
@@ -1790,18 +1909,18 @@
         </p:sp>
         <p:sp>
           <p:nvSpPr>
-            <p:cNvPr id="16" name="Rectangle 16"/>
+            <p:cNvPr id="18" name="Rectangle 18"/>
             <p:cNvSpPr/>
             <p:nvPr/>
           </p:nvSpPr>
           <p:spPr>
             <a:xfrm>
-              <a:off x="7620000" y="2438400"/>
-              <a:ext cx="3714750" cy="742950"/>
+              <a:off x="4457700" y="2000250"/>
+              <a:ext cx="3238500" cy="3143250"/>
             </a:xfrm>
             <a:prstGeom prst="roundRect">
               <a:avLst>
-                <a:gd name="adj" fmla="val 28205"/>
+                <a:gd name="adj" fmla="val 6667"/>
               </a:avLst>
             </a:prstGeom>
             <a:solidFill>
@@ -1821,28 +1940,28 @@
         </p:sp>
         <p:grpSp>
           <p:nvGrpSpPr>
-            <p:cNvPr id="19" name="Group 19"/>
+            <p:cNvPr id="21" name="Group 21"/>
             <p:cNvGrpSpPr/>
             <p:nvPr/>
           </p:nvGrpSpPr>
           <p:grpSpPr>
             <a:xfrm>
-              <a:off x="7860485" y="2647343"/>
-              <a:ext cx="312556" cy="312571"/>
-              <a:chOff x="7860485" y="2647343"/>
-              <a:chExt cx="312556" cy="312571"/>
+              <a:off x="5714903" y="2266950"/>
+              <a:ext cx="552547" cy="552547"/>
+              <a:chOff x="5714903" y="2266950"/>
+              <a:chExt cx="552547" cy="552547"/>
             </a:xfrm>
           </p:grpSpPr>
           <p:sp>
             <p:nvSpPr>
-              <p:cNvPr id="17" name="Freeform 17"/>
+              <p:cNvPr id="19" name="Freeform 19"/>
               <p:cNvSpPr/>
               <p:nvPr/>
             </p:nvSpPr>
             <p:spPr>
               <a:xfrm>
-                <a:off x="8023026" y="2658635"/>
-                <a:ext cx="137542" cy="138738"/>
+                <a:off x="5734056" y="2381256"/>
+                <a:ext cx="419088" cy="419088"/>
               </a:xfrm>
               <a:custGeom>
                 <a:avLst/>
@@ -1851,36 +1970,73 @@
                 <a:cxnLst/>
                 <a:rect l="l" t="t" r="r" b="b"/>
                 <a:pathLst>
-                  <a:path w="137542" h="138738">
+                  <a:path w="419088" h="419088">
                     <a:moveTo>
-                      <a:pt x="133860" y="92389"/>
+                      <a:pt x="406759" y="227237"/>
                     </a:moveTo>
                     <a:lnTo>
-                      <a:pt x="87511" y="138738"/>
-                    </a:lnTo>
-                    <a:lnTo>
-                      <a:pt x="0" y="51228"/>
-                    </a:lnTo>
-                    <a:lnTo>
-                      <a:pt x="46349" y="4878"/>
-                    </a:lnTo>
-                    <a:cubicBezTo>
-                      <a:pt x="51231" y="0"/>
-                      <a:pt x="59142" y="0"/>
-                      <a:pt x="64023" y="4878"/>
-                    </a:cubicBezTo>
-                    <a:lnTo>
-                      <a:pt x="133860" y="74668"/>
-                    </a:lnTo>
-                    <a:cubicBezTo>
-                      <a:pt x="136217" y="77014"/>
-                      <a:pt x="137542" y="80203"/>
-                      <a:pt x="137542" y="83529"/>
-                    </a:cubicBezTo>
-                    <a:cubicBezTo>
-                      <a:pt x="137542" y="86854"/>
-                      <a:pt x="136217" y="90043"/>
-                      <a:pt x="133860" y="92389"/>
+                      <a:pt x="275576" y="275576"/>
+                    </a:lnTo>
+                    <a:lnTo>
+                      <a:pt x="227237" y="406759"/>
+                    </a:lnTo>
+                    <a:cubicBezTo>
+                      <a:pt x="224502" y="414168"/>
+                      <a:pt x="217441" y="419088"/>
+                      <a:pt x="209544" y="419088"/>
+                    </a:cubicBezTo>
+                    <a:cubicBezTo>
+                      <a:pt x="201647" y="419088"/>
+                      <a:pt x="194586" y="414168"/>
+                      <a:pt x="191851" y="406759"/>
+                    </a:cubicBezTo>
+                    <a:lnTo>
+                      <a:pt x="143512" y="275576"/>
+                    </a:lnTo>
+                    <a:lnTo>
+                      <a:pt x="12329" y="227237"/>
+                    </a:lnTo>
+                    <a:cubicBezTo>
+                      <a:pt x="4920" y="224502"/>
+                      <a:pt x="0" y="217441"/>
+                      <a:pt x="0" y="209544"/>
+                    </a:cubicBezTo>
+                    <a:cubicBezTo>
+                      <a:pt x="0" y="201647"/>
+                      <a:pt x="4920" y="194586"/>
+                      <a:pt x="12329" y="191851"/>
+                    </a:cubicBezTo>
+                    <a:lnTo>
+                      <a:pt x="143512" y="143512"/>
+                    </a:lnTo>
+                    <a:lnTo>
+                      <a:pt x="191851" y="12329"/>
+                    </a:lnTo>
+                    <a:cubicBezTo>
+                      <a:pt x="194586" y="4920"/>
+                      <a:pt x="201647" y="0"/>
+                      <a:pt x="209544" y="0"/>
+                    </a:cubicBezTo>
+                    <a:cubicBezTo>
+                      <a:pt x="217441" y="0"/>
+                      <a:pt x="224502" y="4920"/>
+                      <a:pt x="227237" y="12329"/>
+                    </a:cubicBezTo>
+                    <a:lnTo>
+                      <a:pt x="275576" y="143512"/>
+                    </a:lnTo>
+                    <a:lnTo>
+                      <a:pt x="406759" y="191851"/>
+                    </a:lnTo>
+                    <a:cubicBezTo>
+                      <a:pt x="414168" y="194586"/>
+                      <a:pt x="419088" y="201647"/>
+                      <a:pt x="419088" y="209544"/>
+                    </a:cubicBezTo>
+                    <a:cubicBezTo>
+                      <a:pt x="419088" y="217441"/>
+                      <a:pt x="414168" y="224502"/>
+                      <a:pt x="406759" y="227237"/>
                     </a:cubicBezTo>
                     <a:close/>
                   </a:path>
@@ -1898,14 +2054,14 @@
           </p:sp>
           <p:sp>
             <p:nvSpPr>
-              <p:cNvPr id="18" name="Freeform 18"/>
+              <p:cNvPr id="20" name="Freeform 20"/>
               <p:cNvSpPr/>
               <p:nvPr/>
             </p:nvSpPr>
             <p:spPr>
               <a:xfrm>
-                <a:off x="7860485" y="2647343"/>
-                <a:ext cx="312556" cy="312571"/>
+                <a:off x="5714903" y="2266950"/>
+                <a:ext cx="552547" cy="552547"/>
               </a:xfrm>
               <a:custGeom>
                 <a:avLst/>
@@ -1914,89 +2070,255 @@
                 <a:cxnLst/>
                 <a:rect l="l" t="t" r="r" b="b"/>
                 <a:pathLst>
-                  <a:path w="312556" h="312571">
+                  <a:path w="552547" h="552547">
                     <a:moveTo>
-                      <a:pt x="305230" y="77162"/>
+                      <a:pt x="432484" y="288274"/>
                     </a:moveTo>
                     <a:lnTo>
-                      <a:pt x="235409" y="7325"/>
-                    </a:lnTo>
-                    <a:cubicBezTo>
-                      <a:pt x="230720" y="2635"/>
-                      <a:pt x="224360" y="0"/>
-                      <a:pt x="217727" y="0"/>
-                    </a:cubicBezTo>
-                    <a:cubicBezTo>
-                      <a:pt x="211095" y="0"/>
-                      <a:pt x="204735" y="2635"/>
-                      <a:pt x="200046" y="7325"/>
-                    </a:cubicBezTo>
-                    <a:lnTo>
-                      <a:pt x="7350" y="200036"/>
-                    </a:lnTo>
-                    <a:cubicBezTo>
-                      <a:pt x="2640" y="204709"/>
-                      <a:pt x="0" y="211075"/>
-                      <a:pt x="21" y="217710"/>
-                    </a:cubicBezTo>
-                    <a:lnTo>
-                      <a:pt x="21" y="287547"/>
-                    </a:lnTo>
-                    <a:cubicBezTo>
-                      <a:pt x="21" y="301356"/>
-                      <a:pt x="11215" y="312550"/>
-                      <a:pt x="25024" y="312550"/>
-                    </a:cubicBezTo>
-                    <a:lnTo>
-                      <a:pt x="94861" y="312550"/>
-                    </a:lnTo>
-                    <a:cubicBezTo>
-                      <a:pt x="101496" y="312571"/>
-                      <a:pt x="107862" y="309931"/>
-                      <a:pt x="112535" y="305221"/>
-                    </a:cubicBezTo>
-                    <a:lnTo>
-                      <a:pt x="305230" y="112526"/>
-                    </a:lnTo>
-                    <a:cubicBezTo>
-                      <a:pt x="309921" y="107836"/>
-                      <a:pt x="312556" y="101476"/>
-                      <a:pt x="312556" y="94844"/>
-                    </a:cubicBezTo>
-                    <a:cubicBezTo>
-                      <a:pt x="312556" y="88212"/>
-                      <a:pt x="309921" y="81851"/>
-                      <a:pt x="305230" y="77162"/>
+                      <a:pt x="309659" y="242888"/>
+                    </a:lnTo>
+                    <a:lnTo>
+                      <a:pt x="264416" y="119967"/>
+                    </a:lnTo>
+                    <a:cubicBezTo>
+                      <a:pt x="258928" y="105059"/>
+                      <a:pt x="244726" y="95153"/>
+                      <a:pt x="228840" y="95153"/>
+                    </a:cubicBezTo>
+                    <a:cubicBezTo>
+                      <a:pt x="212953" y="95153"/>
+                      <a:pt x="198752" y="105059"/>
+                      <a:pt x="193264" y="119967"/>
+                    </a:cubicBezTo>
+                    <a:lnTo>
+                      <a:pt x="147734" y="242888"/>
+                    </a:lnTo>
+                    <a:lnTo>
+                      <a:pt x="24814" y="288131"/>
+                    </a:lnTo>
+                    <a:cubicBezTo>
+                      <a:pt x="9906" y="293619"/>
+                      <a:pt x="0" y="307821"/>
+                      <a:pt x="0" y="323707"/>
+                    </a:cubicBezTo>
+                    <a:cubicBezTo>
+                      <a:pt x="0" y="339594"/>
+                      <a:pt x="9906" y="353795"/>
+                      <a:pt x="24814" y="359283"/>
+                    </a:cubicBezTo>
+                    <a:lnTo>
+                      <a:pt x="147734" y="404812"/>
+                    </a:lnTo>
+                    <a:lnTo>
+                      <a:pt x="192978" y="527733"/>
+                    </a:lnTo>
+                    <a:cubicBezTo>
+                      <a:pt x="198466" y="542641"/>
+                      <a:pt x="212667" y="552547"/>
+                      <a:pt x="228554" y="552547"/>
+                    </a:cubicBezTo>
+                    <a:cubicBezTo>
+                      <a:pt x="244441" y="552547"/>
+                      <a:pt x="258642" y="542641"/>
+                      <a:pt x="264130" y="527733"/>
+                    </a:cubicBezTo>
+                    <a:lnTo>
+                      <a:pt x="309659" y="404812"/>
+                    </a:lnTo>
+                    <a:lnTo>
+                      <a:pt x="432579" y="359569"/>
+                    </a:lnTo>
+                    <a:cubicBezTo>
+                      <a:pt x="447488" y="354081"/>
+                      <a:pt x="457394" y="339879"/>
+                      <a:pt x="457394" y="323993"/>
+                    </a:cubicBezTo>
+                    <a:cubicBezTo>
+                      <a:pt x="457394" y="308106"/>
+                      <a:pt x="447488" y="293905"/>
+                      <a:pt x="432579" y="288417"/>
                     </a:cubicBezTo>
                     <a:close/>
                     <a:moveTo>
-                      <a:pt x="94861" y="287547"/>
+                      <a:pt x="288228" y="371999"/>
                     </a:moveTo>
-                    <a:lnTo>
-                      <a:pt x="25024" y="287547"/>
-                    </a:lnTo>
-                    <a:lnTo>
-                      <a:pt x="25024" y="217710"/>
-                    </a:lnTo>
-                    <a:lnTo>
-                      <a:pt x="162541" y="80194"/>
-                    </a:lnTo>
-                    <a:lnTo>
-                      <a:pt x="232378" y="150030"/>
+                    <a:cubicBezTo>
+                      <a:pt x="282995" y="373928"/>
+                      <a:pt x="278870" y="378053"/>
+                      <a:pt x="276941" y="383286"/>
+                    </a:cubicBezTo>
+                    <a:lnTo>
+                      <a:pt x="228697" y="513993"/>
+                    </a:lnTo>
+                    <a:lnTo>
+                      <a:pt x="180548" y="383381"/>
+                    </a:lnTo>
+                    <a:cubicBezTo>
+                      <a:pt x="178622" y="378092"/>
+                      <a:pt x="174455" y="373925"/>
+                      <a:pt x="169166" y="371999"/>
+                    </a:cubicBezTo>
+                    <a:lnTo>
+                      <a:pt x="38554" y="323850"/>
+                    </a:lnTo>
+                    <a:lnTo>
+                      <a:pt x="169166" y="275701"/>
+                    </a:lnTo>
+                    <a:cubicBezTo>
+                      <a:pt x="174455" y="273775"/>
+                      <a:pt x="178622" y="269608"/>
+                      <a:pt x="180548" y="264319"/>
+                    </a:cubicBezTo>
+                    <a:lnTo>
+                      <a:pt x="228697" y="133707"/>
+                    </a:lnTo>
+                    <a:lnTo>
+                      <a:pt x="276846" y="264319"/>
+                    </a:lnTo>
+                    <a:cubicBezTo>
+                      <a:pt x="278774" y="269552"/>
+                      <a:pt x="282900" y="273677"/>
+                      <a:pt x="288133" y="275606"/>
+                    </a:cubicBezTo>
+                    <a:lnTo>
+                      <a:pt x="418840" y="323850"/>
                     </a:lnTo>
                     <a:close/>
                     <a:moveTo>
-                      <a:pt x="250052" y="132340"/>
+                      <a:pt x="304897" y="76200"/>
                     </a:moveTo>
-                    <a:lnTo>
-                      <a:pt x="180215" y="62519"/>
-                    </a:lnTo>
-                    <a:lnTo>
-                      <a:pt x="217720" y="25015"/>
-                    </a:lnTo>
-                    <a:lnTo>
-                      <a:pt x="287556" y="94836"/>
-                    </a:lnTo>
+                    <a:cubicBezTo>
+                      <a:pt x="304897" y="65679"/>
+                      <a:pt x="313426" y="57150"/>
+                      <a:pt x="323947" y="57150"/>
+                    </a:cubicBezTo>
+                    <a:lnTo>
+                      <a:pt x="362047" y="57150"/>
+                    </a:lnTo>
+                    <a:lnTo>
+                      <a:pt x="362047" y="19050"/>
+                    </a:lnTo>
+                    <a:cubicBezTo>
+                      <a:pt x="362047" y="8529"/>
+                      <a:pt x="370576" y="0"/>
+                      <a:pt x="381097" y="0"/>
+                    </a:cubicBezTo>
+                    <a:cubicBezTo>
+                      <a:pt x="391618" y="0"/>
+                      <a:pt x="400147" y="8529"/>
+                      <a:pt x="400147" y="19050"/>
+                    </a:cubicBezTo>
+                    <a:lnTo>
+                      <a:pt x="400147" y="57150"/>
+                    </a:lnTo>
+                    <a:lnTo>
+                      <a:pt x="438247" y="57150"/>
+                    </a:lnTo>
+                    <a:cubicBezTo>
+                      <a:pt x="448768" y="57150"/>
+                      <a:pt x="457297" y="65679"/>
+                      <a:pt x="457297" y="76200"/>
+                    </a:cubicBezTo>
+                    <a:cubicBezTo>
+                      <a:pt x="457297" y="86721"/>
+                      <a:pt x="448768" y="95250"/>
+                      <a:pt x="438247" y="95250"/>
+                    </a:cubicBezTo>
+                    <a:lnTo>
+                      <a:pt x="400147" y="95250"/>
+                    </a:lnTo>
+                    <a:lnTo>
+                      <a:pt x="400147" y="133350"/>
+                    </a:lnTo>
+                    <a:cubicBezTo>
+                      <a:pt x="400147" y="143871"/>
+                      <a:pt x="391618" y="152400"/>
+                      <a:pt x="381097" y="152400"/>
+                    </a:cubicBezTo>
+                    <a:cubicBezTo>
+                      <a:pt x="370576" y="152400"/>
+                      <a:pt x="362047" y="143871"/>
+                      <a:pt x="362047" y="133350"/>
+                    </a:cubicBezTo>
+                    <a:lnTo>
+                      <a:pt x="362047" y="95250"/>
+                    </a:lnTo>
+                    <a:lnTo>
+                      <a:pt x="323947" y="95250"/>
+                    </a:lnTo>
+                    <a:cubicBezTo>
+                      <a:pt x="313426" y="95250"/>
+                      <a:pt x="304897" y="86721"/>
+                      <a:pt x="304897" y="76200"/>
+                    </a:cubicBezTo>
+                    <a:close/>
+                    <a:moveTo>
+                      <a:pt x="552547" y="190500"/>
+                    </a:moveTo>
+                    <a:cubicBezTo>
+                      <a:pt x="552547" y="201021"/>
+                      <a:pt x="544018" y="209550"/>
+                      <a:pt x="533497" y="209550"/>
+                    </a:cubicBezTo>
+                    <a:lnTo>
+                      <a:pt x="514447" y="209550"/>
+                    </a:lnTo>
+                    <a:lnTo>
+                      <a:pt x="514447" y="228600"/>
+                    </a:lnTo>
+                    <a:cubicBezTo>
+                      <a:pt x="514447" y="239121"/>
+                      <a:pt x="505918" y="247650"/>
+                      <a:pt x="495397" y="247650"/>
+                    </a:cubicBezTo>
+                    <a:cubicBezTo>
+                      <a:pt x="484876" y="247650"/>
+                      <a:pt x="476347" y="239121"/>
+                      <a:pt x="476347" y="228600"/>
+                    </a:cubicBezTo>
+                    <a:lnTo>
+                      <a:pt x="476347" y="209550"/>
+                    </a:lnTo>
+                    <a:lnTo>
+                      <a:pt x="457297" y="209550"/>
+                    </a:lnTo>
+                    <a:cubicBezTo>
+                      <a:pt x="446776" y="209550"/>
+                      <a:pt x="438247" y="201021"/>
+                      <a:pt x="438247" y="190500"/>
+                    </a:cubicBezTo>
+                    <a:cubicBezTo>
+                      <a:pt x="438247" y="179979"/>
+                      <a:pt x="446776" y="171450"/>
+                      <a:pt x="457297" y="171450"/>
+                    </a:cubicBezTo>
+                    <a:lnTo>
+                      <a:pt x="476347" y="171450"/>
+                    </a:lnTo>
+                    <a:lnTo>
+                      <a:pt x="476347" y="152400"/>
+                    </a:lnTo>
+                    <a:cubicBezTo>
+                      <a:pt x="476347" y="141879"/>
+                      <a:pt x="484876" y="133350"/>
+                      <a:pt x="495397" y="133350"/>
+                    </a:cubicBezTo>
+                    <a:cubicBezTo>
+                      <a:pt x="505918" y="133350"/>
+                      <a:pt x="514447" y="141879"/>
+                      <a:pt x="514447" y="152400"/>
+                    </a:cubicBezTo>
+                    <a:lnTo>
+                      <a:pt x="514447" y="171450"/>
+                    </a:lnTo>
+                    <a:lnTo>
+                      <a:pt x="533497" y="171450"/>
+                    </a:lnTo>
+                    <a:cubicBezTo>
+                      <a:pt x="544018" y="171450"/>
+                      <a:pt x="552547" y="179979"/>
+                      <a:pt x="552547" y="190500"/>
+                    </a:cubicBezTo>
                     <a:close/>
                   </a:path>
                 </a:pathLst>
@@ -2012,14 +2334,14 @@
         </p:grpSp>
         <p:sp>
           <p:nvSpPr>
-            <p:cNvPr id="20" name="TextBox 20"/>
+            <p:cNvPr id="22" name="TextBox 22"/>
             <p:cNvSpPr txBox="1"/>
             <p:nvPr/>
           </p:nvSpPr>
           <p:spPr>
             <a:xfrm>
-              <a:off x="8356854" y="2603500"/>
-              <a:ext cx="553853" cy="234696"/>
+              <a:off x="5705053" y="3098800"/>
+              <a:ext cx="743795" cy="234696"/>
             </a:xfrm>
             <a:prstGeom prst="rect">
               <a:avLst/>
@@ -2035,7 +2357,7 @@
             </a:bodyPr>
             <a:lstStyle/>
             <a:p>
-              <a:pPr algn="l"/>
+              <a:pPr algn="ctr"/>
               <a:r>
                 <a:rPr lang="en" sz="1200" b="1" dirty="0">
                   <a:solidFill>
@@ -2045,21 +2367,21 @@
                   <a:ea typeface="+mn-ea"/>
                   <a:cs typeface="+mn-cs"/>
                 </a:rPr>
-                <a:t>SAME 5</a:t>
+                <a:t>THROUGH</a:t>
               </a:r>
             </a:p>
           </p:txBody>
         </p:sp>
         <p:sp>
           <p:nvSpPr>
-            <p:cNvPr id="21" name="TextBox 21"/>
+            <p:cNvPr id="23" name="TextBox 23"/>
             <p:cNvSpPr txBox="1"/>
             <p:nvPr/>
           </p:nvSpPr>
           <p:spPr>
             <a:xfrm>
-              <a:off x="8353806" y="2774950"/>
-              <a:ext cx="989722" cy="352044"/>
+              <a:off x="5351855" y="3422650"/>
+              <a:ext cx="1450190" cy="410718"/>
             </a:xfrm>
             <a:prstGeom prst="rect">
               <a:avLst/>
@@ -2075,9 +2397,9 @@
             </a:bodyPr>
             <a:lstStyle/>
             <a:p>
-              <a:pPr algn="l"/>
+              <a:pPr algn="ctr"/>
               <a:r>
-                <a:rPr lang="en" sz="1800" b="1" dirty="0">
+                <a:rPr lang="en" sz="2100" b="1" dirty="0">
                   <a:solidFill>
                     <a:schemeClr val="dk1"/>
                   </a:solidFill>
@@ -2085,25 +2407,224 @@
                   <a:ea typeface="+mn-ea"/>
                   <a:cs typeface="+mn-cs"/>
                 </a:rPr>
-                <a:t>Idea brief</a:t>
+                <a:t>An assistant</a:t>
               </a:r>
             </a:p>
           </p:txBody>
         </p:sp>
         <p:sp>
           <p:nvSpPr>
-            <p:cNvPr id="22" name="Rectangle 22"/>
-            <p:cNvSpPr/>
+            <p:cNvPr id="24" name="TextBox 24"/>
+            <p:cNvSpPr txBox="1"/>
             <p:nvPr/>
           </p:nvSpPr>
           <p:spPr>
             <a:xfrm>
-              <a:off x="7696200" y="3505200"/>
-              <a:ext cx="3714750" cy="742950"/>
+              <a:off x="4858048" y="3879850"/>
+              <a:ext cx="2437803" cy="352044"/>
+            </a:xfrm>
+            <a:prstGeom prst="rect">
+              <a:avLst/>
+            </a:prstGeom>
+            <a:noFill/>
+            <a:ln>
+              <a:noFill/>
+            </a:ln>
+          </p:spPr>
+          <p:txBody>
+            <a:bodyPr wrap="none" lIns="0" tIns="0" rIns="0" bIns="0" anchor="t" anchorCtr="0">
+              <a:spAutoFit/>
+            </a:bodyPr>
+            <a:lstStyle/>
+            <a:p>
+              <a:pPr algn="ctr"/>
+              <a:r>
+                <a:rPr lang="en" sz="1800" dirty="0">
+                  <a:solidFill>
+                    <a:schemeClr val="accent5"/>
+                  </a:solidFill>
+                  <a:latin typeface="+mn-lt"/>
+                  <a:ea typeface="+mn-ea"/>
+                  <a:cs typeface="+mn-cs"/>
+                </a:rPr>
+                <a:t>You decide what it does.</a:t>
+              </a:r>
+            </a:p>
+          </p:txBody>
+        </p:sp>
+        <p:grpSp>
+          <p:nvGrpSpPr>
+            <p:cNvPr id="27" name="Group 27"/>
+            <p:cNvGrpSpPr/>
+            <p:nvPr/>
+          </p:nvGrpSpPr>
+          <p:grpSpPr>
+            <a:xfrm>
+              <a:off x="7896225" y="3404240"/>
+              <a:ext cx="285759" cy="240019"/>
+              <a:chOff x="7896225" y="3404240"/>
+              <a:chExt cx="285759" cy="240019"/>
+            </a:xfrm>
+          </p:grpSpPr>
+          <p:sp>
+            <p:nvSpPr>
+              <p:cNvPr id="25" name="Freeform 25"/>
+              <p:cNvSpPr/>
+              <p:nvPr/>
+            </p:nvSpPr>
+            <p:spPr>
+              <a:xfrm>
+                <a:off x="8062912" y="3417094"/>
+                <a:ext cx="107156" cy="214312"/>
+              </a:xfrm>
+              <a:custGeom>
+                <a:avLst/>
+                <a:gdLst/>
+                <a:ahLst/>
+                <a:cxnLst/>
+                <a:rect l="l" t="t" r="r" b="b"/>
+                <a:pathLst>
+                  <a:path w="107156" h="214312">
+                    <a:moveTo>
+                      <a:pt x="107156" y="107156"/>
+                    </a:moveTo>
+                    <a:lnTo>
+                      <a:pt x="0" y="214312"/>
+                    </a:lnTo>
+                    <a:lnTo>
+                      <a:pt x="0" y="0"/>
+                    </a:lnTo>
+                    <a:close/>
+                  </a:path>
+                </a:pathLst>
+              </a:custGeom>
+              <a:solidFill>
+                <a:schemeClr val="accent1">
+                  <a:alpha val="20000"/>
+                </a:schemeClr>
+              </a:solidFill>
+              <a:ln>
+                <a:noFill/>
+              </a:ln>
+            </p:spPr>
+          </p:sp>
+          <p:sp>
+            <p:nvSpPr>
+              <p:cNvPr id="26" name="Freeform 26"/>
+              <p:cNvSpPr/>
+              <p:nvPr/>
+            </p:nvSpPr>
+            <p:spPr>
+              <a:xfrm>
+                <a:off x="7896225" y="3404240"/>
+                <a:ext cx="285759" cy="240019"/>
+              </a:xfrm>
+              <a:custGeom>
+                <a:avLst/>
+                <a:gdLst/>
+                <a:ahLst/>
+                <a:cxnLst/>
+                <a:rect l="l" t="t" r="r" b="b"/>
+                <a:pathLst>
+                  <a:path w="285759" h="240019">
+                    <a:moveTo>
+                      <a:pt x="282267" y="111586"/>
+                    </a:moveTo>
+                    <a:lnTo>
+                      <a:pt x="175111" y="4430"/>
+                    </a:lnTo>
+                    <a:cubicBezTo>
+                      <a:pt x="171706" y="1020"/>
+                      <a:pt x="166581" y="0"/>
+                      <a:pt x="162130" y="1844"/>
+                    </a:cubicBezTo>
+                    <a:cubicBezTo>
+                      <a:pt x="157678" y="3689"/>
+                      <a:pt x="154777" y="8035"/>
+                      <a:pt x="154781" y="12853"/>
+                    </a:cubicBezTo>
+                    <a:lnTo>
+                      <a:pt x="154781" y="108103"/>
+                    </a:lnTo>
+                    <a:lnTo>
+                      <a:pt x="11906" y="108103"/>
+                    </a:lnTo>
+                    <a:cubicBezTo>
+                      <a:pt x="5331" y="108103"/>
+                      <a:pt x="0" y="113434"/>
+                      <a:pt x="0" y="120010"/>
+                    </a:cubicBezTo>
+                    <a:cubicBezTo>
+                      <a:pt x="0" y="126585"/>
+                      <a:pt x="5331" y="131916"/>
+                      <a:pt x="11906" y="131916"/>
+                    </a:cubicBezTo>
+                    <a:lnTo>
+                      <a:pt x="154781" y="131916"/>
+                    </a:lnTo>
+                    <a:lnTo>
+                      <a:pt x="154781" y="227166"/>
+                    </a:lnTo>
+                    <a:cubicBezTo>
+                      <a:pt x="154777" y="231984"/>
+                      <a:pt x="157678" y="236330"/>
+                      <a:pt x="162130" y="238175"/>
+                    </a:cubicBezTo>
+                    <a:cubicBezTo>
+                      <a:pt x="166581" y="240019"/>
+                      <a:pt x="171706" y="238999"/>
+                      <a:pt x="175111" y="235589"/>
+                    </a:cubicBezTo>
+                    <a:lnTo>
+                      <a:pt x="282267" y="128433"/>
+                    </a:lnTo>
+                    <a:cubicBezTo>
+                      <a:pt x="284503" y="126200"/>
+                      <a:pt x="285759" y="123170"/>
+                      <a:pt x="285759" y="120010"/>
+                    </a:cubicBezTo>
+                    <a:cubicBezTo>
+                      <a:pt x="285759" y="116849"/>
+                      <a:pt x="284503" y="113819"/>
+                      <a:pt x="282267" y="111586"/>
+                    </a:cubicBezTo>
+                    <a:close/>
+                    <a:moveTo>
+                      <a:pt x="178594" y="198427"/>
+                    </a:moveTo>
+                    <a:lnTo>
+                      <a:pt x="178594" y="41592"/>
+                    </a:lnTo>
+                    <a:lnTo>
+                      <a:pt x="257011" y="120010"/>
+                    </a:lnTo>
+                    <a:close/>
+                  </a:path>
+                </a:pathLst>
+              </a:custGeom>
+              <a:solidFill>
+                <a:schemeClr val="accent1"/>
+              </a:solidFill>
+              <a:ln>
+                <a:noFill/>
+              </a:ln>
+            </p:spPr>
+          </p:sp>
+        </p:grpSp>
+        <p:sp>
+          <p:nvSpPr>
+            <p:cNvPr id="28" name="Rectangle 28"/>
+            <p:cNvSpPr/>
+            <p:nvPr/>
+          </p:nvSpPr>
+          <p:spPr>
+            <a:xfrm>
+              <a:off x="8477250" y="2133600"/>
+              <a:ext cx="3238500" cy="3143250"/>
             </a:xfrm>
             <a:prstGeom prst="roundRect">
               <a:avLst>
-                <a:gd name="adj" fmla="val 28205"/>
+                <a:gd name="adj" fmla="val 6667"/>
               </a:avLst>
             </a:prstGeom>
             <a:solidFill>
@@ -2118,18 +2639,18 @@
         </p:sp>
         <p:sp>
           <p:nvSpPr>
-            <p:cNvPr id="23" name="Rectangle 23"/>
+            <p:cNvPr id="29" name="Rectangle 29"/>
             <p:cNvSpPr/>
             <p:nvPr/>
           </p:nvSpPr>
           <p:spPr>
             <a:xfrm>
-              <a:off x="7620000" y="3390900"/>
-              <a:ext cx="3714750" cy="742950"/>
+              <a:off x="8382000" y="2000250"/>
+              <a:ext cx="3238500" cy="3143250"/>
             </a:xfrm>
             <a:prstGeom prst="roundRect">
               <a:avLst>
-                <a:gd name="adj" fmla="val 28205"/>
+                <a:gd name="adj" fmla="val 6667"/>
               </a:avLst>
             </a:prstGeom>
             <a:solidFill>
@@ -2149,28 +2670,28 @@
         </p:sp>
         <p:grpSp>
           <p:nvGrpSpPr>
-            <p:cNvPr id="26" name="Group 26"/>
+            <p:cNvPr id="32" name="Group 32"/>
             <p:cNvGrpSpPr/>
             <p:nvPr/>
           </p:nvGrpSpPr>
           <p:grpSpPr>
             <a:xfrm>
-              <a:off x="7848005" y="3624858"/>
-              <a:ext cx="325040" cy="300037"/>
-              <a:chOff x="7848005" y="3624858"/>
-              <a:chExt cx="325040" cy="300037"/>
+              <a:off x="9658350" y="2286000"/>
+              <a:ext cx="495300" cy="516758"/>
+              <a:chOff x="9658350" y="2286000"/>
+              <a:chExt cx="495300" cy="516758"/>
             </a:xfrm>
           </p:grpSpPr>
           <p:sp>
             <p:nvSpPr>
-              <p:cNvPr id="24" name="Freeform 24"/>
+              <p:cNvPr id="30" name="Freeform 30"/>
               <p:cNvSpPr/>
               <p:nvPr/>
             </p:nvSpPr>
             <p:spPr>
               <a:xfrm>
-                <a:off x="7860506" y="3637359"/>
-                <a:ext cx="300037" cy="225027"/>
+                <a:off x="9677400" y="2362200"/>
+                <a:ext cx="457200" cy="323850"/>
               </a:xfrm>
               <a:custGeom>
                 <a:avLst/>
@@ -2179,41 +2700,41 @@
                 <a:cxnLst/>
                 <a:rect l="l" t="t" r="r" b="b"/>
                 <a:pathLst>
-                  <a:path w="300037" h="225027">
+                  <a:path w="457200" h="323850">
                     <a:moveTo>
-                      <a:pt x="300037" y="25003"/>
+                      <a:pt x="457200" y="19050"/>
                     </a:moveTo>
                     <a:lnTo>
-                      <a:pt x="300037" y="200024"/>
-                    </a:lnTo>
-                    <a:cubicBezTo>
-                      <a:pt x="300037" y="213833"/>
-                      <a:pt x="288842" y="225027"/>
-                      <a:pt x="275034" y="225027"/>
-                    </a:cubicBezTo>
-                    <a:lnTo>
-                      <a:pt x="25003" y="225027"/>
-                    </a:lnTo>
-                    <a:cubicBezTo>
-                      <a:pt x="11194" y="225027"/>
-                      <a:pt x="0" y="213833"/>
-                      <a:pt x="0" y="200024"/>
-                    </a:cubicBezTo>
-                    <a:lnTo>
-                      <a:pt x="0" y="25003"/>
-                    </a:lnTo>
-                    <a:cubicBezTo>
-                      <a:pt x="0" y="11194"/>
-                      <a:pt x="11194" y="0"/>
-                      <a:pt x="25003" y="0"/>
-                    </a:cubicBezTo>
-                    <a:lnTo>
-                      <a:pt x="275034" y="0"/>
-                    </a:lnTo>
-                    <a:cubicBezTo>
-                      <a:pt x="288842" y="0"/>
-                      <a:pt x="300037" y="11194"/>
-                      <a:pt x="300037" y="25003"/>
+                      <a:pt x="457200" y="304800"/>
+                    </a:lnTo>
+                    <a:cubicBezTo>
+                      <a:pt x="457200" y="315321"/>
+                      <a:pt x="448671" y="323850"/>
+                      <a:pt x="438150" y="323850"/>
+                    </a:cubicBezTo>
+                    <a:lnTo>
+                      <a:pt x="19050" y="323850"/>
+                    </a:lnTo>
+                    <a:cubicBezTo>
+                      <a:pt x="8529" y="323850"/>
+                      <a:pt x="0" y="315321"/>
+                      <a:pt x="0" y="304800"/>
+                    </a:cubicBezTo>
+                    <a:lnTo>
+                      <a:pt x="0" y="19050"/>
+                    </a:lnTo>
+                    <a:cubicBezTo>
+                      <a:pt x="0" y="8529"/>
+                      <a:pt x="8529" y="0"/>
+                      <a:pt x="19050" y="0"/>
+                    </a:cubicBezTo>
+                    <a:lnTo>
+                      <a:pt x="438150" y="0"/>
+                    </a:lnTo>
+                    <a:cubicBezTo>
+                      <a:pt x="448671" y="0"/>
+                      <a:pt x="457200" y="8529"/>
+                      <a:pt x="457200" y="19050"/>
                     </a:cubicBezTo>
                     <a:close/>
                   </a:path>
@@ -2231,14 +2752,14 @@
           </p:sp>
           <p:sp>
             <p:nvSpPr>
-              <p:cNvPr id="25" name="Freeform 25"/>
+              <p:cNvPr id="31" name="Freeform 31"/>
               <p:cNvSpPr/>
               <p:nvPr/>
             </p:nvSpPr>
             <p:spPr>
               <a:xfrm>
-                <a:off x="7848005" y="3624858"/>
-                <a:ext cx="325040" cy="300037"/>
+                <a:off x="9658350" y="2286000"/>
+                <a:ext cx="495300" cy="516758"/>
               </a:xfrm>
               <a:custGeom>
                 <a:avLst/>
@@ -2247,104 +2768,204 @@
                 <a:cxnLst/>
                 <a:rect l="l" t="t" r="r" b="b"/>
                 <a:pathLst>
-                  <a:path w="325040" h="300037">
+                  <a:path w="495300" h="516758">
                     <a:moveTo>
-                      <a:pt x="287535" y="0"/>
+                      <a:pt x="457200" y="57150"/>
                     </a:moveTo>
                     <a:lnTo>
-                      <a:pt x="37505" y="0"/>
-                    </a:lnTo>
-                    <a:cubicBezTo>
-                      <a:pt x="16791" y="0"/>
-                      <a:pt x="0" y="16791"/>
-                      <a:pt x="0" y="37505"/>
-                    </a:cubicBezTo>
-                    <a:lnTo>
-                      <a:pt x="0" y="212526"/>
-                    </a:lnTo>
-                    <a:cubicBezTo>
-                      <a:pt x="0" y="233239"/>
-                      <a:pt x="16791" y="250030"/>
-                      <a:pt x="37505" y="250030"/>
-                    </a:cubicBezTo>
-                    <a:lnTo>
-                      <a:pt x="287535" y="250030"/>
-                    </a:lnTo>
-                    <a:cubicBezTo>
-                      <a:pt x="308248" y="250030"/>
-                      <a:pt x="325040" y="233239"/>
-                      <a:pt x="325040" y="212526"/>
-                    </a:cubicBezTo>
-                    <a:lnTo>
-                      <a:pt x="325040" y="37505"/>
-                    </a:lnTo>
-                    <a:cubicBezTo>
-                      <a:pt x="325040" y="16791"/>
-                      <a:pt x="308248" y="0"/>
-                      <a:pt x="287535" y="0"/>
+                      <a:pt x="266700" y="57150"/>
+                    </a:lnTo>
+                    <a:lnTo>
+                      <a:pt x="266700" y="19050"/>
+                    </a:lnTo>
+                    <a:cubicBezTo>
+                      <a:pt x="266700" y="8529"/>
+                      <a:pt x="258171" y="0"/>
+                      <a:pt x="247650" y="0"/>
+                    </a:cubicBezTo>
+                    <a:cubicBezTo>
+                      <a:pt x="237129" y="0"/>
+                      <a:pt x="228600" y="8529"/>
+                      <a:pt x="228600" y="19050"/>
+                    </a:cubicBezTo>
+                    <a:lnTo>
+                      <a:pt x="228600" y="57150"/>
+                    </a:lnTo>
+                    <a:lnTo>
+                      <a:pt x="38100" y="57150"/>
+                    </a:lnTo>
+                    <a:cubicBezTo>
+                      <a:pt x="17058" y="57150"/>
+                      <a:pt x="0" y="74208"/>
+                      <a:pt x="0" y="95250"/>
+                    </a:cubicBezTo>
+                    <a:lnTo>
+                      <a:pt x="0" y="381000"/>
+                    </a:lnTo>
+                    <a:cubicBezTo>
+                      <a:pt x="0" y="402042"/>
+                      <a:pt x="17058" y="419100"/>
+                      <a:pt x="38100" y="419100"/>
+                    </a:cubicBezTo>
+                    <a:lnTo>
+                      <a:pt x="131826" y="419100"/>
+                    </a:lnTo>
+                    <a:lnTo>
+                      <a:pt x="80367" y="483394"/>
+                    </a:lnTo>
+                    <a:cubicBezTo>
+                      <a:pt x="73792" y="491613"/>
+                      <a:pt x="75124" y="503607"/>
+                      <a:pt x="83344" y="510183"/>
+                    </a:cubicBezTo>
+                    <a:cubicBezTo>
+                      <a:pt x="91563" y="516758"/>
+                      <a:pt x="103557" y="515426"/>
+                      <a:pt x="110133" y="507206"/>
+                    </a:cubicBezTo>
+                    <a:lnTo>
+                      <a:pt x="180594" y="419100"/>
+                    </a:lnTo>
+                    <a:lnTo>
+                      <a:pt x="314706" y="419100"/>
+                    </a:lnTo>
+                    <a:lnTo>
+                      <a:pt x="385167" y="507206"/>
+                    </a:lnTo>
+                    <a:cubicBezTo>
+                      <a:pt x="391743" y="515426"/>
+                      <a:pt x="403737" y="516758"/>
+                      <a:pt x="411956" y="510183"/>
+                    </a:cubicBezTo>
+                    <a:cubicBezTo>
+                      <a:pt x="420176" y="503607"/>
+                      <a:pt x="421508" y="491613"/>
+                      <a:pt x="414933" y="483394"/>
+                    </a:cubicBezTo>
+                    <a:lnTo>
+                      <a:pt x="363474" y="419100"/>
+                    </a:lnTo>
+                    <a:lnTo>
+                      <a:pt x="457200" y="419100"/>
+                    </a:lnTo>
+                    <a:cubicBezTo>
+                      <a:pt x="478242" y="419100"/>
+                      <a:pt x="495300" y="402042"/>
+                      <a:pt x="495300" y="381000"/>
+                    </a:cubicBezTo>
+                    <a:lnTo>
+                      <a:pt x="495300" y="95250"/>
+                    </a:lnTo>
+                    <a:cubicBezTo>
+                      <a:pt x="495300" y="74208"/>
+                      <a:pt x="478242" y="57150"/>
+                      <a:pt x="457200" y="57150"/>
                     </a:cubicBezTo>
                     <a:close/>
                     <a:moveTo>
-                      <a:pt x="300037" y="212526"/>
+                      <a:pt x="457200" y="381000"/>
                     </a:moveTo>
-                    <a:cubicBezTo>
-                      <a:pt x="300037" y="219430"/>
-                      <a:pt x="294439" y="225027"/>
-                      <a:pt x="287535" y="225027"/>
-                    </a:cubicBezTo>
-                    <a:lnTo>
-                      <a:pt x="37505" y="225027"/>
-                    </a:lnTo>
-                    <a:cubicBezTo>
-                      <a:pt x="30600" y="225027"/>
-                      <a:pt x="25003" y="219430"/>
-                      <a:pt x="25003" y="212526"/>
-                    </a:cubicBezTo>
-                    <a:lnTo>
-                      <a:pt x="25003" y="37505"/>
-                    </a:lnTo>
-                    <a:cubicBezTo>
-                      <a:pt x="25003" y="30600"/>
-                      <a:pt x="30600" y="25003"/>
-                      <a:pt x="37505" y="25003"/>
-                    </a:cubicBezTo>
-                    <a:lnTo>
-                      <a:pt x="287535" y="25003"/>
-                    </a:lnTo>
-                    <a:cubicBezTo>
-                      <a:pt x="294439" y="25003"/>
-                      <a:pt x="300037" y="30600"/>
-                      <a:pt x="300037" y="37505"/>
-                    </a:cubicBezTo>
+                    <a:lnTo>
+                      <a:pt x="38100" y="381000"/>
+                    </a:lnTo>
+                    <a:lnTo>
+                      <a:pt x="38100" y="95250"/>
+                    </a:lnTo>
+                    <a:lnTo>
+                      <a:pt x="457200" y="95250"/>
+                    </a:lnTo>
+                    <a:lnTo>
+                      <a:pt x="457200" y="381000"/>
+                    </a:lnTo>
                     <a:close/>
                     <a:moveTo>
-                      <a:pt x="225027" y="287535"/>
+                      <a:pt x="190500" y="247650"/>
                     </a:moveTo>
-                    <a:cubicBezTo>
-                      <a:pt x="225027" y="294439"/>
-                      <a:pt x="219430" y="300037"/>
-                      <a:pt x="212526" y="300037"/>
-                    </a:cubicBezTo>
-                    <a:lnTo>
-                      <a:pt x="112514" y="300037"/>
-                    </a:lnTo>
-                    <a:cubicBezTo>
-                      <a:pt x="105609" y="300037"/>
-                      <a:pt x="100012" y="294439"/>
-                      <a:pt x="100012" y="287535"/>
-                    </a:cubicBezTo>
-                    <a:cubicBezTo>
-                      <a:pt x="100012" y="280631"/>
-                      <a:pt x="105609" y="275034"/>
-                      <a:pt x="112514" y="275034"/>
-                    </a:cubicBezTo>
-                    <a:lnTo>
-                      <a:pt x="212526" y="275034"/>
-                    </a:lnTo>
-                    <a:cubicBezTo>
-                      <a:pt x="219430" y="275034"/>
-                      <a:pt x="225027" y="280631"/>
-                      <a:pt x="225027" y="287535"/>
+                    <a:lnTo>
+                      <a:pt x="190500" y="304800"/>
+                    </a:lnTo>
+                    <a:cubicBezTo>
+                      <a:pt x="190500" y="315321"/>
+                      <a:pt x="181971" y="323850"/>
+                      <a:pt x="171450" y="323850"/>
+                    </a:cubicBezTo>
+                    <a:cubicBezTo>
+                      <a:pt x="160929" y="323850"/>
+                      <a:pt x="152400" y="315321"/>
+                      <a:pt x="152400" y="304800"/>
+                    </a:cubicBezTo>
+                    <a:lnTo>
+                      <a:pt x="152400" y="247650"/>
+                    </a:lnTo>
+                    <a:cubicBezTo>
+                      <a:pt x="152400" y="237129"/>
+                      <a:pt x="160929" y="228600"/>
+                      <a:pt x="171450" y="228600"/>
+                    </a:cubicBezTo>
+                    <a:cubicBezTo>
+                      <a:pt x="181971" y="228600"/>
+                      <a:pt x="190500" y="237129"/>
+                      <a:pt x="190500" y="247650"/>
+                    </a:cubicBezTo>
+                    <a:close/>
+                    <a:moveTo>
+                      <a:pt x="266700" y="209550"/>
+                    </a:moveTo>
+                    <a:lnTo>
+                      <a:pt x="266700" y="304800"/>
+                    </a:lnTo>
+                    <a:cubicBezTo>
+                      <a:pt x="266700" y="315321"/>
+                      <a:pt x="258171" y="323850"/>
+                      <a:pt x="247650" y="323850"/>
+                    </a:cubicBezTo>
+                    <a:cubicBezTo>
+                      <a:pt x="237129" y="323850"/>
+                      <a:pt x="228600" y="315321"/>
+                      <a:pt x="228600" y="304800"/>
+                    </a:cubicBezTo>
+                    <a:lnTo>
+                      <a:pt x="228600" y="209550"/>
+                    </a:lnTo>
+                    <a:cubicBezTo>
+                      <a:pt x="228600" y="199029"/>
+                      <a:pt x="237129" y="190500"/>
+                      <a:pt x="247650" y="190500"/>
+                    </a:cubicBezTo>
+                    <a:cubicBezTo>
+                      <a:pt x="258171" y="190500"/>
+                      <a:pt x="266700" y="199029"/>
+                      <a:pt x="266700" y="209550"/>
+                    </a:cubicBezTo>
+                    <a:close/>
+                    <a:moveTo>
+                      <a:pt x="342900" y="171450"/>
+                    </a:moveTo>
+                    <a:lnTo>
+                      <a:pt x="342900" y="304800"/>
+                    </a:lnTo>
+                    <a:cubicBezTo>
+                      <a:pt x="342900" y="315321"/>
+                      <a:pt x="334371" y="323850"/>
+                      <a:pt x="323850" y="323850"/>
+                    </a:cubicBezTo>
+                    <a:cubicBezTo>
+                      <a:pt x="313329" y="323850"/>
+                      <a:pt x="304800" y="315321"/>
+                      <a:pt x="304800" y="304800"/>
+                    </a:cubicBezTo>
+                    <a:lnTo>
+                      <a:pt x="304800" y="171450"/>
+                    </a:lnTo>
+                    <a:cubicBezTo>
+                      <a:pt x="304800" y="160929"/>
+                      <a:pt x="313329" y="152400"/>
+                      <a:pt x="323850" y="152400"/>
+                    </a:cubicBezTo>
+                    <a:cubicBezTo>
+                      <a:pt x="334371" y="152400"/>
+                      <a:pt x="342900" y="160929"/>
+                      <a:pt x="342900" y="171450"/>
                     </a:cubicBezTo>
                     <a:close/>
                   </a:path>
@@ -2361,14 +2982,14 @@
         </p:grpSp>
         <p:sp>
           <p:nvSpPr>
-            <p:cNvPr id="27" name="TextBox 27"/>
+            <p:cNvPr id="33" name="TextBox 33"/>
             <p:cNvSpPr txBox="1"/>
             <p:nvPr/>
           </p:nvSpPr>
           <p:spPr>
             <a:xfrm>
-              <a:off x="8356854" y="3556000"/>
-              <a:ext cx="530913" cy="234696"/>
+              <a:off x="9895182" y="3098800"/>
+              <a:ext cx="212136" cy="234696"/>
             </a:xfrm>
             <a:prstGeom prst="rect">
               <a:avLst/>
@@ -2384,7 +3005,7 @@
             </a:bodyPr>
             <a:lstStyle/>
             <a:p>
-              <a:pPr algn="l"/>
+              <a:pPr algn="ctr"/>
               <a:r>
                 <a:rPr lang="en" sz="1200" b="1" dirty="0">
                   <a:solidFill>
@@ -2394,21 +3015,21 @@
                   <a:ea typeface="+mn-ea"/>
                   <a:cs typeface="+mn-cs"/>
                 </a:rPr>
-                <a:t>10 MIN</a:t>
+                <a:t>TO</a:t>
               </a:r>
             </a:p>
           </p:txBody>
         </p:sp>
         <p:sp>
           <p:nvSpPr>
-            <p:cNvPr id="28" name="TextBox 28"/>
+            <p:cNvPr id="34" name="TextBox 34"/>
             <p:cNvSpPr txBox="1"/>
             <p:nvPr/>
           </p:nvSpPr>
           <p:spPr>
             <a:xfrm>
-              <a:off x="8353806" y="3727450"/>
-              <a:ext cx="950744" cy="352044"/>
+              <a:off x="8852456" y="3422650"/>
+              <a:ext cx="2297587" cy="410718"/>
             </a:xfrm>
             <a:prstGeom prst="rect">
               <a:avLst/>
@@ -2424,9 +3045,9 @@
             </a:bodyPr>
             <a:lstStyle/>
             <a:p>
-              <a:pPr algn="l"/>
+              <a:pPr algn="ctr"/>
               <a:r>
-                <a:rPr lang="en" sz="1800" b="1" dirty="0">
+                <a:rPr lang="en" sz="2100" b="1" dirty="0">
                   <a:solidFill>
                     <a:schemeClr val="dk1"/>
                   </a:solidFill>
@@ -2434,25 +3055,80 @@
                   <a:ea typeface="+mn-ea"/>
                   <a:cs typeface="+mn-cs"/>
                 </a:rPr>
-                <a:t>3 screens</a:t>
+                <a:t>Something to show</a:t>
               </a:r>
             </a:p>
           </p:txBody>
         </p:sp>
         <p:sp>
           <p:nvSpPr>
-            <p:cNvPr id="29" name="Rectangle 29"/>
-            <p:cNvSpPr/>
+            <p:cNvPr id="35" name="TextBox 35"/>
+            <p:cNvSpPr txBox="1"/>
             <p:nvPr/>
           </p:nvSpPr>
           <p:spPr>
             <a:xfrm>
-              <a:off x="7696200" y="4457700"/>
-              <a:ext cx="3714750" cy="742950"/>
+              <a:off x="9100873" y="3879850"/>
+              <a:ext cx="1800753" cy="352044"/>
+            </a:xfrm>
+            <a:prstGeom prst="rect">
+              <a:avLst/>
+            </a:prstGeom>
+            <a:noFill/>
+            <a:ln>
+              <a:noFill/>
+            </a:ln>
+          </p:spPr>
+          <p:txBody>
+            <a:bodyPr wrap="none" lIns="0" tIns="0" rIns="0" bIns="0" anchor="t" anchorCtr="0">
+              <a:spAutoFit/>
+            </a:bodyPr>
+            <a:lstStyle/>
+            <a:p>
+              <a:pPr algn="ctr"/>
+              <a:r>
+                <a:rPr lang="en" sz="1800" dirty="0">
+                  <a:solidFill>
+                    <a:schemeClr val="accent5"/>
+                  </a:solidFill>
+                  <a:latin typeface="+mn-lt"/>
+                  <a:ea typeface="+mn-ea"/>
+                  <a:cs typeface="+mn-cs"/>
+                </a:rPr>
+                <a:t>In ninety seconds.</a:t>
+              </a:r>
+            </a:p>
+          </p:txBody>
+        </p:sp>
+      </p:grpSp>
+      <p:grpSp>
+        <p:nvGrpSpPr>
+          <p:cNvPr id="40" name="promise"/>
+          <p:cNvGrpSpPr/>
+          <p:nvPr/>
+        </p:nvGrpSpPr>
+        <p:grpSpPr>
+          <a:xfrm>
+            <a:off x="457200" y="5791200"/>
+            <a:ext cx="11182350" cy="704850"/>
+            <a:chOff x="457200" y="5791200"/>
+            <a:chExt cx="11182350" cy="704850"/>
+          </a:xfrm>
+        </p:grpSpPr>
+        <p:sp>
+          <p:nvSpPr>
+            <p:cNvPr id="37" name="Rectangle 37"/>
+            <p:cNvSpPr/>
+            <p:nvPr/>
+          </p:nvSpPr>
+          <p:spPr>
+            <a:xfrm>
+              <a:off x="552450" y="5886450"/>
+              <a:ext cx="11087100" cy="609600"/>
             </a:xfrm>
             <a:prstGeom prst="roundRect">
               <a:avLst>
-                <a:gd name="adj" fmla="val 28205"/>
+                <a:gd name="adj" fmla="val 34375"/>
               </a:avLst>
             </a:prstGeom>
             <a:solidFill>
@@ -2467,18 +3143,18 @@
         </p:sp>
         <p:sp>
           <p:nvSpPr>
-            <p:cNvPr id="30" name="Rectangle 30"/>
+            <p:cNvPr id="38" name="Rectangle 38"/>
             <p:cNvSpPr/>
             <p:nvPr/>
           </p:nvSpPr>
           <p:spPr>
             <a:xfrm>
-              <a:off x="7620000" y="4343400"/>
-              <a:ext cx="3714750" cy="742950"/>
+              <a:off x="457200" y="5791200"/>
+              <a:ext cx="11087100" cy="609600"/>
             </a:xfrm>
             <a:prstGeom prst="roundRect">
               <a:avLst>
-                <a:gd name="adj" fmla="val 28205"/>
+                <a:gd name="adj" fmla="val 34375"/>
               </a:avLst>
             </a:prstGeom>
             <a:solidFill>
@@ -2496,253 +3172,16 @@
             </a:effectLst>
           </p:spPr>
         </p:sp>
-        <p:grpSp>
-          <p:nvGrpSpPr>
-            <p:cNvPr id="33" name="Group 33"/>
-            <p:cNvGrpSpPr/>
-            <p:nvPr/>
-          </p:nvGrpSpPr>
-          <p:grpSpPr>
-            <a:xfrm>
-              <a:off x="7835503" y="4589859"/>
-              <a:ext cx="350043" cy="262532"/>
-              <a:chOff x="7835503" y="4589859"/>
-              <a:chExt cx="350043" cy="262532"/>
-            </a:xfrm>
-          </p:grpSpPr>
-          <p:sp>
-            <p:nvSpPr>
-              <p:cNvPr id="31" name="Freeform 31"/>
-              <p:cNvSpPr/>
-              <p:nvPr/>
-            </p:nvSpPr>
-            <p:spPr>
-              <a:xfrm>
-                <a:off x="7873008" y="4602361"/>
-                <a:ext cx="275034" cy="187523"/>
-              </a:xfrm>
-              <a:custGeom>
-                <a:avLst/>
-                <a:gdLst/>
-                <a:ahLst/>
-                <a:cxnLst/>
-                <a:rect l="l" t="t" r="r" b="b"/>
-                <a:pathLst>
-                  <a:path w="275034" h="187523">
-                    <a:moveTo>
-                      <a:pt x="275034" y="25003"/>
-                    </a:moveTo>
-                    <a:lnTo>
-                      <a:pt x="275034" y="187523"/>
-                    </a:lnTo>
-                    <a:lnTo>
-                      <a:pt x="0" y="187523"/>
-                    </a:lnTo>
-                    <a:lnTo>
-                      <a:pt x="0" y="25003"/>
-                    </a:lnTo>
-                    <a:cubicBezTo>
-                      <a:pt x="0" y="11194"/>
-                      <a:pt x="11194" y="0"/>
-                      <a:pt x="25003" y="0"/>
-                    </a:cubicBezTo>
-                    <a:lnTo>
-                      <a:pt x="250030" y="0"/>
-                    </a:lnTo>
-                    <a:cubicBezTo>
-                      <a:pt x="263839" y="0"/>
-                      <a:pt x="275034" y="11194"/>
-                      <a:pt x="275034" y="25003"/>
-                    </a:cubicBezTo>
-                    <a:close/>
-                  </a:path>
-                </a:pathLst>
-              </a:custGeom>
-              <a:solidFill>
-                <a:schemeClr val="accent1">
-                  <a:alpha val="20000"/>
-                </a:schemeClr>
-              </a:solidFill>
-              <a:ln>
-                <a:noFill/>
-              </a:ln>
-            </p:spPr>
-          </p:sp>
-          <p:sp>
-            <p:nvSpPr>
-              <p:cNvPr id="32" name="Freeform 32"/>
-              <p:cNvSpPr/>
-              <p:nvPr/>
-            </p:nvSpPr>
-            <p:spPr>
-              <a:xfrm>
-                <a:off x="7835503" y="4589859"/>
-                <a:ext cx="350043" cy="262532"/>
-              </a:xfrm>
-              <a:custGeom>
-                <a:avLst/>
-                <a:gdLst/>
-                <a:ahLst/>
-                <a:cxnLst/>
-                <a:rect l="l" t="t" r="r" b="b"/>
-                <a:pathLst>
-                  <a:path w="350043" h="262532">
-                    <a:moveTo>
-                      <a:pt x="337541" y="187523"/>
-                    </a:moveTo>
-                    <a:lnTo>
-                      <a:pt x="325040" y="187523"/>
-                    </a:lnTo>
-                    <a:lnTo>
-                      <a:pt x="325040" y="37505"/>
-                    </a:lnTo>
-                    <a:cubicBezTo>
-                      <a:pt x="325040" y="16791"/>
-                      <a:pt x="308248" y="0"/>
-                      <a:pt x="287535" y="0"/>
-                    </a:cubicBezTo>
-                    <a:lnTo>
-                      <a:pt x="62508" y="0"/>
-                    </a:lnTo>
-                    <a:cubicBezTo>
-                      <a:pt x="41794" y="0"/>
-                      <a:pt x="25003" y="16791"/>
-                      <a:pt x="25003" y="37505"/>
-                    </a:cubicBezTo>
-                    <a:lnTo>
-                      <a:pt x="25003" y="187523"/>
-                    </a:lnTo>
-                    <a:lnTo>
-                      <a:pt x="12502" y="187523"/>
-                    </a:lnTo>
-                    <a:cubicBezTo>
-                      <a:pt x="5597" y="187523"/>
-                      <a:pt x="0" y="193120"/>
-                      <a:pt x="0" y="200024"/>
-                    </a:cubicBezTo>
-                    <a:lnTo>
-                      <a:pt x="0" y="225027"/>
-                    </a:lnTo>
-                    <a:cubicBezTo>
-                      <a:pt x="0" y="245741"/>
-                      <a:pt x="16791" y="262532"/>
-                      <a:pt x="37505" y="262532"/>
-                    </a:cubicBezTo>
-                    <a:lnTo>
-                      <a:pt x="312538" y="262532"/>
-                    </a:lnTo>
-                    <a:cubicBezTo>
-                      <a:pt x="333251" y="262532"/>
-                      <a:pt x="350043" y="245741"/>
-                      <a:pt x="350043" y="225027"/>
-                    </a:cubicBezTo>
-                    <a:lnTo>
-                      <a:pt x="350043" y="200024"/>
-                    </a:lnTo>
-                    <a:cubicBezTo>
-                      <a:pt x="350043" y="193120"/>
-                      <a:pt x="344446" y="187523"/>
-                      <a:pt x="337541" y="187523"/>
-                    </a:cubicBezTo>
-                    <a:close/>
-                    <a:moveTo>
-                      <a:pt x="50006" y="37505"/>
-                    </a:moveTo>
-                    <a:cubicBezTo>
-                      <a:pt x="50006" y="30600"/>
-                      <a:pt x="55603" y="25003"/>
-                      <a:pt x="62508" y="25003"/>
-                    </a:cubicBezTo>
-                    <a:lnTo>
-                      <a:pt x="287535" y="25003"/>
-                    </a:lnTo>
-                    <a:cubicBezTo>
-                      <a:pt x="294439" y="25003"/>
-                      <a:pt x="300037" y="30600"/>
-                      <a:pt x="300037" y="37505"/>
-                    </a:cubicBezTo>
-                    <a:lnTo>
-                      <a:pt x="300037" y="187523"/>
-                    </a:lnTo>
-                    <a:lnTo>
-                      <a:pt x="50006" y="187523"/>
-                    </a:lnTo>
-                    <a:close/>
-                    <a:moveTo>
-                      <a:pt x="325040" y="225027"/>
-                    </a:moveTo>
-                    <a:cubicBezTo>
-                      <a:pt x="325040" y="231932"/>
-                      <a:pt x="319443" y="237529"/>
-                      <a:pt x="312538" y="237529"/>
-                    </a:cubicBezTo>
-                    <a:lnTo>
-                      <a:pt x="37505" y="237529"/>
-                    </a:lnTo>
-                    <a:cubicBezTo>
-                      <a:pt x="30600" y="237529"/>
-                      <a:pt x="25003" y="231932"/>
-                      <a:pt x="25003" y="225027"/>
-                    </a:cubicBezTo>
-                    <a:lnTo>
-                      <a:pt x="25003" y="212526"/>
-                    </a:lnTo>
-                    <a:lnTo>
-                      <a:pt x="325040" y="212526"/>
-                    </a:lnTo>
-                    <a:close/>
-                    <a:moveTo>
-                      <a:pt x="212526" y="62508"/>
-                    </a:moveTo>
-                    <a:cubicBezTo>
-                      <a:pt x="212526" y="69412"/>
-                      <a:pt x="206929" y="75009"/>
-                      <a:pt x="200024" y="75009"/>
-                    </a:cubicBezTo>
-                    <a:lnTo>
-                      <a:pt x="150018" y="75009"/>
-                    </a:lnTo>
-                    <a:cubicBezTo>
-                      <a:pt x="143114" y="75009"/>
-                      <a:pt x="137517" y="69412"/>
-                      <a:pt x="137517" y="62508"/>
-                    </a:cubicBezTo>
-                    <a:cubicBezTo>
-                      <a:pt x="137517" y="55603"/>
-                      <a:pt x="143114" y="50006"/>
-                      <a:pt x="150018" y="50006"/>
-                    </a:cubicBezTo>
-                    <a:lnTo>
-                      <a:pt x="200024" y="50006"/>
-                    </a:lnTo>
-                    <a:cubicBezTo>
-                      <a:pt x="206929" y="50006"/>
-                      <a:pt x="212526" y="55603"/>
-                      <a:pt x="212526" y="62508"/>
-                    </a:cubicBezTo>
-                    <a:close/>
-                  </a:path>
-                </a:pathLst>
-              </a:custGeom>
-              <a:solidFill>
-                <a:schemeClr val="accent1"/>
-              </a:solidFill>
-              <a:ln>
-                <a:noFill/>
-              </a:ln>
-            </p:spPr>
-          </p:sp>
-        </p:grpSp>
         <p:sp>
           <p:nvSpPr>
-            <p:cNvPr id="34" name="TextBox 34"/>
+            <p:cNvPr id="39" name="TextBox 39"/>
             <p:cNvSpPr txBox="1"/>
             <p:nvPr/>
           </p:nvSpPr>
           <p:spPr>
             <a:xfrm>
-              <a:off x="8356854" y="4508500"/>
-              <a:ext cx="530913" cy="234696"/>
+              <a:off x="4058777" y="5975350"/>
+              <a:ext cx="4074447" cy="352044"/>
             </a:xfrm>
             <a:prstGeom prst="rect">
               <a:avLst/>
@@ -2758,47 +3197,7 @@
             </a:bodyPr>
             <a:lstStyle/>
             <a:p>
-              <a:pPr algn="l"/>
-              <a:r>
-                <a:rPr lang="en" sz="1200" b="1" dirty="0">
-                  <a:solidFill>
-                    <a:schemeClr val="accent1"/>
-                  </a:solidFill>
-                  <a:latin typeface="+mn-lt"/>
-                  <a:ea typeface="+mn-ea"/>
-                  <a:cs typeface="+mn-cs"/>
-                </a:rPr>
-                <a:t>15 MIN</a:t>
-              </a:r>
-            </a:p>
-          </p:txBody>
-        </p:sp>
-        <p:sp>
-          <p:nvSpPr>
-            <p:cNvPr id="35" name="TextBox 35"/>
-            <p:cNvSpPr txBox="1"/>
-            <p:nvPr/>
-          </p:nvSpPr>
-          <p:spPr>
-            <a:xfrm>
-              <a:off x="8353806" y="4679950"/>
-              <a:ext cx="1035076" cy="352044"/>
-            </a:xfrm>
-            <a:prstGeom prst="rect">
-              <a:avLst/>
-            </a:prstGeom>
-            <a:noFill/>
-            <a:ln>
-              <a:noFill/>
-            </a:ln>
-          </p:spPr>
-          <p:txBody>
-            <a:bodyPr wrap="none" lIns="0" tIns="0" rIns="0" bIns="0" anchor="t" anchorCtr="0">
-              <a:spAutoFit/>
-            </a:bodyPr>
-            <a:lstStyle/>
-            <a:p>
-              <a:pPr algn="l"/>
+              <a:pPr algn="ctr"/>
               <a:r>
                 <a:rPr lang="en" sz="1800" b="1" dirty="0">
                   <a:solidFill>
@@ -2808,7 +3207,7 @@
                   <a:ea typeface="+mn-ea"/>
                   <a:cs typeface="+mn-cs"/>
                 </a:rPr>
-                <a:t>Prototype</a:t>
+                <a:t>One live demo. Then your group does it.</a:t>
               </a:r>
             </a:p>
           </p:txBody>

</xml_diff>

<commit_message>
Give every slide a luminous red-to-violet gradient.
</commit_message>
<xml_diff>
--- a/docs/Wealth-Symposium-Activity.pptx
+++ b/docs/Wealth-Symposium-Activity.pptx
@@ -1162,13 +1162,13 @@
         <a:gradFill>
           <a:gsLst>
             <a:gs pos="0">
-              <a:srgbClr val="FFF1F2"/>
+              <a:srgbClr val="FFE4F2"/>
             </a:gs>
-            <a:gs pos="42000">
-              <a:schemeClr val="lt2"/>
+            <a:gs pos="46000">
+              <a:srgbClr val="E4DCFF"/>
             </a:gs>
             <a:gs pos="100000">
-              <a:schemeClr val="lt1"/>
+              <a:srgbClr val="DCEBFF"/>
             </a:gs>
           </a:gsLst>
           <a:lin ang="2700000" scaled="1"/>
@@ -1190,9 +1190,117 @@
           <a:chExt cx="0" cy="0"/>
         </a:xfrm>
       </p:grpSpPr>
+      <p:sp>
+        <p:nvSpPr>
+          <p:cNvPr id="2" name="glow-a"/>
+          <p:cNvSpPr/>
+          <p:nvPr/>
+        </p:nvSpPr>
+        <p:spPr>
+          <a:xfrm>
+            <a:off x="-3810000" y="-3238500"/>
+            <a:ext cx="10668000" cy="7239000"/>
+          </a:xfrm>
+          <a:prstGeom prst="ellipse">
+            <a:avLst/>
+          </a:prstGeom>
+          <a:gradFill>
+            <a:gsLst>
+              <a:gs pos="0">
+                <a:srgbClr val="FF4D6A">
+                  <a:alpha val="72000"/>
+                </a:srgbClr>
+              </a:gs>
+              <a:gs pos="100000">
+                <a:srgbClr val="FF4D6A">
+                  <a:alpha val="0"/>
+                </a:srgbClr>
+              </a:gs>
+            </a:gsLst>
+            <a:path path="circle">
+              <a:fillToRect l="50000" t="50000" r="50000" b="50000"/>
+            </a:path>
+          </a:gradFill>
+          <a:ln>
+            <a:noFill/>
+          </a:ln>
+        </p:spPr>
+      </p:sp>
+      <p:sp>
+        <p:nvSpPr>
+          <p:cNvPr id="3" name="glow-b"/>
+          <p:cNvSpPr/>
+          <p:nvPr/>
+        </p:nvSpPr>
+        <p:spPr>
+          <a:xfrm>
+            <a:off x="6096000" y="3238500"/>
+            <a:ext cx="9906000" cy="6858000"/>
+          </a:xfrm>
+          <a:prstGeom prst="ellipse">
+            <a:avLst/>
+          </a:prstGeom>
+          <a:gradFill>
+            <a:gsLst>
+              <a:gs pos="0">
+                <a:srgbClr val="6E63FF">
+                  <a:alpha val="62000"/>
+                </a:srgbClr>
+              </a:gs>
+              <a:gs pos="100000">
+                <a:srgbClr val="6E63FF">
+                  <a:alpha val="0"/>
+                </a:srgbClr>
+              </a:gs>
+            </a:gsLst>
+            <a:path path="circle">
+              <a:fillToRect l="50000" t="50000" r="50000" b="50000"/>
+            </a:path>
+          </a:gradFill>
+          <a:ln>
+            <a:noFill/>
+          </a:ln>
+        </p:spPr>
+      </p:sp>
+      <p:sp>
+        <p:nvSpPr>
+          <p:cNvPr id="4" name="glow-c"/>
+          <p:cNvSpPr/>
+          <p:nvPr/>
+        </p:nvSpPr>
+        <p:spPr>
+          <a:xfrm>
+            <a:off x="2095500" y="381000"/>
+            <a:ext cx="8001000" cy="4953000"/>
+          </a:xfrm>
+          <a:prstGeom prst="ellipse">
+            <a:avLst/>
+          </a:prstGeom>
+          <a:gradFill>
+            <a:gsLst>
+              <a:gs pos="0">
+                <a:srgbClr val="FFFFFF">
+                  <a:alpha val="85000"/>
+                </a:srgbClr>
+              </a:gs>
+              <a:gs pos="100000">
+                <a:srgbClr val="FFFFFF">
+                  <a:alpha val="0"/>
+                </a:srgbClr>
+              </a:gs>
+            </a:gsLst>
+            <a:path path="circle">
+              <a:fillToRect l="50000" t="50000" r="50000" b="50000"/>
+            </a:path>
+          </a:gradFill>
+          <a:ln>
+            <a:noFill/>
+          </a:ln>
+        </p:spPr>
+      </p:sp>
       <p:grpSp>
         <p:nvGrpSpPr>
-          <p:cNvPr id="5" name="title-block"/>
+          <p:cNvPr id="8" name="title-block"/>
           <p:cNvGrpSpPr/>
           <p:nvPr/>
         </p:nvGrpSpPr>
@@ -1206,7 +1314,7 @@
         </p:grpSpPr>
         <p:sp>
           <p:nvSpPr>
-            <p:cNvPr id="2" name="TextBox 2"/>
+            <p:cNvPr id="5" name="TextBox 5"/>
             <p:cNvSpPr txBox="1"/>
             <p:nvPr/>
           </p:nvSpPr>
@@ -1246,7 +1354,7 @@
         </p:sp>
         <p:sp>
           <p:nvSpPr>
-            <p:cNvPr id="3" name="TextBox 3"/>
+            <p:cNvPr id="6" name="TextBox 6"/>
             <p:cNvSpPr txBox="1"/>
             <p:nvPr/>
           </p:nvSpPr>
@@ -1286,7 +1394,7 @@
         </p:sp>
         <p:sp>
           <p:nvSpPr>
-            <p:cNvPr id="4" name="TextBox 4"/>
+            <p:cNvPr id="7" name="TextBox 7"/>
             <p:cNvSpPr txBox="1"/>
             <p:nvPr/>
           </p:nvSpPr>
@@ -1327,7 +1435,7 @@
       </p:grpSp>
       <p:grpSp>
         <p:nvGrpSpPr>
-          <p:cNvPr id="36" name="transformation"/>
+          <p:cNvPr id="39" name="transformation"/>
           <p:cNvGrpSpPr/>
           <p:nvPr/>
         </p:nvGrpSpPr>
@@ -1341,7 +1449,7 @@
         </p:grpSpPr>
         <p:sp>
           <p:nvSpPr>
-            <p:cNvPr id="6" name="Rectangle 6"/>
+            <p:cNvPr id="9" name="Rectangle 9"/>
             <p:cNvSpPr/>
             <p:nvPr/>
           </p:nvSpPr>
@@ -1367,7 +1475,7 @@
         </p:sp>
         <p:sp>
           <p:nvSpPr>
-            <p:cNvPr id="7" name="Rectangle 7"/>
+            <p:cNvPr id="10" name="Rectangle 10"/>
             <p:cNvSpPr/>
             <p:nvPr/>
           </p:nvSpPr>
@@ -1382,7 +1490,9 @@
               </a:avLst>
             </a:prstGeom>
             <a:solidFill>
-              <a:srgbClr val="FFFFFF"/>
+              <a:srgbClr val="FFFFFF">
+                <a:alpha val="86000"/>
+              </a:srgbClr>
             </a:solidFill>
             <a:ln>
               <a:noFill/>
@@ -1398,7 +1508,7 @@
         </p:sp>
         <p:grpSp>
           <p:nvGrpSpPr>
-            <p:cNvPr id="10" name="Group 10"/>
+            <p:cNvPr id="13" name="Group 13"/>
             <p:cNvGrpSpPr/>
             <p:nvPr/>
           </p:nvGrpSpPr>
@@ -1412,7 +1522,7 @@
           </p:grpSpPr>
           <p:sp>
             <p:nvSpPr>
-              <p:cNvPr id="8" name="Freeform 8"/>
+              <p:cNvPr id="11" name="Freeform 11"/>
               <p:cNvSpPr/>
               <p:nvPr/>
             </p:nvSpPr>
@@ -1480,7 +1590,7 @@
           </p:sp>
           <p:sp>
             <p:nvSpPr>
-              <p:cNvPr id="9" name="Freeform 9"/>
+              <p:cNvPr id="12" name="Freeform 12"/>
               <p:cNvSpPr/>
               <p:nvPr/>
             </p:nvSpPr>
@@ -1604,7 +1714,7 @@
         </p:grpSp>
         <p:sp>
           <p:nvSpPr>
-            <p:cNvPr id="11" name="TextBox 11"/>
+            <p:cNvPr id="14" name="TextBox 14"/>
             <p:cNvSpPr txBox="1"/>
             <p:nvPr/>
           </p:nvSpPr>
@@ -1644,7 +1754,7 @@
         </p:sp>
         <p:sp>
           <p:nvSpPr>
-            <p:cNvPr id="12" name="TextBox 12"/>
+            <p:cNvPr id="15" name="TextBox 15"/>
             <p:cNvSpPr txBox="1"/>
             <p:nvPr/>
           </p:nvSpPr>
@@ -1684,7 +1794,7 @@
         </p:sp>
         <p:sp>
           <p:nvSpPr>
-            <p:cNvPr id="13" name="TextBox 13"/>
+            <p:cNvPr id="16" name="TextBox 16"/>
             <p:cNvSpPr txBox="1"/>
             <p:nvPr/>
           </p:nvSpPr>
@@ -1724,7 +1834,7 @@
         </p:sp>
         <p:grpSp>
           <p:nvGrpSpPr>
-            <p:cNvPr id="16" name="Group 16"/>
+            <p:cNvPr id="19" name="Group 19"/>
             <p:cNvGrpSpPr/>
             <p:nvPr/>
           </p:nvGrpSpPr>
@@ -1738,7 +1848,7 @@
           </p:grpSpPr>
           <p:sp>
             <p:nvSpPr>
-              <p:cNvPr id="14" name="Freeform 14"/>
+              <p:cNvPr id="17" name="Freeform 17"/>
               <p:cNvSpPr/>
               <p:nvPr/>
             </p:nvSpPr>
@@ -1780,7 +1890,7 @@
           </p:sp>
           <p:sp>
             <p:nvSpPr>
-              <p:cNvPr id="15" name="Freeform 15"/>
+              <p:cNvPr id="18" name="Freeform 18"/>
               <p:cNvSpPr/>
               <p:nvPr/>
             </p:nvSpPr>
@@ -1883,7 +1993,7 @@
         </p:grpSp>
         <p:sp>
           <p:nvSpPr>
-            <p:cNvPr id="17" name="Rectangle 17"/>
+            <p:cNvPr id="20" name="Rectangle 20"/>
             <p:cNvSpPr/>
             <p:nvPr/>
           </p:nvSpPr>
@@ -1909,7 +2019,7 @@
         </p:sp>
         <p:sp>
           <p:nvSpPr>
-            <p:cNvPr id="18" name="Rectangle 18"/>
+            <p:cNvPr id="21" name="Rectangle 21"/>
             <p:cNvSpPr/>
             <p:nvPr/>
           </p:nvSpPr>
@@ -1924,7 +2034,9 @@
               </a:avLst>
             </a:prstGeom>
             <a:solidFill>
-              <a:srgbClr val="FFFFFF"/>
+              <a:srgbClr val="FFFFFF">
+                <a:alpha val="86000"/>
+              </a:srgbClr>
             </a:solidFill>
             <a:ln>
               <a:noFill/>
@@ -1940,7 +2052,7 @@
         </p:sp>
         <p:grpSp>
           <p:nvGrpSpPr>
-            <p:cNvPr id="21" name="Group 21"/>
+            <p:cNvPr id="24" name="Group 24"/>
             <p:cNvGrpSpPr/>
             <p:nvPr/>
           </p:nvGrpSpPr>
@@ -1954,7 +2066,7 @@
           </p:grpSpPr>
           <p:sp>
             <p:nvSpPr>
-              <p:cNvPr id="19" name="Freeform 19"/>
+              <p:cNvPr id="22" name="Freeform 22"/>
               <p:cNvSpPr/>
               <p:nvPr/>
             </p:nvSpPr>
@@ -2054,7 +2166,7 @@
           </p:sp>
           <p:sp>
             <p:nvSpPr>
-              <p:cNvPr id="20" name="Freeform 20"/>
+              <p:cNvPr id="23" name="Freeform 23"/>
               <p:cNvSpPr/>
               <p:nvPr/>
             </p:nvSpPr>
@@ -2334,7 +2446,7 @@
         </p:grpSp>
         <p:sp>
           <p:nvSpPr>
-            <p:cNvPr id="22" name="TextBox 22"/>
+            <p:cNvPr id="25" name="TextBox 25"/>
             <p:cNvSpPr txBox="1"/>
             <p:nvPr/>
           </p:nvSpPr>
@@ -2374,7 +2486,7 @@
         </p:sp>
         <p:sp>
           <p:nvSpPr>
-            <p:cNvPr id="23" name="TextBox 23"/>
+            <p:cNvPr id="26" name="TextBox 26"/>
             <p:cNvSpPr txBox="1"/>
             <p:nvPr/>
           </p:nvSpPr>
@@ -2414,7 +2526,7 @@
         </p:sp>
         <p:sp>
           <p:nvSpPr>
-            <p:cNvPr id="24" name="TextBox 24"/>
+            <p:cNvPr id="27" name="TextBox 27"/>
             <p:cNvSpPr txBox="1"/>
             <p:nvPr/>
           </p:nvSpPr>
@@ -2454,7 +2566,7 @@
         </p:sp>
         <p:grpSp>
           <p:nvGrpSpPr>
-            <p:cNvPr id="27" name="Group 27"/>
+            <p:cNvPr id="30" name="Group 30"/>
             <p:cNvGrpSpPr/>
             <p:nvPr/>
           </p:nvGrpSpPr>
@@ -2468,7 +2580,7 @@
           </p:grpSpPr>
           <p:sp>
             <p:nvSpPr>
-              <p:cNvPr id="25" name="Freeform 25"/>
+              <p:cNvPr id="28" name="Freeform 28"/>
               <p:cNvSpPr/>
               <p:nvPr/>
             </p:nvSpPr>
@@ -2510,7 +2622,7 @@
           </p:sp>
           <p:sp>
             <p:nvSpPr>
-              <p:cNvPr id="26" name="Freeform 26"/>
+              <p:cNvPr id="29" name="Freeform 29"/>
               <p:cNvSpPr/>
               <p:nvPr/>
             </p:nvSpPr>
@@ -2613,7 +2725,7 @@
         </p:grpSp>
         <p:sp>
           <p:nvSpPr>
-            <p:cNvPr id="28" name="Rectangle 28"/>
+            <p:cNvPr id="31" name="Rectangle 31"/>
             <p:cNvSpPr/>
             <p:nvPr/>
           </p:nvSpPr>
@@ -2639,7 +2751,7 @@
         </p:sp>
         <p:sp>
           <p:nvSpPr>
-            <p:cNvPr id="29" name="Rectangle 29"/>
+            <p:cNvPr id="32" name="Rectangle 32"/>
             <p:cNvSpPr/>
             <p:nvPr/>
           </p:nvSpPr>
@@ -2654,7 +2766,9 @@
               </a:avLst>
             </a:prstGeom>
             <a:solidFill>
-              <a:srgbClr val="FFFFFF"/>
+              <a:srgbClr val="FFFFFF">
+                <a:alpha val="86000"/>
+              </a:srgbClr>
             </a:solidFill>
             <a:ln>
               <a:noFill/>
@@ -2670,7 +2784,7 @@
         </p:sp>
         <p:grpSp>
           <p:nvGrpSpPr>
-            <p:cNvPr id="32" name="Group 32"/>
+            <p:cNvPr id="35" name="Group 35"/>
             <p:cNvGrpSpPr/>
             <p:nvPr/>
           </p:nvGrpSpPr>
@@ -2684,7 +2798,7 @@
           </p:grpSpPr>
           <p:sp>
             <p:nvSpPr>
-              <p:cNvPr id="30" name="Freeform 30"/>
+              <p:cNvPr id="33" name="Freeform 33"/>
               <p:cNvSpPr/>
               <p:nvPr/>
             </p:nvSpPr>
@@ -2752,7 +2866,7 @@
           </p:sp>
           <p:sp>
             <p:nvSpPr>
-              <p:cNvPr id="31" name="Freeform 31"/>
+              <p:cNvPr id="34" name="Freeform 34"/>
               <p:cNvSpPr/>
               <p:nvPr/>
             </p:nvSpPr>
@@ -2982,7 +3096,7 @@
         </p:grpSp>
         <p:sp>
           <p:nvSpPr>
-            <p:cNvPr id="33" name="TextBox 33"/>
+            <p:cNvPr id="36" name="TextBox 36"/>
             <p:cNvSpPr txBox="1"/>
             <p:nvPr/>
           </p:nvSpPr>
@@ -3022,7 +3136,7 @@
         </p:sp>
         <p:sp>
           <p:nvSpPr>
-            <p:cNvPr id="34" name="TextBox 34"/>
+            <p:cNvPr id="37" name="TextBox 37"/>
             <p:cNvSpPr txBox="1"/>
             <p:nvPr/>
           </p:nvSpPr>
@@ -3062,7 +3176,7 @@
         </p:sp>
         <p:sp>
           <p:nvSpPr>
-            <p:cNvPr id="35" name="TextBox 35"/>
+            <p:cNvPr id="38" name="TextBox 38"/>
             <p:cNvSpPr txBox="1"/>
             <p:nvPr/>
           </p:nvSpPr>
@@ -3103,7 +3217,7 @@
       </p:grpSp>
       <p:grpSp>
         <p:nvGrpSpPr>
-          <p:cNvPr id="40" name="promise"/>
+          <p:cNvPr id="43" name="promise"/>
           <p:cNvGrpSpPr/>
           <p:nvPr/>
         </p:nvGrpSpPr>
@@ -3117,7 +3231,7 @@
         </p:grpSpPr>
         <p:sp>
           <p:nvSpPr>
-            <p:cNvPr id="37" name="Rectangle 37"/>
+            <p:cNvPr id="40" name="Rectangle 40"/>
             <p:cNvSpPr/>
             <p:nvPr/>
           </p:nvSpPr>
@@ -3143,7 +3257,7 @@
         </p:sp>
         <p:sp>
           <p:nvSpPr>
-            <p:cNvPr id="38" name="Rectangle 38"/>
+            <p:cNvPr id="41" name="Rectangle 41"/>
             <p:cNvSpPr/>
             <p:nvPr/>
           </p:nvSpPr>
@@ -3158,7 +3272,9 @@
               </a:avLst>
             </a:prstGeom>
             <a:solidFill>
-              <a:srgbClr val="FFFFFF"/>
+              <a:srgbClr val="FFFFFF">
+                <a:alpha val="86000"/>
+              </a:srgbClr>
             </a:solidFill>
             <a:ln>
               <a:noFill/>
@@ -3174,7 +3290,7 @@
         </p:sp>
         <p:sp>
           <p:nvSpPr>
-            <p:cNvPr id="39" name="TextBox 39"/>
+            <p:cNvPr id="42" name="TextBox 42"/>
             <p:cNvSpPr txBox="1"/>
             <p:nvPr/>
           </p:nvSpPr>
@@ -3232,13 +3348,13 @@
         <a:gradFill>
           <a:gsLst>
             <a:gs pos="0">
-              <a:srgbClr val="FFF1F2"/>
+              <a:srgbClr val="FFE4F2"/>
             </a:gs>
-            <a:gs pos="42000">
-              <a:schemeClr val="lt2"/>
+            <a:gs pos="46000">
+              <a:srgbClr val="E4DCFF"/>
             </a:gs>
             <a:gs pos="100000">
-              <a:schemeClr val="lt1"/>
+              <a:srgbClr val="DCEBFF"/>
             </a:gs>
           </a:gsLst>
           <a:lin ang="2700000" scaled="1"/>
@@ -3260,9 +3376,117 @@
           <a:chExt cx="0" cy="0"/>
         </a:xfrm>
       </p:grpSpPr>
+      <p:sp>
+        <p:nvSpPr>
+          <p:cNvPr id="2" name="glow-a"/>
+          <p:cNvSpPr/>
+          <p:nvPr/>
+        </p:nvSpPr>
+        <p:spPr>
+          <a:xfrm>
+            <a:off x="-3810000" y="-3238500"/>
+            <a:ext cx="10668000" cy="7239000"/>
+          </a:xfrm>
+          <a:prstGeom prst="ellipse">
+            <a:avLst/>
+          </a:prstGeom>
+          <a:gradFill>
+            <a:gsLst>
+              <a:gs pos="0">
+                <a:srgbClr val="FF4D6A">
+                  <a:alpha val="72000"/>
+                </a:srgbClr>
+              </a:gs>
+              <a:gs pos="100000">
+                <a:srgbClr val="FF4D6A">
+                  <a:alpha val="0"/>
+                </a:srgbClr>
+              </a:gs>
+            </a:gsLst>
+            <a:path path="circle">
+              <a:fillToRect l="50000" t="50000" r="50000" b="50000"/>
+            </a:path>
+          </a:gradFill>
+          <a:ln>
+            <a:noFill/>
+          </a:ln>
+        </p:spPr>
+      </p:sp>
+      <p:sp>
+        <p:nvSpPr>
+          <p:cNvPr id="3" name="glow-b"/>
+          <p:cNvSpPr/>
+          <p:nvPr/>
+        </p:nvSpPr>
+        <p:spPr>
+          <a:xfrm>
+            <a:off x="6096000" y="3238500"/>
+            <a:ext cx="9906000" cy="6858000"/>
+          </a:xfrm>
+          <a:prstGeom prst="ellipse">
+            <a:avLst/>
+          </a:prstGeom>
+          <a:gradFill>
+            <a:gsLst>
+              <a:gs pos="0">
+                <a:srgbClr val="6E63FF">
+                  <a:alpha val="62000"/>
+                </a:srgbClr>
+              </a:gs>
+              <a:gs pos="100000">
+                <a:srgbClr val="6E63FF">
+                  <a:alpha val="0"/>
+                </a:srgbClr>
+              </a:gs>
+            </a:gsLst>
+            <a:path path="circle">
+              <a:fillToRect l="50000" t="50000" r="50000" b="50000"/>
+            </a:path>
+          </a:gradFill>
+          <a:ln>
+            <a:noFill/>
+          </a:ln>
+        </p:spPr>
+      </p:sp>
+      <p:sp>
+        <p:nvSpPr>
+          <p:cNvPr id="4" name="glow-c"/>
+          <p:cNvSpPr/>
+          <p:nvPr/>
+        </p:nvSpPr>
+        <p:spPr>
+          <a:xfrm>
+            <a:off x="2095500" y="381000"/>
+            <a:ext cx="8001000" cy="4953000"/>
+          </a:xfrm>
+          <a:prstGeom prst="ellipse">
+            <a:avLst/>
+          </a:prstGeom>
+          <a:gradFill>
+            <a:gsLst>
+              <a:gs pos="0">
+                <a:srgbClr val="FFFFFF">
+                  <a:alpha val="85000"/>
+                </a:srgbClr>
+              </a:gs>
+              <a:gs pos="100000">
+                <a:srgbClr val="FFFFFF">
+                  <a:alpha val="0"/>
+                </a:srgbClr>
+              </a:gs>
+            </a:gsLst>
+            <a:path path="circle">
+              <a:fillToRect l="50000" t="50000" r="50000" b="50000"/>
+            </a:path>
+          </a:gradFill>
+          <a:ln>
+            <a:noFill/>
+          </a:ln>
+        </p:spPr>
+      </p:sp>
       <p:grpSp>
         <p:nvGrpSpPr>
-          <p:cNvPr id="4" name="header"/>
+          <p:cNvPr id="7" name="header"/>
           <p:cNvGrpSpPr/>
           <p:nvPr/>
         </p:nvGrpSpPr>
@@ -3276,7 +3500,7 @@
         </p:grpSpPr>
         <p:sp>
           <p:nvSpPr>
-            <p:cNvPr id="2" name="TextBox 2"/>
+            <p:cNvPr id="5" name="TextBox 5"/>
             <p:cNvSpPr txBox="1"/>
             <p:nvPr/>
           </p:nvSpPr>
@@ -3316,7 +3540,7 @@
         </p:sp>
         <p:sp>
           <p:nvSpPr>
-            <p:cNvPr id="3" name="TextBox 3"/>
+            <p:cNvPr id="6" name="TextBox 6"/>
             <p:cNvSpPr txBox="1"/>
             <p:nvPr/>
           </p:nvSpPr>
@@ -3357,7 +3581,7 @@
       </p:grpSp>
       <p:grpSp>
         <p:nvGrpSpPr>
-          <p:cNvPr id="41" name="steps"/>
+          <p:cNvPr id="44" name="steps"/>
           <p:cNvGrpSpPr/>
           <p:nvPr/>
         </p:nvGrpSpPr>
@@ -3371,7 +3595,7 @@
         </p:grpSpPr>
         <p:sp>
           <p:nvSpPr>
-            <p:cNvPr id="5" name="Rectangle 5"/>
+            <p:cNvPr id="8" name="Rectangle 8"/>
             <p:cNvSpPr/>
             <p:nvPr/>
           </p:nvSpPr>
@@ -3397,7 +3621,7 @@
         </p:sp>
         <p:sp>
           <p:nvSpPr>
-            <p:cNvPr id="6" name="Rectangle 6"/>
+            <p:cNvPr id="9" name="Rectangle 9"/>
             <p:cNvSpPr/>
             <p:nvPr/>
           </p:nvSpPr>
@@ -3412,7 +3636,9 @@
               </a:avLst>
             </a:prstGeom>
             <a:solidFill>
-              <a:srgbClr val="FFFFFF"/>
+              <a:srgbClr val="FFFFFF">
+                <a:alpha val="86000"/>
+              </a:srgbClr>
             </a:solidFill>
             <a:ln>
               <a:noFill/>
@@ -3428,7 +3654,7 @@
         </p:sp>
         <p:grpSp>
           <p:nvGrpSpPr>
-            <p:cNvPr id="9" name="Group 9"/>
+            <p:cNvPr id="12" name="Group 12"/>
             <p:cNvGrpSpPr/>
             <p:nvPr/>
           </p:nvGrpSpPr>
@@ -3442,7 +3668,7 @@
           </p:grpSpPr>
           <p:sp>
             <p:nvSpPr>
-              <p:cNvPr id="7" name="Freeform 7"/>
+              <p:cNvPr id="10" name="Freeform 10"/>
               <p:cNvSpPr/>
               <p:nvPr/>
             </p:nvSpPr>
@@ -3510,7 +3736,7 @@
           </p:sp>
           <p:sp>
             <p:nvSpPr>
-              <p:cNvPr id="8" name="Freeform 8"/>
+              <p:cNvPr id="11" name="Freeform 11"/>
               <p:cNvSpPr/>
               <p:nvPr/>
             </p:nvSpPr>
@@ -3634,7 +3860,7 @@
         </p:grpSp>
         <p:sp>
           <p:nvSpPr>
-            <p:cNvPr id="10" name="TextBox 10"/>
+            <p:cNvPr id="13" name="TextBox 13"/>
             <p:cNvSpPr txBox="1"/>
             <p:nvPr/>
           </p:nvSpPr>
@@ -3674,7 +3900,7 @@
         </p:sp>
         <p:sp>
           <p:nvSpPr>
-            <p:cNvPr id="11" name="TextBox 11"/>
+            <p:cNvPr id="14" name="TextBox 14"/>
             <p:cNvSpPr txBox="1"/>
             <p:nvPr/>
           </p:nvSpPr>
@@ -3714,7 +3940,7 @@
         </p:sp>
         <p:sp>
           <p:nvSpPr>
-            <p:cNvPr id="12" name="TextBox 12"/>
+            <p:cNvPr id="15" name="TextBox 15"/>
             <p:cNvSpPr txBox="1"/>
             <p:nvPr/>
           </p:nvSpPr>
@@ -3754,7 +3980,7 @@
         </p:sp>
         <p:sp>
           <p:nvSpPr>
-            <p:cNvPr id="13" name="TextBox 13"/>
+            <p:cNvPr id="16" name="TextBox 16"/>
             <p:cNvSpPr txBox="1"/>
             <p:nvPr/>
           </p:nvSpPr>
@@ -3794,7 +4020,7 @@
         </p:sp>
         <p:sp>
           <p:nvSpPr>
-            <p:cNvPr id="14" name="Rectangle 14"/>
+            <p:cNvPr id="17" name="Rectangle 17"/>
             <p:cNvSpPr/>
             <p:nvPr/>
           </p:nvSpPr>
@@ -3820,7 +4046,7 @@
         </p:sp>
         <p:sp>
           <p:nvSpPr>
-            <p:cNvPr id="15" name="Rectangle 15"/>
+            <p:cNvPr id="18" name="Rectangle 18"/>
             <p:cNvSpPr/>
             <p:nvPr/>
           </p:nvSpPr>
@@ -3835,7 +4061,9 @@
               </a:avLst>
             </a:prstGeom>
             <a:solidFill>
-              <a:srgbClr val="FFFFFF"/>
+              <a:srgbClr val="FFFFFF">
+                <a:alpha val="86000"/>
+              </a:srgbClr>
             </a:solidFill>
             <a:ln>
               <a:noFill/>
@@ -3851,7 +4079,7 @@
         </p:sp>
         <p:grpSp>
           <p:nvGrpSpPr>
-            <p:cNvPr id="18" name="Group 18"/>
+            <p:cNvPr id="21" name="Group 21"/>
             <p:cNvGrpSpPr/>
             <p:nvPr/>
           </p:nvGrpSpPr>
@@ -3865,7 +4093,7 @@
           </p:grpSpPr>
           <p:sp>
             <p:nvSpPr>
-              <p:cNvPr id="16" name="Freeform 16"/>
+              <p:cNvPr id="19" name="Freeform 19"/>
               <p:cNvSpPr/>
               <p:nvPr/>
             </p:nvSpPr>
@@ -3928,7 +4156,7 @@
           </p:sp>
           <p:sp>
             <p:nvSpPr>
-              <p:cNvPr id="17" name="Freeform 17"/>
+              <p:cNvPr id="20" name="Freeform 20"/>
               <p:cNvSpPr/>
               <p:nvPr/>
             </p:nvSpPr>
@@ -4042,7 +4270,7 @@
         </p:grpSp>
         <p:sp>
           <p:nvSpPr>
-            <p:cNvPr id="19" name="TextBox 19"/>
+            <p:cNvPr id="22" name="TextBox 22"/>
             <p:cNvSpPr txBox="1"/>
             <p:nvPr/>
           </p:nvSpPr>
@@ -4082,7 +4310,7 @@
         </p:sp>
         <p:sp>
           <p:nvSpPr>
-            <p:cNvPr id="20" name="TextBox 20"/>
+            <p:cNvPr id="23" name="TextBox 23"/>
             <p:cNvSpPr txBox="1"/>
             <p:nvPr/>
           </p:nvSpPr>
@@ -4122,7 +4350,7 @@
         </p:sp>
         <p:sp>
           <p:nvSpPr>
-            <p:cNvPr id="21" name="TextBox 21"/>
+            <p:cNvPr id="24" name="TextBox 24"/>
             <p:cNvSpPr txBox="1"/>
             <p:nvPr/>
           </p:nvSpPr>
@@ -4162,7 +4390,7 @@
         </p:sp>
         <p:sp>
           <p:nvSpPr>
-            <p:cNvPr id="22" name="TextBox 22"/>
+            <p:cNvPr id="25" name="TextBox 25"/>
             <p:cNvSpPr txBox="1"/>
             <p:nvPr/>
           </p:nvSpPr>
@@ -4202,7 +4430,7 @@
         </p:sp>
         <p:sp>
           <p:nvSpPr>
-            <p:cNvPr id="23" name="Rectangle 23"/>
+            <p:cNvPr id="26" name="Rectangle 26"/>
             <p:cNvSpPr/>
             <p:nvPr/>
           </p:nvSpPr>
@@ -4228,7 +4456,7 @@
         </p:sp>
         <p:sp>
           <p:nvSpPr>
-            <p:cNvPr id="24" name="Rectangle 24"/>
+            <p:cNvPr id="27" name="Rectangle 27"/>
             <p:cNvSpPr/>
             <p:nvPr/>
           </p:nvSpPr>
@@ -4243,7 +4471,9 @@
               </a:avLst>
             </a:prstGeom>
             <a:solidFill>
-              <a:srgbClr val="FFFFFF"/>
+              <a:srgbClr val="FFFFFF">
+                <a:alpha val="86000"/>
+              </a:srgbClr>
             </a:solidFill>
             <a:ln>
               <a:noFill/>
@@ -4259,7 +4489,7 @@
         </p:sp>
         <p:grpSp>
           <p:nvGrpSpPr>
-            <p:cNvPr id="27" name="Group 27"/>
+            <p:cNvPr id="30" name="Group 30"/>
             <p:cNvGrpSpPr/>
             <p:nvPr/>
           </p:nvGrpSpPr>
@@ -4273,7 +4503,7 @@
           </p:grpSpPr>
           <p:sp>
             <p:nvSpPr>
-              <p:cNvPr id="25" name="Freeform 25"/>
+              <p:cNvPr id="28" name="Freeform 28"/>
               <p:cNvSpPr/>
               <p:nvPr/>
             </p:nvSpPr>
@@ -4341,7 +4571,7 @@
           </p:sp>
           <p:sp>
             <p:nvSpPr>
-              <p:cNvPr id="26" name="Freeform 26"/>
+              <p:cNvPr id="29" name="Freeform 29"/>
               <p:cNvSpPr/>
               <p:nvPr/>
             </p:nvSpPr>
@@ -4471,7 +4701,7 @@
         </p:grpSp>
         <p:sp>
           <p:nvSpPr>
-            <p:cNvPr id="28" name="TextBox 28"/>
+            <p:cNvPr id="31" name="TextBox 31"/>
             <p:cNvSpPr txBox="1"/>
             <p:nvPr/>
           </p:nvSpPr>
@@ -4511,7 +4741,7 @@
         </p:sp>
         <p:sp>
           <p:nvSpPr>
-            <p:cNvPr id="29" name="TextBox 29"/>
+            <p:cNvPr id="32" name="TextBox 32"/>
             <p:cNvSpPr txBox="1"/>
             <p:nvPr/>
           </p:nvSpPr>
@@ -4551,7 +4781,7 @@
         </p:sp>
         <p:sp>
           <p:nvSpPr>
-            <p:cNvPr id="30" name="TextBox 30"/>
+            <p:cNvPr id="33" name="TextBox 33"/>
             <p:cNvSpPr txBox="1"/>
             <p:nvPr/>
           </p:nvSpPr>
@@ -4591,7 +4821,7 @@
         </p:sp>
         <p:sp>
           <p:nvSpPr>
-            <p:cNvPr id="31" name="TextBox 31"/>
+            <p:cNvPr id="34" name="TextBox 34"/>
             <p:cNvSpPr txBox="1"/>
             <p:nvPr/>
           </p:nvSpPr>
@@ -4631,7 +4861,7 @@
         </p:sp>
         <p:sp>
           <p:nvSpPr>
-            <p:cNvPr id="32" name="Rectangle 32"/>
+            <p:cNvPr id="35" name="Rectangle 35"/>
             <p:cNvSpPr/>
             <p:nvPr/>
           </p:nvSpPr>
@@ -4657,7 +4887,7 @@
         </p:sp>
         <p:sp>
           <p:nvSpPr>
-            <p:cNvPr id="33" name="Rectangle 33"/>
+            <p:cNvPr id="36" name="Rectangle 36"/>
             <p:cNvSpPr/>
             <p:nvPr/>
           </p:nvSpPr>
@@ -4672,7 +4902,9 @@
               </a:avLst>
             </a:prstGeom>
             <a:solidFill>
-              <a:srgbClr val="FFFFFF"/>
+              <a:srgbClr val="FFFFFF">
+                <a:alpha val="86000"/>
+              </a:srgbClr>
             </a:solidFill>
             <a:ln>
               <a:noFill/>
@@ -4688,7 +4920,7 @@
         </p:sp>
         <p:grpSp>
           <p:nvGrpSpPr>
-            <p:cNvPr id="36" name="Group 36"/>
+            <p:cNvPr id="39" name="Group 39"/>
             <p:cNvGrpSpPr/>
             <p:nvPr/>
           </p:nvGrpSpPr>
@@ -4702,7 +4934,7 @@
           </p:grpSpPr>
           <p:sp>
             <p:nvSpPr>
-              <p:cNvPr id="34" name="Freeform 34"/>
+              <p:cNvPr id="37" name="Freeform 37"/>
               <p:cNvSpPr/>
               <p:nvPr/>
             </p:nvSpPr>
@@ -4760,7 +4992,7 @@
           </p:sp>
           <p:sp>
             <p:nvSpPr>
-              <p:cNvPr id="35" name="Freeform 35"/>
+              <p:cNvPr id="38" name="Freeform 38"/>
               <p:cNvSpPr/>
               <p:nvPr/>
             </p:nvSpPr>
@@ -4925,7 +5157,7 @@
         </p:grpSp>
         <p:sp>
           <p:nvSpPr>
-            <p:cNvPr id="37" name="TextBox 37"/>
+            <p:cNvPr id="40" name="TextBox 40"/>
             <p:cNvSpPr txBox="1"/>
             <p:nvPr/>
           </p:nvSpPr>
@@ -4965,7 +5197,7 @@
         </p:sp>
         <p:sp>
           <p:nvSpPr>
-            <p:cNvPr id="38" name="TextBox 38"/>
+            <p:cNvPr id="41" name="TextBox 41"/>
             <p:cNvSpPr txBox="1"/>
             <p:nvPr/>
           </p:nvSpPr>
@@ -5005,7 +5237,7 @@
         </p:sp>
         <p:sp>
           <p:nvSpPr>
-            <p:cNvPr id="39" name="TextBox 39"/>
+            <p:cNvPr id="42" name="TextBox 42"/>
             <p:cNvSpPr txBox="1"/>
             <p:nvPr/>
           </p:nvSpPr>
@@ -5045,7 +5277,7 @@
         </p:sp>
         <p:sp>
           <p:nvSpPr>
-            <p:cNvPr id="40" name="TextBox 40"/>
+            <p:cNvPr id="43" name="TextBox 43"/>
             <p:cNvSpPr txBox="1"/>
             <p:nvPr/>
           </p:nvSpPr>
@@ -5086,7 +5318,7 @@
       </p:grpSp>
       <p:grpSp>
         <p:nvGrpSpPr>
-          <p:cNvPr id="56" name="conditions"/>
+          <p:cNvPr id="59" name="conditions"/>
           <p:cNvGrpSpPr/>
           <p:nvPr/>
         </p:nvGrpSpPr>
@@ -5100,7 +5332,7 @@
         </p:grpSpPr>
         <p:sp>
           <p:nvSpPr>
-            <p:cNvPr id="42" name="Rectangle 42"/>
+            <p:cNvPr id="45" name="Rectangle 45"/>
             <p:cNvSpPr/>
             <p:nvPr/>
           </p:nvSpPr>
@@ -5126,7 +5358,7 @@
         </p:sp>
         <p:sp>
           <p:nvSpPr>
-            <p:cNvPr id="43" name="Rectangle 43"/>
+            <p:cNvPr id="46" name="Rectangle 46"/>
             <p:cNvSpPr/>
             <p:nvPr/>
           </p:nvSpPr>
@@ -5141,7 +5373,9 @@
               </a:avLst>
             </a:prstGeom>
             <a:solidFill>
-              <a:srgbClr val="FFFFFF"/>
+              <a:srgbClr val="FFFFFF">
+                <a:alpha val="86000"/>
+              </a:srgbClr>
             </a:solidFill>
             <a:ln>
               <a:noFill/>
@@ -5157,7 +5391,7 @@
         </p:sp>
         <p:grpSp>
           <p:nvGrpSpPr>
-            <p:cNvPr id="46" name="Group 46"/>
+            <p:cNvPr id="49" name="Group 49"/>
             <p:cNvGrpSpPr/>
             <p:nvPr/>
           </p:nvGrpSpPr>
@@ -5171,7 +5405,7 @@
           </p:grpSpPr>
           <p:sp>
             <p:nvSpPr>
-              <p:cNvPr id="44" name="Freeform 44"/>
+              <p:cNvPr id="47" name="Freeform 47"/>
               <p:cNvSpPr/>
               <p:nvPr/>
             </p:nvSpPr>
@@ -5275,7 +5509,7 @@
           </p:sp>
           <p:sp>
             <p:nvSpPr>
-              <p:cNvPr id="45" name="Freeform 45"/>
+              <p:cNvPr id="48" name="Freeform 48"/>
               <p:cNvSpPr/>
               <p:nvPr/>
             </p:nvSpPr>
@@ -5557,7 +5791,7 @@
         </p:grpSp>
         <p:sp>
           <p:nvSpPr>
-            <p:cNvPr id="47" name="TextBox 47"/>
+            <p:cNvPr id="50" name="TextBox 50"/>
             <p:cNvSpPr txBox="1"/>
             <p:nvPr/>
           </p:nvSpPr>
@@ -5597,7 +5831,7 @@
         </p:sp>
         <p:sp>
           <p:nvSpPr>
-            <p:cNvPr id="48" name="TextBox 48"/>
+            <p:cNvPr id="51" name="TextBox 51"/>
             <p:cNvSpPr txBox="1"/>
             <p:nvPr/>
           </p:nvSpPr>
@@ -5637,7 +5871,7 @@
         </p:sp>
         <p:sp>
           <p:nvSpPr>
-            <p:cNvPr id="49" name="Rectangle 49"/>
+            <p:cNvPr id="52" name="Rectangle 52"/>
             <p:cNvSpPr/>
             <p:nvPr/>
           </p:nvSpPr>
@@ -5663,7 +5897,7 @@
         </p:sp>
         <p:sp>
           <p:nvSpPr>
-            <p:cNvPr id="50" name="Rectangle 50"/>
+            <p:cNvPr id="53" name="Rectangle 53"/>
             <p:cNvSpPr/>
             <p:nvPr/>
           </p:nvSpPr>
@@ -5678,7 +5912,9 @@
               </a:avLst>
             </a:prstGeom>
             <a:solidFill>
-              <a:srgbClr val="FFFFFF"/>
+              <a:srgbClr val="FFFFFF">
+                <a:alpha val="86000"/>
+              </a:srgbClr>
             </a:solidFill>
             <a:ln>
               <a:noFill/>
@@ -5694,7 +5930,7 @@
         </p:sp>
         <p:grpSp>
           <p:nvGrpSpPr>
-            <p:cNvPr id="53" name="Group 53"/>
+            <p:cNvPr id="56" name="Group 56"/>
             <p:cNvGrpSpPr/>
             <p:nvPr/>
           </p:nvGrpSpPr>
@@ -5708,7 +5944,7 @@
           </p:grpSpPr>
           <p:sp>
             <p:nvSpPr>
-              <p:cNvPr id="51" name="Freeform 51"/>
+              <p:cNvPr id="54" name="Freeform 54"/>
               <p:cNvSpPr/>
               <p:nvPr/>
             </p:nvSpPr>
@@ -5776,7 +6012,7 @@
           </p:sp>
           <p:sp>
             <p:nvSpPr>
-              <p:cNvPr id="52" name="Freeform 52"/>
+              <p:cNvPr id="55" name="Freeform 55"/>
               <p:cNvSpPr/>
               <p:nvPr/>
             </p:nvSpPr>
@@ -6006,7 +6242,7 @@
         </p:grpSp>
         <p:sp>
           <p:nvSpPr>
-            <p:cNvPr id="54" name="TextBox 54"/>
+            <p:cNvPr id="57" name="TextBox 57"/>
             <p:cNvSpPr txBox="1"/>
             <p:nvPr/>
           </p:nvSpPr>
@@ -6046,7 +6282,7 @@
         </p:sp>
         <p:sp>
           <p:nvSpPr>
-            <p:cNvPr id="55" name="TextBox 55"/>
+            <p:cNvPr id="58" name="TextBox 58"/>
             <p:cNvSpPr txBox="1"/>
             <p:nvPr/>
           </p:nvSpPr>
@@ -6104,13 +6340,13 @@
         <a:gradFill>
           <a:gsLst>
             <a:gs pos="0">
-              <a:srgbClr val="FFF1F2"/>
+              <a:srgbClr val="FFE4F2"/>
             </a:gs>
-            <a:gs pos="42000">
-              <a:schemeClr val="lt2"/>
+            <a:gs pos="46000">
+              <a:srgbClr val="E4DCFF"/>
             </a:gs>
             <a:gs pos="100000">
-              <a:schemeClr val="lt1"/>
+              <a:srgbClr val="DCEBFF"/>
             </a:gs>
           </a:gsLst>
           <a:lin ang="2700000" scaled="1"/>
@@ -6132,9 +6368,117 @@
           <a:chExt cx="0" cy="0"/>
         </a:xfrm>
       </p:grpSpPr>
+      <p:sp>
+        <p:nvSpPr>
+          <p:cNvPr id="2" name="glow-a"/>
+          <p:cNvSpPr/>
+          <p:nvPr/>
+        </p:nvSpPr>
+        <p:spPr>
+          <a:xfrm>
+            <a:off x="-3810000" y="-3238500"/>
+            <a:ext cx="10668000" cy="7239000"/>
+          </a:xfrm>
+          <a:prstGeom prst="ellipse">
+            <a:avLst/>
+          </a:prstGeom>
+          <a:gradFill>
+            <a:gsLst>
+              <a:gs pos="0">
+                <a:srgbClr val="FF4D6A">
+                  <a:alpha val="72000"/>
+                </a:srgbClr>
+              </a:gs>
+              <a:gs pos="100000">
+                <a:srgbClr val="FF4D6A">
+                  <a:alpha val="0"/>
+                </a:srgbClr>
+              </a:gs>
+            </a:gsLst>
+            <a:path path="circle">
+              <a:fillToRect l="50000" t="50000" r="50000" b="50000"/>
+            </a:path>
+          </a:gradFill>
+          <a:ln>
+            <a:noFill/>
+          </a:ln>
+        </p:spPr>
+      </p:sp>
+      <p:sp>
+        <p:nvSpPr>
+          <p:cNvPr id="3" name="glow-b"/>
+          <p:cNvSpPr/>
+          <p:nvPr/>
+        </p:nvSpPr>
+        <p:spPr>
+          <a:xfrm>
+            <a:off x="6096000" y="3238500"/>
+            <a:ext cx="9906000" cy="6858000"/>
+          </a:xfrm>
+          <a:prstGeom prst="ellipse">
+            <a:avLst/>
+          </a:prstGeom>
+          <a:gradFill>
+            <a:gsLst>
+              <a:gs pos="0">
+                <a:srgbClr val="6E63FF">
+                  <a:alpha val="62000"/>
+                </a:srgbClr>
+              </a:gs>
+              <a:gs pos="100000">
+                <a:srgbClr val="6E63FF">
+                  <a:alpha val="0"/>
+                </a:srgbClr>
+              </a:gs>
+            </a:gsLst>
+            <a:path path="circle">
+              <a:fillToRect l="50000" t="50000" r="50000" b="50000"/>
+            </a:path>
+          </a:gradFill>
+          <a:ln>
+            <a:noFill/>
+          </a:ln>
+        </p:spPr>
+      </p:sp>
+      <p:sp>
+        <p:nvSpPr>
+          <p:cNvPr id="4" name="glow-c"/>
+          <p:cNvSpPr/>
+          <p:nvPr/>
+        </p:nvSpPr>
+        <p:spPr>
+          <a:xfrm>
+            <a:off x="2095500" y="381000"/>
+            <a:ext cx="8001000" cy="4953000"/>
+          </a:xfrm>
+          <a:prstGeom prst="ellipse">
+            <a:avLst/>
+          </a:prstGeom>
+          <a:gradFill>
+            <a:gsLst>
+              <a:gs pos="0">
+                <a:srgbClr val="FFFFFF">
+                  <a:alpha val="85000"/>
+                </a:srgbClr>
+              </a:gs>
+              <a:gs pos="100000">
+                <a:srgbClr val="FFFFFF">
+                  <a:alpha val="0"/>
+                </a:srgbClr>
+              </a:gs>
+            </a:gsLst>
+            <a:path path="circle">
+              <a:fillToRect l="50000" t="50000" r="50000" b="50000"/>
+            </a:path>
+          </a:gradFill>
+          <a:ln>
+            <a:noFill/>
+          </a:ln>
+        </p:spPr>
+      </p:sp>
       <p:grpSp>
         <p:nvGrpSpPr>
-          <p:cNvPr id="4" name="header"/>
+          <p:cNvPr id="7" name="header"/>
           <p:cNvGrpSpPr/>
           <p:nvPr/>
         </p:nvGrpSpPr>
@@ -6148,7 +6492,7 @@
         </p:grpSpPr>
         <p:sp>
           <p:nvSpPr>
-            <p:cNvPr id="2" name="TextBox 2"/>
+            <p:cNvPr id="5" name="TextBox 5"/>
             <p:cNvSpPr txBox="1"/>
             <p:nvPr/>
           </p:nvSpPr>
@@ -6188,7 +6532,7 @@
         </p:sp>
         <p:sp>
           <p:nvSpPr>
-            <p:cNvPr id="3" name="TextBox 3"/>
+            <p:cNvPr id="6" name="TextBox 6"/>
             <p:cNvSpPr txBox="1"/>
             <p:nvPr/>
           </p:nvSpPr>
@@ -6229,7 +6573,7 @@
       </p:grpSp>
       <p:grpSp>
         <p:nvGrpSpPr>
-          <p:cNvPr id="32" name="grid"/>
+          <p:cNvPr id="35" name="grid"/>
           <p:cNvGrpSpPr/>
           <p:nvPr/>
         </p:nvGrpSpPr>
@@ -6243,7 +6587,7 @@
         </p:grpSpPr>
         <p:sp>
           <p:nvSpPr>
-            <p:cNvPr id="5" name="Rectangle 5"/>
+            <p:cNvPr id="8" name="Rectangle 8"/>
             <p:cNvSpPr/>
             <p:nvPr/>
           </p:nvSpPr>
@@ -6269,7 +6613,7 @@
         </p:sp>
         <p:sp>
           <p:nvSpPr>
-            <p:cNvPr id="6" name="Rectangle 6"/>
+            <p:cNvPr id="9" name="Rectangle 9"/>
             <p:cNvSpPr/>
             <p:nvPr/>
           </p:nvSpPr>
@@ -6284,7 +6628,9 @@
               </a:avLst>
             </a:prstGeom>
             <a:solidFill>
-              <a:srgbClr val="FFFFFF"/>
+              <a:srgbClr val="FFFFFF">
+                <a:alpha val="86000"/>
+              </a:srgbClr>
             </a:solidFill>
             <a:ln>
               <a:noFill/>
@@ -6300,7 +6646,7 @@
         </p:sp>
         <p:sp>
           <p:nvSpPr>
-            <p:cNvPr id="7" name="TextBox 7"/>
+            <p:cNvPr id="10" name="TextBox 10"/>
             <p:cNvSpPr txBox="1"/>
             <p:nvPr/>
           </p:nvSpPr>
@@ -6340,7 +6686,7 @@
         </p:sp>
         <p:sp>
           <p:nvSpPr>
-            <p:cNvPr id="8" name="Rectangle 8"/>
+            <p:cNvPr id="11" name="Rectangle 11"/>
             <p:cNvSpPr/>
             <p:nvPr/>
           </p:nvSpPr>
@@ -6364,7 +6710,7 @@
         </p:sp>
         <p:sp>
           <p:nvSpPr>
-            <p:cNvPr id="9" name="TextBox 9"/>
+            <p:cNvPr id="12" name="TextBox 12"/>
             <p:cNvSpPr txBox="1"/>
             <p:nvPr/>
           </p:nvSpPr>
@@ -6404,7 +6750,7 @@
         </p:sp>
         <p:sp>
           <p:nvSpPr>
-            <p:cNvPr id="10" name="Rectangle 10"/>
+            <p:cNvPr id="13" name="Rectangle 13"/>
             <p:cNvSpPr/>
             <p:nvPr/>
           </p:nvSpPr>
@@ -6428,7 +6774,7 @@
         </p:sp>
         <p:sp>
           <p:nvSpPr>
-            <p:cNvPr id="11" name="TextBox 11"/>
+            <p:cNvPr id="14" name="TextBox 14"/>
             <p:cNvSpPr txBox="1"/>
             <p:nvPr/>
           </p:nvSpPr>
@@ -6468,7 +6814,7 @@
         </p:sp>
         <p:sp>
           <p:nvSpPr>
-            <p:cNvPr id="12" name="Rectangle 12"/>
+            <p:cNvPr id="15" name="Rectangle 15"/>
             <p:cNvSpPr/>
             <p:nvPr/>
           </p:nvSpPr>
@@ -6492,7 +6838,7 @@
         </p:sp>
         <p:sp>
           <p:nvSpPr>
-            <p:cNvPr id="13" name="TextBox 13"/>
+            <p:cNvPr id="16" name="TextBox 16"/>
             <p:cNvSpPr txBox="1"/>
             <p:nvPr/>
           </p:nvSpPr>
@@ -6532,7 +6878,7 @@
         </p:sp>
         <p:sp>
           <p:nvSpPr>
-            <p:cNvPr id="14" name="Rectangle 14"/>
+            <p:cNvPr id="17" name="Rectangle 17"/>
             <p:cNvSpPr/>
             <p:nvPr/>
           </p:nvSpPr>
@@ -6556,7 +6902,7 @@
         </p:sp>
         <p:sp>
           <p:nvSpPr>
-            <p:cNvPr id="15" name="TextBox 15"/>
+            <p:cNvPr id="18" name="TextBox 18"/>
             <p:cNvSpPr txBox="1"/>
             <p:nvPr/>
           </p:nvSpPr>
@@ -6596,7 +6942,7 @@
         </p:sp>
         <p:sp>
           <p:nvSpPr>
-            <p:cNvPr id="16" name="Rectangle 16"/>
+            <p:cNvPr id="19" name="Rectangle 19"/>
             <p:cNvSpPr/>
             <p:nvPr/>
           </p:nvSpPr>
@@ -6622,7 +6968,7 @@
         </p:sp>
         <p:sp>
           <p:nvSpPr>
-            <p:cNvPr id="17" name="Rectangle 17"/>
+            <p:cNvPr id="20" name="Rectangle 20"/>
             <p:cNvSpPr/>
             <p:nvPr/>
           </p:nvSpPr>
@@ -6646,7 +6992,7 @@
         </p:sp>
         <p:sp>
           <p:nvSpPr>
-            <p:cNvPr id="18" name="TextBox 18"/>
+            <p:cNvPr id="21" name="TextBox 21"/>
             <p:cNvSpPr txBox="1"/>
             <p:nvPr/>
           </p:nvSpPr>
@@ -6686,7 +7032,7 @@
         </p:sp>
         <p:sp>
           <p:nvSpPr>
-            <p:cNvPr id="19" name="Rectangle 19"/>
+            <p:cNvPr id="22" name="Rectangle 22"/>
             <p:cNvSpPr/>
             <p:nvPr/>
           </p:nvSpPr>
@@ -6710,7 +7056,7 @@
         </p:sp>
         <p:sp>
           <p:nvSpPr>
-            <p:cNvPr id="20" name="TextBox 20"/>
+            <p:cNvPr id="23" name="TextBox 23"/>
             <p:cNvSpPr txBox="1"/>
             <p:nvPr/>
           </p:nvSpPr>
@@ -6750,7 +7096,7 @@
         </p:sp>
         <p:sp>
           <p:nvSpPr>
-            <p:cNvPr id="21" name="Rectangle 21"/>
+            <p:cNvPr id="24" name="Rectangle 24"/>
             <p:cNvSpPr/>
             <p:nvPr/>
           </p:nvSpPr>
@@ -6774,7 +7120,7 @@
         </p:sp>
         <p:sp>
           <p:nvSpPr>
-            <p:cNvPr id="22" name="TextBox 22"/>
+            <p:cNvPr id="25" name="TextBox 25"/>
             <p:cNvSpPr txBox="1"/>
             <p:nvPr/>
           </p:nvSpPr>
@@ -6814,7 +7160,7 @@
         </p:sp>
         <p:sp>
           <p:nvSpPr>
-            <p:cNvPr id="23" name="Rectangle 23"/>
+            <p:cNvPr id="26" name="Rectangle 26"/>
             <p:cNvSpPr/>
             <p:nvPr/>
           </p:nvSpPr>
@@ -6838,7 +7184,7 @@
         </p:sp>
         <p:sp>
           <p:nvSpPr>
-            <p:cNvPr id="24" name="TextBox 24"/>
+            <p:cNvPr id="27" name="TextBox 27"/>
             <p:cNvSpPr txBox="1"/>
             <p:nvPr/>
           </p:nvSpPr>
@@ -6878,7 +7224,7 @@
         </p:sp>
         <p:sp>
           <p:nvSpPr>
-            <p:cNvPr id="25" name="Rectangle 25"/>
+            <p:cNvPr id="28" name="Rectangle 28"/>
             <p:cNvSpPr/>
             <p:nvPr/>
           </p:nvSpPr>
@@ -6902,7 +7248,7 @@
         </p:sp>
         <p:sp>
           <p:nvSpPr>
-            <p:cNvPr id="26" name="TextBox 26"/>
+            <p:cNvPr id="29" name="TextBox 29"/>
             <p:cNvSpPr txBox="1"/>
             <p:nvPr/>
           </p:nvSpPr>
@@ -6942,7 +7288,7 @@
         </p:sp>
         <p:sp>
           <p:nvSpPr>
-            <p:cNvPr id="27" name="Rectangle 27"/>
+            <p:cNvPr id="30" name="Rectangle 30"/>
             <p:cNvSpPr/>
             <p:nvPr/>
           </p:nvSpPr>
@@ -6966,7 +7312,7 @@
         </p:sp>
         <p:grpSp>
           <p:nvGrpSpPr>
-            <p:cNvPr id="30" name="Group 30"/>
+            <p:cNvPr id="33" name="Group 33"/>
             <p:cNvGrpSpPr/>
             <p:nvPr/>
           </p:nvGrpSpPr>
@@ -6980,7 +7326,7 @@
           </p:grpSpPr>
           <p:sp>
             <p:nvSpPr>
-              <p:cNvPr id="28" name="Freeform 28"/>
+              <p:cNvPr id="31" name="Freeform 31"/>
               <p:cNvSpPr/>
               <p:nvPr/>
             </p:nvSpPr>
@@ -7043,7 +7389,7 @@
           </p:sp>
           <p:sp>
             <p:nvSpPr>
-              <p:cNvPr id="29" name="Freeform 29"/>
+              <p:cNvPr id="32" name="Freeform 32"/>
               <p:cNvSpPr/>
               <p:nvPr/>
             </p:nvSpPr>
@@ -7157,7 +7503,7 @@
         </p:grpSp>
         <p:sp>
           <p:nvSpPr>
-            <p:cNvPr id="31" name="TextBox 31"/>
+            <p:cNvPr id="34" name="TextBox 34"/>
             <p:cNvSpPr txBox="1"/>
             <p:nvPr/>
           </p:nvSpPr>
@@ -7198,7 +7544,7 @@
       </p:grpSp>
       <p:grpSp>
         <p:nvGrpSpPr>
-          <p:cNvPr id="50" name="rules"/>
+          <p:cNvPr id="53" name="rules"/>
           <p:cNvGrpSpPr/>
           <p:nvPr/>
         </p:nvGrpSpPr>
@@ -7212,7 +7558,7 @@
         </p:grpSpPr>
         <p:sp>
           <p:nvSpPr>
-            <p:cNvPr id="33" name="Rectangle 33"/>
+            <p:cNvPr id="36" name="Rectangle 36"/>
             <p:cNvSpPr/>
             <p:nvPr/>
           </p:nvSpPr>
@@ -7238,7 +7584,7 @@
         </p:sp>
         <p:sp>
           <p:nvSpPr>
-            <p:cNvPr id="34" name="Rectangle 34"/>
+            <p:cNvPr id="37" name="Rectangle 37"/>
             <p:cNvSpPr/>
             <p:nvPr/>
           </p:nvSpPr>
@@ -7253,7 +7599,9 @@
               </a:avLst>
             </a:prstGeom>
             <a:solidFill>
-              <a:srgbClr val="FFFFFF"/>
+              <a:srgbClr val="FFFFFF">
+                <a:alpha val="86000"/>
+              </a:srgbClr>
             </a:solidFill>
             <a:ln>
               <a:noFill/>
@@ -7269,7 +7617,7 @@
         </p:sp>
         <p:grpSp>
           <p:nvGrpSpPr>
-            <p:cNvPr id="37" name="Group 37"/>
+            <p:cNvPr id="40" name="Group 40"/>
             <p:cNvGrpSpPr/>
             <p:nvPr/>
           </p:nvGrpSpPr>
@@ -7283,7 +7631,7 @@
           </p:grpSpPr>
           <p:sp>
             <p:nvSpPr>
-              <p:cNvPr id="35" name="Freeform 35"/>
+              <p:cNvPr id="38" name="Freeform 38"/>
               <p:cNvSpPr/>
               <p:nvPr/>
             </p:nvSpPr>
@@ -7341,7 +7689,7 @@
           </p:sp>
           <p:sp>
             <p:nvSpPr>
-              <p:cNvPr id="36" name="Freeform 36"/>
+              <p:cNvPr id="39" name="Freeform 39"/>
               <p:cNvSpPr/>
               <p:nvPr/>
             </p:nvSpPr>
@@ -7506,7 +7854,7 @@
         </p:grpSp>
         <p:sp>
           <p:nvSpPr>
-            <p:cNvPr id="38" name="TextBox 38"/>
+            <p:cNvPr id="41" name="TextBox 41"/>
             <p:cNvSpPr txBox="1"/>
             <p:nvPr/>
           </p:nvSpPr>
@@ -7546,7 +7894,7 @@
         </p:sp>
         <p:sp>
           <p:nvSpPr>
-            <p:cNvPr id="39" name="TextBox 39"/>
+            <p:cNvPr id="42" name="TextBox 42"/>
             <p:cNvSpPr txBox="1"/>
             <p:nvPr/>
           </p:nvSpPr>
@@ -7586,7 +7934,7 @@
         </p:sp>
         <p:grpSp>
           <p:nvGrpSpPr>
-            <p:cNvPr id="42" name="Group 42"/>
+            <p:cNvPr id="45" name="Group 45"/>
             <p:cNvGrpSpPr/>
             <p:nvPr/>
           </p:nvGrpSpPr>
@@ -7600,7 +7948,7 @@
           </p:grpSpPr>
           <p:sp>
             <p:nvSpPr>
-              <p:cNvPr id="40" name="Freeform 40"/>
+              <p:cNvPr id="43" name="Freeform 43"/>
               <p:cNvSpPr/>
               <p:nvPr/>
             </p:nvSpPr>
@@ -7660,7 +8008,7 @@
           </p:sp>
           <p:sp>
             <p:nvSpPr>
-              <p:cNvPr id="41" name="Freeform 41"/>
+              <p:cNvPr id="44" name="Freeform 44"/>
               <p:cNvSpPr/>
               <p:nvPr/>
             </p:nvSpPr>
@@ -7834,7 +8182,7 @@
         </p:grpSp>
         <p:sp>
           <p:nvSpPr>
-            <p:cNvPr id="43" name="TextBox 43"/>
+            <p:cNvPr id="46" name="TextBox 46"/>
             <p:cNvSpPr txBox="1"/>
             <p:nvPr/>
           </p:nvSpPr>
@@ -7874,7 +8222,7 @@
         </p:sp>
         <p:sp>
           <p:nvSpPr>
-            <p:cNvPr id="44" name="TextBox 44"/>
+            <p:cNvPr id="47" name="TextBox 47"/>
             <p:cNvSpPr txBox="1"/>
             <p:nvPr/>
           </p:nvSpPr>
@@ -7914,7 +8262,7 @@
         </p:sp>
         <p:grpSp>
           <p:nvGrpSpPr>
-            <p:cNvPr id="47" name="Group 47"/>
+            <p:cNvPr id="50" name="Group 50"/>
             <p:cNvGrpSpPr/>
             <p:nvPr/>
           </p:nvGrpSpPr>
@@ -7928,7 +8276,7 @@
           </p:grpSpPr>
           <p:sp>
             <p:nvSpPr>
-              <p:cNvPr id="45" name="Freeform 45"/>
+              <p:cNvPr id="48" name="Freeform 48"/>
               <p:cNvSpPr/>
               <p:nvPr/>
             </p:nvSpPr>
@@ -7984,7 +8332,7 @@
           </p:sp>
           <p:sp>
             <p:nvSpPr>
-              <p:cNvPr id="46" name="Freeform 46"/>
+              <p:cNvPr id="49" name="Freeform 49"/>
               <p:cNvSpPr/>
               <p:nvPr/>
             </p:nvSpPr>
@@ -8104,7 +8452,7 @@
         </p:grpSp>
         <p:sp>
           <p:nvSpPr>
-            <p:cNvPr id="48" name="TextBox 48"/>
+            <p:cNvPr id="51" name="TextBox 51"/>
             <p:cNvSpPr txBox="1"/>
             <p:nvPr/>
           </p:nvSpPr>
@@ -8144,7 +8492,7 @@
         </p:sp>
         <p:sp>
           <p:nvSpPr>
-            <p:cNvPr id="49" name="TextBox 49"/>
+            <p:cNvPr id="52" name="TextBox 52"/>
             <p:cNvSpPr txBox="1"/>
             <p:nvPr/>
           </p:nvSpPr>
@@ -8202,13 +8550,13 @@
         <a:gradFill>
           <a:gsLst>
             <a:gs pos="0">
-              <a:srgbClr val="FFF1F2"/>
+              <a:srgbClr val="FFE4F2"/>
             </a:gs>
-            <a:gs pos="42000">
-              <a:schemeClr val="lt2"/>
+            <a:gs pos="46000">
+              <a:srgbClr val="E4DCFF"/>
             </a:gs>
             <a:gs pos="100000">
-              <a:schemeClr val="lt1"/>
+              <a:srgbClr val="DCEBFF"/>
             </a:gs>
           </a:gsLst>
           <a:lin ang="2700000" scaled="1"/>
@@ -8230,9 +8578,117 @@
           <a:chExt cx="0" cy="0"/>
         </a:xfrm>
       </p:grpSpPr>
+      <p:sp>
+        <p:nvSpPr>
+          <p:cNvPr id="2" name="glow-a"/>
+          <p:cNvSpPr/>
+          <p:nvPr/>
+        </p:nvSpPr>
+        <p:spPr>
+          <a:xfrm>
+            <a:off x="-3810000" y="-3238500"/>
+            <a:ext cx="10668000" cy="7239000"/>
+          </a:xfrm>
+          <a:prstGeom prst="ellipse">
+            <a:avLst/>
+          </a:prstGeom>
+          <a:gradFill>
+            <a:gsLst>
+              <a:gs pos="0">
+                <a:srgbClr val="FF4D6A">
+                  <a:alpha val="72000"/>
+                </a:srgbClr>
+              </a:gs>
+              <a:gs pos="100000">
+                <a:srgbClr val="FF4D6A">
+                  <a:alpha val="0"/>
+                </a:srgbClr>
+              </a:gs>
+            </a:gsLst>
+            <a:path path="circle">
+              <a:fillToRect l="50000" t="50000" r="50000" b="50000"/>
+            </a:path>
+          </a:gradFill>
+          <a:ln>
+            <a:noFill/>
+          </a:ln>
+        </p:spPr>
+      </p:sp>
+      <p:sp>
+        <p:nvSpPr>
+          <p:cNvPr id="3" name="glow-b"/>
+          <p:cNvSpPr/>
+          <p:nvPr/>
+        </p:nvSpPr>
+        <p:spPr>
+          <a:xfrm>
+            <a:off x="6096000" y="3238500"/>
+            <a:ext cx="9906000" cy="6858000"/>
+          </a:xfrm>
+          <a:prstGeom prst="ellipse">
+            <a:avLst/>
+          </a:prstGeom>
+          <a:gradFill>
+            <a:gsLst>
+              <a:gs pos="0">
+                <a:srgbClr val="6E63FF">
+                  <a:alpha val="62000"/>
+                </a:srgbClr>
+              </a:gs>
+              <a:gs pos="100000">
+                <a:srgbClr val="6E63FF">
+                  <a:alpha val="0"/>
+                </a:srgbClr>
+              </a:gs>
+            </a:gsLst>
+            <a:path path="circle">
+              <a:fillToRect l="50000" t="50000" r="50000" b="50000"/>
+            </a:path>
+          </a:gradFill>
+          <a:ln>
+            <a:noFill/>
+          </a:ln>
+        </p:spPr>
+      </p:sp>
+      <p:sp>
+        <p:nvSpPr>
+          <p:cNvPr id="4" name="glow-c"/>
+          <p:cNvSpPr/>
+          <p:nvPr/>
+        </p:nvSpPr>
+        <p:spPr>
+          <a:xfrm>
+            <a:off x="2095500" y="381000"/>
+            <a:ext cx="8001000" cy="4953000"/>
+          </a:xfrm>
+          <a:prstGeom prst="ellipse">
+            <a:avLst/>
+          </a:prstGeom>
+          <a:gradFill>
+            <a:gsLst>
+              <a:gs pos="0">
+                <a:srgbClr val="FFFFFF">
+                  <a:alpha val="85000"/>
+                </a:srgbClr>
+              </a:gs>
+              <a:gs pos="100000">
+                <a:srgbClr val="FFFFFF">
+                  <a:alpha val="0"/>
+                </a:srgbClr>
+              </a:gs>
+            </a:gsLst>
+            <a:path path="circle">
+              <a:fillToRect l="50000" t="50000" r="50000" b="50000"/>
+            </a:path>
+          </a:gradFill>
+          <a:ln>
+            <a:noFill/>
+          </a:ln>
+        </p:spPr>
+      </p:sp>
       <p:grpSp>
         <p:nvGrpSpPr>
-          <p:cNvPr id="4" name="header"/>
+          <p:cNvPr id="7" name="header"/>
           <p:cNvGrpSpPr/>
           <p:nvPr/>
         </p:nvGrpSpPr>
@@ -8246,7 +8702,7 @@
         </p:grpSpPr>
         <p:sp>
           <p:nvSpPr>
-            <p:cNvPr id="2" name="TextBox 2"/>
+            <p:cNvPr id="5" name="TextBox 5"/>
             <p:cNvSpPr txBox="1"/>
             <p:nvPr/>
           </p:nvSpPr>
@@ -8286,7 +8742,7 @@
         </p:sp>
         <p:sp>
           <p:nvSpPr>
-            <p:cNvPr id="3" name="TextBox 3"/>
+            <p:cNvPr id="6" name="TextBox 6"/>
             <p:cNvSpPr txBox="1"/>
             <p:nvPr/>
           </p:nvSpPr>
@@ -8327,7 +8783,7 @@
       </p:grpSp>
       <p:grpSp>
         <p:nvGrpSpPr>
-          <p:cNvPr id="33" name="boxes"/>
+          <p:cNvPr id="36" name="boxes"/>
           <p:cNvGrpSpPr/>
           <p:nvPr/>
         </p:nvGrpSpPr>
@@ -8341,7 +8797,7 @@
         </p:grpSpPr>
         <p:sp>
           <p:nvSpPr>
-            <p:cNvPr id="5" name="Rectangle 5"/>
+            <p:cNvPr id="8" name="Rectangle 8"/>
             <p:cNvSpPr/>
             <p:nvPr/>
           </p:nvSpPr>
@@ -8367,7 +8823,7 @@
         </p:sp>
         <p:sp>
           <p:nvSpPr>
-            <p:cNvPr id="6" name="Rectangle 6"/>
+            <p:cNvPr id="9" name="Rectangle 9"/>
             <p:cNvSpPr/>
             <p:nvPr/>
           </p:nvSpPr>
@@ -8382,7 +8838,9 @@
               </a:avLst>
             </a:prstGeom>
             <a:solidFill>
-              <a:srgbClr val="FFFFFF"/>
+              <a:srgbClr val="FFFFFF">
+                <a:alpha val="86000"/>
+              </a:srgbClr>
             </a:solidFill>
             <a:ln>
               <a:noFill/>
@@ -8398,7 +8856,7 @@
         </p:sp>
         <p:grpSp>
           <p:nvGrpSpPr>
-            <p:cNvPr id="9" name="Group 9"/>
+            <p:cNvPr id="12" name="Group 12"/>
             <p:cNvGrpSpPr/>
             <p:nvPr/>
           </p:nvGrpSpPr>
@@ -8412,7 +8870,7 @@
           </p:grpSpPr>
           <p:sp>
             <p:nvSpPr>
-              <p:cNvPr id="7" name="Freeform 7"/>
+              <p:cNvPr id="10" name="Freeform 10"/>
               <p:cNvSpPr/>
               <p:nvPr/>
             </p:nvSpPr>
@@ -8475,7 +8933,7 @@
           </p:sp>
           <p:sp>
             <p:nvSpPr>
-              <p:cNvPr id="8" name="Freeform 8"/>
+              <p:cNvPr id="11" name="Freeform 11"/>
               <p:cNvSpPr/>
               <p:nvPr/>
             </p:nvSpPr>
@@ -8589,7 +9047,7 @@
         </p:grpSp>
         <p:sp>
           <p:nvSpPr>
-            <p:cNvPr id="10" name="TextBox 10"/>
+            <p:cNvPr id="13" name="TextBox 13"/>
             <p:cNvSpPr txBox="1"/>
             <p:nvPr/>
           </p:nvSpPr>
@@ -8629,7 +9087,7 @@
         </p:sp>
         <p:sp>
           <p:nvSpPr>
-            <p:cNvPr id="11" name="TextBox 11"/>
+            <p:cNvPr id="14" name="TextBox 14"/>
             <p:cNvSpPr txBox="1"/>
             <p:nvPr/>
           </p:nvSpPr>
@@ -8669,7 +9127,7 @@
         </p:sp>
         <p:sp>
           <p:nvSpPr>
-            <p:cNvPr id="12" name="Rectangle 12"/>
+            <p:cNvPr id="15" name="Rectangle 15"/>
             <p:cNvSpPr/>
             <p:nvPr/>
           </p:nvSpPr>
@@ -8695,7 +9153,7 @@
         </p:sp>
         <p:sp>
           <p:nvSpPr>
-            <p:cNvPr id="13" name="Rectangle 13"/>
+            <p:cNvPr id="16" name="Rectangle 16"/>
             <p:cNvSpPr/>
             <p:nvPr/>
           </p:nvSpPr>
@@ -8710,7 +9168,9 @@
               </a:avLst>
             </a:prstGeom>
             <a:solidFill>
-              <a:srgbClr val="FFFFFF"/>
+              <a:srgbClr val="FFFFFF">
+                <a:alpha val="86000"/>
+              </a:srgbClr>
             </a:solidFill>
             <a:ln>
               <a:noFill/>
@@ -8726,7 +9186,7 @@
         </p:sp>
         <p:grpSp>
           <p:nvGrpSpPr>
-            <p:cNvPr id="16" name="Group 16"/>
+            <p:cNvPr id="19" name="Group 19"/>
             <p:cNvGrpSpPr/>
             <p:nvPr/>
           </p:nvGrpSpPr>
@@ -8740,7 +9200,7 @@
           </p:grpSpPr>
           <p:sp>
             <p:nvSpPr>
-              <p:cNvPr id="14" name="Freeform 14"/>
+              <p:cNvPr id="17" name="Freeform 17"/>
               <p:cNvSpPr/>
               <p:nvPr/>
             </p:nvSpPr>
@@ -8840,7 +9300,7 @@
           </p:sp>
           <p:sp>
             <p:nvSpPr>
-              <p:cNvPr id="15" name="Freeform 15"/>
+              <p:cNvPr id="18" name="Freeform 18"/>
               <p:cNvSpPr/>
               <p:nvPr/>
             </p:nvSpPr>
@@ -9120,7 +9580,7 @@
         </p:grpSp>
         <p:sp>
           <p:nvSpPr>
-            <p:cNvPr id="17" name="TextBox 17"/>
+            <p:cNvPr id="20" name="TextBox 20"/>
             <p:cNvSpPr txBox="1"/>
             <p:nvPr/>
           </p:nvSpPr>
@@ -9160,7 +9620,7 @@
         </p:sp>
         <p:sp>
           <p:nvSpPr>
-            <p:cNvPr id="18" name="TextBox 18"/>
+            <p:cNvPr id="21" name="TextBox 21"/>
             <p:cNvSpPr txBox="1"/>
             <p:nvPr/>
           </p:nvSpPr>
@@ -9200,7 +9660,7 @@
         </p:sp>
         <p:sp>
           <p:nvSpPr>
-            <p:cNvPr id="19" name="Rectangle 19"/>
+            <p:cNvPr id="22" name="Rectangle 22"/>
             <p:cNvSpPr/>
             <p:nvPr/>
           </p:nvSpPr>
@@ -9226,7 +9686,7 @@
         </p:sp>
         <p:sp>
           <p:nvSpPr>
-            <p:cNvPr id="20" name="Rectangle 20"/>
+            <p:cNvPr id="23" name="Rectangle 23"/>
             <p:cNvSpPr/>
             <p:nvPr/>
           </p:nvSpPr>
@@ -9241,7 +9701,9 @@
               </a:avLst>
             </a:prstGeom>
             <a:solidFill>
-              <a:srgbClr val="FFFFFF"/>
+              <a:srgbClr val="FFFFFF">
+                <a:alpha val="86000"/>
+              </a:srgbClr>
             </a:solidFill>
             <a:ln>
               <a:noFill/>
@@ -9257,7 +9719,7 @@
         </p:sp>
         <p:grpSp>
           <p:nvGrpSpPr>
-            <p:cNvPr id="23" name="Group 23"/>
+            <p:cNvPr id="26" name="Group 26"/>
             <p:cNvGrpSpPr/>
             <p:nvPr/>
           </p:nvGrpSpPr>
@@ -9271,7 +9733,7 @@
           </p:grpSpPr>
           <p:sp>
             <p:nvSpPr>
-              <p:cNvPr id="21" name="Freeform 21"/>
+              <p:cNvPr id="24" name="Freeform 24"/>
               <p:cNvSpPr/>
               <p:nvPr/>
             </p:nvSpPr>
@@ -9351,7 +9813,7 @@
           </p:sp>
           <p:sp>
             <p:nvSpPr>
-              <p:cNvPr id="22" name="Freeform 22"/>
+              <p:cNvPr id="25" name="Freeform 25"/>
               <p:cNvSpPr/>
               <p:nvPr/>
             </p:nvSpPr>
@@ -9523,7 +9985,7 @@
         </p:grpSp>
         <p:sp>
           <p:nvSpPr>
-            <p:cNvPr id="24" name="TextBox 24"/>
+            <p:cNvPr id="27" name="TextBox 27"/>
             <p:cNvSpPr txBox="1"/>
             <p:nvPr/>
           </p:nvSpPr>
@@ -9563,7 +10025,7 @@
         </p:sp>
         <p:sp>
           <p:nvSpPr>
-            <p:cNvPr id="25" name="TextBox 25"/>
+            <p:cNvPr id="28" name="TextBox 28"/>
             <p:cNvSpPr txBox="1"/>
             <p:nvPr/>
           </p:nvSpPr>
@@ -9603,7 +10065,7 @@
         </p:sp>
         <p:sp>
           <p:nvSpPr>
-            <p:cNvPr id="26" name="Rectangle 26"/>
+            <p:cNvPr id="29" name="Rectangle 29"/>
             <p:cNvSpPr/>
             <p:nvPr/>
           </p:nvSpPr>
@@ -9629,7 +10091,7 @@
         </p:sp>
         <p:sp>
           <p:nvSpPr>
-            <p:cNvPr id="27" name="Rectangle 27"/>
+            <p:cNvPr id="30" name="Rectangle 30"/>
             <p:cNvSpPr/>
             <p:nvPr/>
           </p:nvSpPr>
@@ -9644,7 +10106,9 @@
               </a:avLst>
             </a:prstGeom>
             <a:solidFill>
-              <a:srgbClr val="FFFFFF"/>
+              <a:srgbClr val="FFFFFF">
+                <a:alpha val="86000"/>
+              </a:srgbClr>
             </a:solidFill>
             <a:ln>
               <a:noFill/>
@@ -9660,7 +10124,7 @@
         </p:sp>
         <p:grpSp>
           <p:nvGrpSpPr>
-            <p:cNvPr id="30" name="Group 30"/>
+            <p:cNvPr id="33" name="Group 33"/>
             <p:cNvGrpSpPr/>
             <p:nvPr/>
           </p:nvGrpSpPr>
@@ -9674,7 +10138,7 @@
           </p:grpSpPr>
           <p:sp>
             <p:nvSpPr>
-              <p:cNvPr id="28" name="Freeform 28"/>
+              <p:cNvPr id="31" name="Freeform 31"/>
               <p:cNvSpPr/>
               <p:nvPr/>
             </p:nvSpPr>
@@ -9790,7 +10254,7 @@
           </p:sp>
           <p:sp>
             <p:nvSpPr>
-              <p:cNvPr id="29" name="Freeform 29"/>
+              <p:cNvPr id="32" name="Freeform 32"/>
               <p:cNvSpPr/>
               <p:nvPr/>
             </p:nvSpPr>
@@ -10205,7 +10669,7 @@
         </p:grpSp>
         <p:sp>
           <p:nvSpPr>
-            <p:cNvPr id="31" name="TextBox 31"/>
+            <p:cNvPr id="34" name="TextBox 34"/>
             <p:cNvSpPr txBox="1"/>
             <p:nvPr/>
           </p:nvSpPr>
@@ -10245,7 +10709,7 @@
         </p:sp>
         <p:sp>
           <p:nvSpPr>
-            <p:cNvPr id="32" name="TextBox 32"/>
+            <p:cNvPr id="35" name="TextBox 35"/>
             <p:cNvSpPr txBox="1"/>
             <p:nvPr/>
           </p:nvSpPr>
@@ -10286,7 +10750,7 @@
       </p:grpSp>
       <p:grpSp>
         <p:nvGrpSpPr>
-          <p:cNvPr id="41" name="assistant"/>
+          <p:cNvPr id="44" name="assistant"/>
           <p:cNvGrpSpPr/>
           <p:nvPr/>
         </p:nvGrpSpPr>
@@ -10300,7 +10764,7 @@
         </p:grpSpPr>
         <p:sp>
           <p:nvSpPr>
-            <p:cNvPr id="34" name="Rectangle 34"/>
+            <p:cNvPr id="37" name="Rectangle 37"/>
             <p:cNvSpPr/>
             <p:nvPr/>
           </p:nvSpPr>
@@ -10326,7 +10790,7 @@
         </p:sp>
         <p:sp>
           <p:nvSpPr>
-            <p:cNvPr id="35" name="Rectangle 35"/>
+            <p:cNvPr id="38" name="Rectangle 38"/>
             <p:cNvSpPr/>
             <p:nvPr/>
           </p:nvSpPr>
@@ -10341,7 +10805,9 @@
               </a:avLst>
             </a:prstGeom>
             <a:solidFill>
-              <a:srgbClr val="FFFFFF"/>
+              <a:srgbClr val="FFFFFF">
+                <a:alpha val="86000"/>
+              </a:srgbClr>
             </a:solidFill>
             <a:ln>
               <a:noFill/>
@@ -10357,7 +10823,7 @@
         </p:sp>
         <p:grpSp>
           <p:nvGrpSpPr>
-            <p:cNvPr id="38" name="Group 38"/>
+            <p:cNvPr id="41" name="Group 41"/>
             <p:cNvGrpSpPr/>
             <p:nvPr/>
           </p:nvGrpSpPr>
@@ -10371,7 +10837,7 @@
           </p:grpSpPr>
           <p:sp>
             <p:nvSpPr>
-              <p:cNvPr id="36" name="Freeform 36"/>
+              <p:cNvPr id="39" name="Freeform 39"/>
               <p:cNvSpPr/>
               <p:nvPr/>
             </p:nvSpPr>
@@ -10458,7 +10924,7 @@
           </p:sp>
           <p:sp>
             <p:nvSpPr>
-              <p:cNvPr id="37" name="Freeform 37"/>
+              <p:cNvPr id="40" name="Freeform 40"/>
               <p:cNvSpPr/>
               <p:nvPr/>
             </p:nvSpPr>
@@ -10648,7 +11114,7 @@
         </p:grpSp>
         <p:sp>
           <p:nvSpPr>
-            <p:cNvPr id="39" name="TextBox 39"/>
+            <p:cNvPr id="42" name="TextBox 42"/>
             <p:cNvSpPr txBox="1"/>
             <p:nvPr/>
           </p:nvSpPr>
@@ -10688,7 +11154,7 @@
         </p:sp>
         <p:sp>
           <p:nvSpPr>
-            <p:cNvPr id="40" name="TextBox 40"/>
+            <p:cNvPr id="43" name="TextBox 43"/>
             <p:cNvSpPr txBox="1"/>
             <p:nvPr/>
           </p:nvSpPr>
@@ -10746,13 +11212,13 @@
         <a:gradFill>
           <a:gsLst>
             <a:gs pos="0">
-              <a:srgbClr val="FFF1F2"/>
+              <a:srgbClr val="FFE4F2"/>
             </a:gs>
-            <a:gs pos="42000">
-              <a:schemeClr val="lt2"/>
+            <a:gs pos="46000">
+              <a:srgbClr val="E4DCFF"/>
             </a:gs>
             <a:gs pos="100000">
-              <a:schemeClr val="lt1"/>
+              <a:srgbClr val="DCEBFF"/>
             </a:gs>
           </a:gsLst>
           <a:lin ang="2700000" scaled="1"/>
@@ -10774,9 +11240,117 @@
           <a:chExt cx="0" cy="0"/>
         </a:xfrm>
       </p:grpSpPr>
+      <p:sp>
+        <p:nvSpPr>
+          <p:cNvPr id="2" name="glow-a"/>
+          <p:cNvSpPr/>
+          <p:nvPr/>
+        </p:nvSpPr>
+        <p:spPr>
+          <a:xfrm>
+            <a:off x="-3810000" y="-3238500"/>
+            <a:ext cx="10668000" cy="7239000"/>
+          </a:xfrm>
+          <a:prstGeom prst="ellipse">
+            <a:avLst/>
+          </a:prstGeom>
+          <a:gradFill>
+            <a:gsLst>
+              <a:gs pos="0">
+                <a:srgbClr val="FF4D6A">
+                  <a:alpha val="72000"/>
+                </a:srgbClr>
+              </a:gs>
+              <a:gs pos="100000">
+                <a:srgbClr val="FF4D6A">
+                  <a:alpha val="0"/>
+                </a:srgbClr>
+              </a:gs>
+            </a:gsLst>
+            <a:path path="circle">
+              <a:fillToRect l="50000" t="50000" r="50000" b="50000"/>
+            </a:path>
+          </a:gradFill>
+          <a:ln>
+            <a:noFill/>
+          </a:ln>
+        </p:spPr>
+      </p:sp>
+      <p:sp>
+        <p:nvSpPr>
+          <p:cNvPr id="3" name="glow-b"/>
+          <p:cNvSpPr/>
+          <p:nvPr/>
+        </p:nvSpPr>
+        <p:spPr>
+          <a:xfrm>
+            <a:off x="6096000" y="3238500"/>
+            <a:ext cx="9906000" cy="6858000"/>
+          </a:xfrm>
+          <a:prstGeom prst="ellipse">
+            <a:avLst/>
+          </a:prstGeom>
+          <a:gradFill>
+            <a:gsLst>
+              <a:gs pos="0">
+                <a:srgbClr val="6E63FF">
+                  <a:alpha val="62000"/>
+                </a:srgbClr>
+              </a:gs>
+              <a:gs pos="100000">
+                <a:srgbClr val="6E63FF">
+                  <a:alpha val="0"/>
+                </a:srgbClr>
+              </a:gs>
+            </a:gsLst>
+            <a:path path="circle">
+              <a:fillToRect l="50000" t="50000" r="50000" b="50000"/>
+            </a:path>
+          </a:gradFill>
+          <a:ln>
+            <a:noFill/>
+          </a:ln>
+        </p:spPr>
+      </p:sp>
+      <p:sp>
+        <p:nvSpPr>
+          <p:cNvPr id="4" name="glow-c"/>
+          <p:cNvSpPr/>
+          <p:nvPr/>
+        </p:nvSpPr>
+        <p:spPr>
+          <a:xfrm>
+            <a:off x="2095500" y="381000"/>
+            <a:ext cx="8001000" cy="4953000"/>
+          </a:xfrm>
+          <a:prstGeom prst="ellipse">
+            <a:avLst/>
+          </a:prstGeom>
+          <a:gradFill>
+            <a:gsLst>
+              <a:gs pos="0">
+                <a:srgbClr val="FFFFFF">
+                  <a:alpha val="85000"/>
+                </a:srgbClr>
+              </a:gs>
+              <a:gs pos="100000">
+                <a:srgbClr val="FFFFFF">
+                  <a:alpha val="0"/>
+                </a:srgbClr>
+              </a:gs>
+            </a:gsLst>
+            <a:path path="circle">
+              <a:fillToRect l="50000" t="50000" r="50000" b="50000"/>
+            </a:path>
+          </a:gradFill>
+          <a:ln>
+            <a:noFill/>
+          </a:ln>
+        </p:spPr>
+      </p:sp>
       <p:grpSp>
         <p:nvGrpSpPr>
-          <p:cNvPr id="4" name="header"/>
+          <p:cNvPr id="7" name="header"/>
           <p:cNvGrpSpPr/>
           <p:nvPr/>
         </p:nvGrpSpPr>
@@ -10790,7 +11364,7 @@
         </p:grpSpPr>
         <p:sp>
           <p:nvSpPr>
-            <p:cNvPr id="2" name="TextBox 2"/>
+            <p:cNvPr id="5" name="TextBox 5"/>
             <p:cNvSpPr txBox="1"/>
             <p:nvPr/>
           </p:nvSpPr>
@@ -10830,7 +11404,7 @@
         </p:sp>
         <p:sp>
           <p:nvSpPr>
-            <p:cNvPr id="3" name="TextBox 3"/>
+            <p:cNvPr id="6" name="TextBox 6"/>
             <p:cNvSpPr txBox="1"/>
             <p:nvPr/>
           </p:nvSpPr>
@@ -10871,7 +11445,7 @@
       </p:grpSp>
       <p:grpSp>
         <p:nvGrpSpPr>
-          <p:cNvPr id="23" name="storyboard"/>
+          <p:cNvPr id="26" name="storyboard"/>
           <p:cNvGrpSpPr/>
           <p:nvPr/>
         </p:nvGrpSpPr>
@@ -10885,7 +11459,7 @@
         </p:grpSpPr>
         <p:sp>
           <p:nvSpPr>
-            <p:cNvPr id="5" name="Rectangle 5"/>
+            <p:cNvPr id="8" name="Rectangle 8"/>
             <p:cNvSpPr/>
             <p:nvPr/>
           </p:nvSpPr>
@@ -10911,7 +11485,7 @@
         </p:sp>
         <p:sp>
           <p:nvSpPr>
-            <p:cNvPr id="6" name="Rectangle 6"/>
+            <p:cNvPr id="9" name="Rectangle 9"/>
             <p:cNvSpPr/>
             <p:nvPr/>
           </p:nvSpPr>
@@ -10926,7 +11500,9 @@
               </a:avLst>
             </a:prstGeom>
             <a:solidFill>
-              <a:srgbClr val="FFFFFF"/>
+              <a:srgbClr val="FFFFFF">
+                <a:alpha val="86000"/>
+              </a:srgbClr>
             </a:solidFill>
             <a:ln>
               <a:noFill/>
@@ -10942,7 +11518,7 @@
         </p:sp>
         <p:sp>
           <p:nvSpPr>
-            <p:cNvPr id="7" name="Rectangle 7"/>
+            <p:cNvPr id="10" name="Rectangle 10"/>
             <p:cNvSpPr/>
             <p:nvPr/>
           </p:nvSpPr>
@@ -10966,7 +11542,7 @@
         </p:sp>
         <p:sp>
           <p:nvSpPr>
-            <p:cNvPr id="8" name="TextBox 8"/>
+            <p:cNvPr id="11" name="TextBox 11"/>
             <p:cNvSpPr txBox="1"/>
             <p:nvPr/>
           </p:nvSpPr>
@@ -11006,7 +11582,7 @@
         </p:sp>
         <p:sp>
           <p:nvSpPr>
-            <p:cNvPr id="9" name="TextBox 9"/>
+            <p:cNvPr id="12" name="TextBox 12"/>
             <p:cNvSpPr txBox="1"/>
             <p:nvPr/>
           </p:nvSpPr>
@@ -11046,7 +11622,7 @@
         </p:sp>
         <p:sp>
           <p:nvSpPr>
-            <p:cNvPr id="10" name="TextBox 10"/>
+            <p:cNvPr id="13" name="TextBox 13"/>
             <p:cNvSpPr txBox="1"/>
             <p:nvPr/>
           </p:nvSpPr>
@@ -11086,7 +11662,7 @@
         </p:sp>
         <p:sp>
           <p:nvSpPr>
-            <p:cNvPr id="11" name="Rectangle 11"/>
+            <p:cNvPr id="14" name="Rectangle 14"/>
             <p:cNvSpPr/>
             <p:nvPr/>
           </p:nvSpPr>
@@ -11112,7 +11688,7 @@
         </p:sp>
         <p:sp>
           <p:nvSpPr>
-            <p:cNvPr id="12" name="Rectangle 12"/>
+            <p:cNvPr id="15" name="Rectangle 15"/>
             <p:cNvSpPr/>
             <p:nvPr/>
           </p:nvSpPr>
@@ -11127,7 +11703,9 @@
               </a:avLst>
             </a:prstGeom>
             <a:solidFill>
-              <a:srgbClr val="FFFFFF"/>
+              <a:srgbClr val="FFFFFF">
+                <a:alpha val="86000"/>
+              </a:srgbClr>
             </a:solidFill>
             <a:ln>
               <a:noFill/>
@@ -11143,7 +11721,7 @@
         </p:sp>
         <p:sp>
           <p:nvSpPr>
-            <p:cNvPr id="13" name="Rectangle 13"/>
+            <p:cNvPr id="16" name="Rectangle 16"/>
             <p:cNvSpPr/>
             <p:nvPr/>
           </p:nvSpPr>
@@ -11167,7 +11745,7 @@
         </p:sp>
         <p:sp>
           <p:nvSpPr>
-            <p:cNvPr id="14" name="TextBox 14"/>
+            <p:cNvPr id="17" name="TextBox 17"/>
             <p:cNvSpPr txBox="1"/>
             <p:nvPr/>
           </p:nvSpPr>
@@ -11207,7 +11785,7 @@
         </p:sp>
         <p:sp>
           <p:nvSpPr>
-            <p:cNvPr id="15" name="TextBox 15"/>
+            <p:cNvPr id="18" name="TextBox 18"/>
             <p:cNvSpPr txBox="1"/>
             <p:nvPr/>
           </p:nvSpPr>
@@ -11247,7 +11825,7 @@
         </p:sp>
         <p:sp>
           <p:nvSpPr>
-            <p:cNvPr id="16" name="TextBox 16"/>
+            <p:cNvPr id="19" name="TextBox 19"/>
             <p:cNvSpPr txBox="1"/>
             <p:nvPr/>
           </p:nvSpPr>
@@ -11287,7 +11865,7 @@
         </p:sp>
         <p:sp>
           <p:nvSpPr>
-            <p:cNvPr id="17" name="Rectangle 17"/>
+            <p:cNvPr id="20" name="Rectangle 20"/>
             <p:cNvSpPr/>
             <p:nvPr/>
           </p:nvSpPr>
@@ -11313,7 +11891,7 @@
         </p:sp>
         <p:sp>
           <p:nvSpPr>
-            <p:cNvPr id="18" name="Rectangle 18"/>
+            <p:cNvPr id="21" name="Rectangle 21"/>
             <p:cNvSpPr/>
             <p:nvPr/>
           </p:nvSpPr>
@@ -11328,7 +11906,9 @@
               </a:avLst>
             </a:prstGeom>
             <a:solidFill>
-              <a:srgbClr val="FFFFFF"/>
+              <a:srgbClr val="FFFFFF">
+                <a:alpha val="86000"/>
+              </a:srgbClr>
             </a:solidFill>
             <a:ln>
               <a:noFill/>
@@ -11344,7 +11924,7 @@
         </p:sp>
         <p:sp>
           <p:nvSpPr>
-            <p:cNvPr id="19" name="Rectangle 19"/>
+            <p:cNvPr id="22" name="Rectangle 22"/>
             <p:cNvSpPr/>
             <p:nvPr/>
           </p:nvSpPr>
@@ -11368,7 +11948,7 @@
         </p:sp>
         <p:sp>
           <p:nvSpPr>
-            <p:cNvPr id="20" name="TextBox 20"/>
+            <p:cNvPr id="23" name="TextBox 23"/>
             <p:cNvSpPr txBox="1"/>
             <p:nvPr/>
           </p:nvSpPr>
@@ -11408,7 +11988,7 @@
         </p:sp>
         <p:sp>
           <p:nvSpPr>
-            <p:cNvPr id="21" name="TextBox 21"/>
+            <p:cNvPr id="24" name="TextBox 24"/>
             <p:cNvSpPr txBox="1"/>
             <p:nvPr/>
           </p:nvSpPr>
@@ -11448,7 +12028,7 @@
         </p:sp>
         <p:sp>
           <p:nvSpPr>
-            <p:cNvPr id="22" name="TextBox 22"/>
+            <p:cNvPr id="25" name="TextBox 25"/>
             <p:cNvSpPr txBox="1"/>
             <p:nvPr/>
           </p:nvSpPr>
@@ -11489,7 +12069,7 @@
       </p:grpSp>
       <p:grpSp>
         <p:nvGrpSpPr>
-          <p:cNvPr id="38" name="assistant-rule"/>
+          <p:cNvPr id="41" name="assistant-rule"/>
           <p:cNvGrpSpPr/>
           <p:nvPr/>
         </p:nvGrpSpPr>
@@ -11503,7 +12083,7 @@
         </p:grpSpPr>
         <p:sp>
           <p:nvSpPr>
-            <p:cNvPr id="24" name="Rectangle 24"/>
+            <p:cNvPr id="27" name="Rectangle 27"/>
             <p:cNvSpPr/>
             <p:nvPr/>
           </p:nvSpPr>
@@ -11529,7 +12109,7 @@
         </p:sp>
         <p:sp>
           <p:nvSpPr>
-            <p:cNvPr id="25" name="Rectangle 25"/>
+            <p:cNvPr id="28" name="Rectangle 28"/>
             <p:cNvSpPr/>
             <p:nvPr/>
           </p:nvSpPr>
@@ -11544,7 +12124,9 @@
               </a:avLst>
             </a:prstGeom>
             <a:solidFill>
-              <a:srgbClr val="FFFFFF"/>
+              <a:srgbClr val="FFFFFF">
+                <a:alpha val="86000"/>
+              </a:srgbClr>
             </a:solidFill>
             <a:ln>
               <a:noFill/>
@@ -11560,7 +12142,7 @@
         </p:sp>
         <p:grpSp>
           <p:nvGrpSpPr>
-            <p:cNvPr id="28" name="Group 28"/>
+            <p:cNvPr id="31" name="Group 31"/>
             <p:cNvGrpSpPr/>
             <p:nvPr/>
           </p:nvGrpSpPr>
@@ -11574,7 +12156,7 @@
           </p:grpSpPr>
           <p:sp>
             <p:nvSpPr>
-              <p:cNvPr id="26" name="Freeform 26"/>
+              <p:cNvPr id="29" name="Freeform 29"/>
               <p:cNvSpPr/>
               <p:nvPr/>
             </p:nvSpPr>
@@ -11674,7 +12256,7 @@
           </p:sp>
           <p:sp>
             <p:nvSpPr>
-              <p:cNvPr id="27" name="Freeform 27"/>
+              <p:cNvPr id="30" name="Freeform 30"/>
               <p:cNvSpPr/>
               <p:nvPr/>
             </p:nvSpPr>
@@ -11954,7 +12536,7 @@
         </p:grpSp>
         <p:sp>
           <p:nvSpPr>
-            <p:cNvPr id="29" name="TextBox 29"/>
+            <p:cNvPr id="32" name="TextBox 32"/>
             <p:cNvSpPr txBox="1"/>
             <p:nvPr/>
           </p:nvSpPr>
@@ -11994,7 +12576,7 @@
         </p:sp>
         <p:sp>
           <p:nvSpPr>
-            <p:cNvPr id="30" name="TextBox 30"/>
+            <p:cNvPr id="33" name="TextBox 33"/>
             <p:cNvSpPr txBox="1"/>
             <p:nvPr/>
           </p:nvSpPr>
@@ -12034,7 +12616,7 @@
         </p:sp>
         <p:sp>
           <p:nvSpPr>
-            <p:cNvPr id="31" name="Rectangle 31"/>
+            <p:cNvPr id="34" name="Rectangle 34"/>
             <p:cNvSpPr/>
             <p:nvPr/>
           </p:nvSpPr>
@@ -12060,7 +12642,7 @@
         </p:sp>
         <p:sp>
           <p:nvSpPr>
-            <p:cNvPr id="32" name="Rectangle 32"/>
+            <p:cNvPr id="35" name="Rectangle 35"/>
             <p:cNvSpPr/>
             <p:nvPr/>
           </p:nvSpPr>
@@ -12075,7 +12657,9 @@
               </a:avLst>
             </a:prstGeom>
             <a:solidFill>
-              <a:srgbClr val="FFFFFF"/>
+              <a:srgbClr val="FFFFFF">
+                <a:alpha val="86000"/>
+              </a:srgbClr>
             </a:solidFill>
             <a:ln>
               <a:noFill/>
@@ -12091,7 +12675,7 @@
         </p:sp>
         <p:grpSp>
           <p:nvGrpSpPr>
-            <p:cNvPr id="35" name="Group 35"/>
+            <p:cNvPr id="38" name="Group 38"/>
             <p:cNvGrpSpPr/>
             <p:nvPr/>
           </p:nvGrpSpPr>
@@ -12105,7 +12689,7 @@
           </p:grpSpPr>
           <p:sp>
             <p:nvSpPr>
-              <p:cNvPr id="33" name="Freeform 33"/>
+              <p:cNvPr id="36" name="Freeform 36"/>
               <p:cNvSpPr/>
               <p:nvPr/>
             </p:nvSpPr>
@@ -12192,7 +12776,7 @@
           </p:sp>
           <p:sp>
             <p:nvSpPr>
-              <p:cNvPr id="34" name="Freeform 34"/>
+              <p:cNvPr id="37" name="Freeform 37"/>
               <p:cNvSpPr/>
               <p:nvPr/>
             </p:nvSpPr>
@@ -12382,7 +12966,7 @@
         </p:grpSp>
         <p:sp>
           <p:nvSpPr>
-            <p:cNvPr id="36" name="TextBox 36"/>
+            <p:cNvPr id="39" name="TextBox 39"/>
             <p:cNvSpPr txBox="1"/>
             <p:nvPr/>
           </p:nvSpPr>
@@ -12422,7 +13006,7 @@
         </p:sp>
         <p:sp>
           <p:nvSpPr>
-            <p:cNvPr id="37" name="TextBox 37"/>
+            <p:cNvPr id="40" name="TextBox 40"/>
             <p:cNvSpPr txBox="1"/>
             <p:nvPr/>
           </p:nvSpPr>
@@ -12480,13 +13064,13 @@
         <a:gradFill>
           <a:gsLst>
             <a:gs pos="0">
-              <a:srgbClr val="FFF1F2"/>
+              <a:srgbClr val="FFE4F2"/>
             </a:gs>
-            <a:gs pos="42000">
-              <a:schemeClr val="lt2"/>
+            <a:gs pos="46000">
+              <a:srgbClr val="E4DCFF"/>
             </a:gs>
             <a:gs pos="100000">
-              <a:schemeClr val="lt1"/>
+              <a:srgbClr val="DCEBFF"/>
             </a:gs>
           </a:gsLst>
           <a:lin ang="2700000" scaled="1"/>
@@ -12508,9 +13092,117 @@
           <a:chExt cx="0" cy="0"/>
         </a:xfrm>
       </p:grpSpPr>
+      <p:sp>
+        <p:nvSpPr>
+          <p:cNvPr id="2" name="glow-a"/>
+          <p:cNvSpPr/>
+          <p:nvPr/>
+        </p:nvSpPr>
+        <p:spPr>
+          <a:xfrm>
+            <a:off x="-3810000" y="-3238500"/>
+            <a:ext cx="10668000" cy="7239000"/>
+          </a:xfrm>
+          <a:prstGeom prst="ellipse">
+            <a:avLst/>
+          </a:prstGeom>
+          <a:gradFill>
+            <a:gsLst>
+              <a:gs pos="0">
+                <a:srgbClr val="FF4D6A">
+                  <a:alpha val="72000"/>
+                </a:srgbClr>
+              </a:gs>
+              <a:gs pos="100000">
+                <a:srgbClr val="FF4D6A">
+                  <a:alpha val="0"/>
+                </a:srgbClr>
+              </a:gs>
+            </a:gsLst>
+            <a:path path="circle">
+              <a:fillToRect l="50000" t="50000" r="50000" b="50000"/>
+            </a:path>
+          </a:gradFill>
+          <a:ln>
+            <a:noFill/>
+          </a:ln>
+        </p:spPr>
+      </p:sp>
+      <p:sp>
+        <p:nvSpPr>
+          <p:cNvPr id="3" name="glow-b"/>
+          <p:cNvSpPr/>
+          <p:nvPr/>
+        </p:nvSpPr>
+        <p:spPr>
+          <a:xfrm>
+            <a:off x="6096000" y="3238500"/>
+            <a:ext cx="9906000" cy="6858000"/>
+          </a:xfrm>
+          <a:prstGeom prst="ellipse">
+            <a:avLst/>
+          </a:prstGeom>
+          <a:gradFill>
+            <a:gsLst>
+              <a:gs pos="0">
+                <a:srgbClr val="6E63FF">
+                  <a:alpha val="62000"/>
+                </a:srgbClr>
+              </a:gs>
+              <a:gs pos="100000">
+                <a:srgbClr val="6E63FF">
+                  <a:alpha val="0"/>
+                </a:srgbClr>
+              </a:gs>
+            </a:gsLst>
+            <a:path path="circle">
+              <a:fillToRect l="50000" t="50000" r="50000" b="50000"/>
+            </a:path>
+          </a:gradFill>
+          <a:ln>
+            <a:noFill/>
+          </a:ln>
+        </p:spPr>
+      </p:sp>
+      <p:sp>
+        <p:nvSpPr>
+          <p:cNvPr id="4" name="glow-c"/>
+          <p:cNvSpPr/>
+          <p:nvPr/>
+        </p:nvSpPr>
+        <p:spPr>
+          <a:xfrm>
+            <a:off x="2095500" y="381000"/>
+            <a:ext cx="8001000" cy="4953000"/>
+          </a:xfrm>
+          <a:prstGeom prst="ellipse">
+            <a:avLst/>
+          </a:prstGeom>
+          <a:gradFill>
+            <a:gsLst>
+              <a:gs pos="0">
+                <a:srgbClr val="FFFFFF">
+                  <a:alpha val="85000"/>
+                </a:srgbClr>
+              </a:gs>
+              <a:gs pos="100000">
+                <a:srgbClr val="FFFFFF">
+                  <a:alpha val="0"/>
+                </a:srgbClr>
+              </a:gs>
+            </a:gsLst>
+            <a:path path="circle">
+              <a:fillToRect l="50000" t="50000" r="50000" b="50000"/>
+            </a:path>
+          </a:gradFill>
+          <a:ln>
+            <a:noFill/>
+          </a:ln>
+        </p:spPr>
+      </p:sp>
       <p:grpSp>
         <p:nvGrpSpPr>
-          <p:cNvPr id="4" name="header"/>
+          <p:cNvPr id="7" name="header"/>
           <p:cNvGrpSpPr/>
           <p:nvPr/>
         </p:nvGrpSpPr>
@@ -12524,7 +13216,7 @@
         </p:grpSpPr>
         <p:sp>
           <p:nvSpPr>
-            <p:cNvPr id="2" name="TextBox 2"/>
+            <p:cNvPr id="5" name="TextBox 5"/>
             <p:cNvSpPr txBox="1"/>
             <p:nvPr/>
           </p:nvSpPr>
@@ -12564,7 +13256,7 @@
         </p:sp>
         <p:sp>
           <p:nvSpPr>
-            <p:cNvPr id="3" name="TextBox 3"/>
+            <p:cNvPr id="6" name="TextBox 6"/>
             <p:cNvSpPr txBox="1"/>
             <p:nvPr/>
           </p:nvSpPr>
@@ -12605,7 +13297,7 @@
       </p:grpSp>
       <p:grpSp>
         <p:nvGrpSpPr>
-          <p:cNvPr id="29" name="flow"/>
+          <p:cNvPr id="32" name="flow"/>
           <p:cNvGrpSpPr/>
           <p:nvPr/>
         </p:nvGrpSpPr>
@@ -12619,7 +13311,7 @@
         </p:grpSpPr>
         <p:sp>
           <p:nvSpPr>
-            <p:cNvPr id="5" name="Rectangle 5"/>
+            <p:cNvPr id="8" name="Rectangle 8"/>
             <p:cNvSpPr/>
             <p:nvPr/>
           </p:nvSpPr>
@@ -12645,7 +13337,7 @@
         </p:sp>
         <p:sp>
           <p:nvSpPr>
-            <p:cNvPr id="6" name="Rectangle 6"/>
+            <p:cNvPr id="9" name="Rectangle 9"/>
             <p:cNvSpPr/>
             <p:nvPr/>
           </p:nvSpPr>
@@ -12660,7 +13352,9 @@
               </a:avLst>
             </a:prstGeom>
             <a:solidFill>
-              <a:srgbClr val="FFFFFF"/>
+              <a:srgbClr val="FFFFFF">
+                <a:alpha val="86000"/>
+              </a:srgbClr>
             </a:solidFill>
             <a:ln>
               <a:noFill/>
@@ -12676,7 +13370,7 @@
         </p:sp>
         <p:grpSp>
           <p:nvGrpSpPr>
-            <p:cNvPr id="9" name="Group 9"/>
+            <p:cNvPr id="12" name="Group 12"/>
             <p:cNvGrpSpPr/>
             <p:nvPr/>
           </p:nvGrpSpPr>
@@ -12690,7 +13384,7 @@
           </p:grpSpPr>
           <p:sp>
             <p:nvSpPr>
-              <p:cNvPr id="7" name="Freeform 7"/>
+              <p:cNvPr id="10" name="Freeform 10"/>
               <p:cNvSpPr/>
               <p:nvPr/>
             </p:nvSpPr>
@@ -12748,7 +13442,7 @@
           </p:sp>
           <p:sp>
             <p:nvSpPr>
-              <p:cNvPr id="8" name="Freeform 8"/>
+              <p:cNvPr id="11" name="Freeform 11"/>
               <p:cNvSpPr/>
               <p:nvPr/>
             </p:nvSpPr>
@@ -12913,7 +13607,7 @@
         </p:grpSp>
         <p:sp>
           <p:nvSpPr>
-            <p:cNvPr id="10" name="TextBox 10"/>
+            <p:cNvPr id="13" name="TextBox 13"/>
             <p:cNvSpPr txBox="1"/>
             <p:nvPr/>
           </p:nvSpPr>
@@ -12953,7 +13647,7 @@
         </p:sp>
         <p:sp>
           <p:nvSpPr>
-            <p:cNvPr id="11" name="TextBox 11"/>
+            <p:cNvPr id="14" name="TextBox 14"/>
             <p:cNvSpPr txBox="1"/>
             <p:nvPr/>
           </p:nvSpPr>
@@ -12993,7 +13687,7 @@
         </p:sp>
         <p:sp>
           <p:nvSpPr>
-            <p:cNvPr id="12" name="TextBox 12"/>
+            <p:cNvPr id="15" name="TextBox 15"/>
             <p:cNvSpPr txBox="1"/>
             <p:nvPr/>
           </p:nvSpPr>
@@ -13033,7 +13727,7 @@
         </p:sp>
         <p:sp>
           <p:nvSpPr>
-            <p:cNvPr id="13" name="Rectangle 13"/>
+            <p:cNvPr id="16" name="Rectangle 16"/>
             <p:cNvSpPr/>
             <p:nvPr/>
           </p:nvSpPr>
@@ -13059,7 +13753,7 @@
         </p:sp>
         <p:sp>
           <p:nvSpPr>
-            <p:cNvPr id="14" name="Rectangle 14"/>
+            <p:cNvPr id="17" name="Rectangle 17"/>
             <p:cNvSpPr/>
             <p:nvPr/>
           </p:nvSpPr>
@@ -13074,7 +13768,9 @@
               </a:avLst>
             </a:prstGeom>
             <a:solidFill>
-              <a:srgbClr val="FFFFFF"/>
+              <a:srgbClr val="FFFFFF">
+                <a:alpha val="86000"/>
+              </a:srgbClr>
             </a:solidFill>
             <a:ln>
               <a:noFill/>
@@ -13090,7 +13786,7 @@
         </p:sp>
         <p:grpSp>
           <p:nvGrpSpPr>
-            <p:cNvPr id="17" name="Group 17"/>
+            <p:cNvPr id="20" name="Group 20"/>
             <p:cNvGrpSpPr/>
             <p:nvPr/>
           </p:nvGrpSpPr>
@@ -13104,7 +13800,7 @@
           </p:grpSpPr>
           <p:sp>
             <p:nvSpPr>
-              <p:cNvPr id="15" name="Freeform 15"/>
+              <p:cNvPr id="18" name="Freeform 18"/>
               <p:cNvSpPr/>
               <p:nvPr/>
             </p:nvSpPr>
@@ -13167,7 +13863,7 @@
           </p:sp>
           <p:sp>
             <p:nvSpPr>
-              <p:cNvPr id="16" name="Freeform 16"/>
+              <p:cNvPr id="19" name="Freeform 19"/>
               <p:cNvSpPr/>
               <p:nvPr/>
             </p:nvSpPr>
@@ -13281,7 +13977,7 @@
         </p:grpSp>
         <p:sp>
           <p:nvSpPr>
-            <p:cNvPr id="18" name="TextBox 18"/>
+            <p:cNvPr id="21" name="TextBox 21"/>
             <p:cNvSpPr txBox="1"/>
             <p:nvPr/>
           </p:nvSpPr>
@@ -13321,7 +14017,7 @@
         </p:sp>
         <p:sp>
           <p:nvSpPr>
-            <p:cNvPr id="19" name="TextBox 19"/>
+            <p:cNvPr id="22" name="TextBox 22"/>
             <p:cNvSpPr txBox="1"/>
             <p:nvPr/>
           </p:nvSpPr>
@@ -13361,7 +14057,7 @@
         </p:sp>
         <p:sp>
           <p:nvSpPr>
-            <p:cNvPr id="20" name="TextBox 20"/>
+            <p:cNvPr id="23" name="TextBox 23"/>
             <p:cNvSpPr txBox="1"/>
             <p:nvPr/>
           </p:nvSpPr>
@@ -13401,7 +14097,7 @@
         </p:sp>
         <p:sp>
           <p:nvSpPr>
-            <p:cNvPr id="21" name="Rectangle 21"/>
+            <p:cNvPr id="24" name="Rectangle 24"/>
             <p:cNvSpPr/>
             <p:nvPr/>
           </p:nvSpPr>
@@ -13427,7 +14123,7 @@
         </p:sp>
         <p:sp>
           <p:nvSpPr>
-            <p:cNvPr id="22" name="Rectangle 22"/>
+            <p:cNvPr id="25" name="Rectangle 25"/>
             <p:cNvSpPr/>
             <p:nvPr/>
           </p:nvSpPr>
@@ -13442,7 +14138,9 @@
               </a:avLst>
             </a:prstGeom>
             <a:solidFill>
-              <a:srgbClr val="FFFFFF"/>
+              <a:srgbClr val="FFFFFF">
+                <a:alpha val="86000"/>
+              </a:srgbClr>
             </a:solidFill>
             <a:ln>
               <a:noFill/>
@@ -13458,7 +14156,7 @@
         </p:sp>
         <p:grpSp>
           <p:nvGrpSpPr>
-            <p:cNvPr id="25" name="Group 25"/>
+            <p:cNvPr id="28" name="Group 28"/>
             <p:cNvGrpSpPr/>
             <p:nvPr/>
           </p:nvGrpSpPr>
@@ -13472,7 +14170,7 @@
           </p:grpSpPr>
           <p:sp>
             <p:nvSpPr>
-              <p:cNvPr id="23" name="Freeform 23"/>
+              <p:cNvPr id="26" name="Freeform 26"/>
               <p:cNvSpPr/>
               <p:nvPr/>
             </p:nvSpPr>
@@ -13540,7 +14238,7 @@
           </p:sp>
           <p:sp>
             <p:nvSpPr>
-              <p:cNvPr id="24" name="Freeform 24"/>
+              <p:cNvPr id="27" name="Freeform 27"/>
               <p:cNvSpPr/>
               <p:nvPr/>
             </p:nvSpPr>
@@ -13670,7 +14368,7 @@
         </p:grpSp>
         <p:sp>
           <p:nvSpPr>
-            <p:cNvPr id="26" name="TextBox 26"/>
+            <p:cNvPr id="29" name="TextBox 29"/>
             <p:cNvSpPr txBox="1"/>
             <p:nvPr/>
           </p:nvSpPr>
@@ -13710,7 +14408,7 @@
         </p:sp>
         <p:sp>
           <p:nvSpPr>
-            <p:cNvPr id="27" name="TextBox 27"/>
+            <p:cNvPr id="30" name="TextBox 30"/>
             <p:cNvSpPr txBox="1"/>
             <p:nvPr/>
           </p:nvSpPr>
@@ -13750,7 +14448,7 @@
         </p:sp>
         <p:sp>
           <p:nvSpPr>
-            <p:cNvPr id="28" name="TextBox 28"/>
+            <p:cNvPr id="31" name="TextBox 31"/>
             <p:cNvSpPr txBox="1"/>
             <p:nvPr/>
           </p:nvSpPr>
@@ -13791,7 +14489,7 @@
       </p:grpSp>
       <p:grpSp>
         <p:nvGrpSpPr>
-          <p:cNvPr id="52" name="close"/>
+          <p:cNvPr id="55" name="close"/>
           <p:cNvGrpSpPr/>
           <p:nvPr/>
         </p:nvGrpSpPr>
@@ -13805,7 +14503,7 @@
         </p:grpSpPr>
         <p:sp>
           <p:nvSpPr>
-            <p:cNvPr id="30" name="Rectangle 30"/>
+            <p:cNvPr id="33" name="Rectangle 33"/>
             <p:cNvSpPr/>
             <p:nvPr/>
           </p:nvSpPr>
@@ -13831,7 +14529,7 @@
         </p:sp>
         <p:sp>
           <p:nvSpPr>
-            <p:cNvPr id="31" name="Rectangle 31"/>
+            <p:cNvPr id="34" name="Rectangle 34"/>
             <p:cNvSpPr/>
             <p:nvPr/>
           </p:nvSpPr>
@@ -13846,7 +14544,9 @@
               </a:avLst>
             </a:prstGeom>
             <a:solidFill>
-              <a:srgbClr val="FFFFFF"/>
+              <a:srgbClr val="FFFFFF">
+                <a:alpha val="86000"/>
+              </a:srgbClr>
             </a:solidFill>
             <a:ln>
               <a:noFill/>
@@ -13862,7 +14562,7 @@
         </p:sp>
         <p:grpSp>
           <p:nvGrpSpPr>
-            <p:cNvPr id="34" name="Group 34"/>
+            <p:cNvPr id="37" name="Group 37"/>
             <p:cNvGrpSpPr/>
             <p:nvPr/>
           </p:nvGrpSpPr>
@@ -13876,7 +14576,7 @@
           </p:grpSpPr>
           <p:sp>
             <p:nvSpPr>
-              <p:cNvPr id="32" name="Freeform 32"/>
+              <p:cNvPr id="35" name="Freeform 35"/>
               <p:cNvSpPr/>
               <p:nvPr/>
             </p:nvSpPr>
@@ -13944,7 +14644,7 @@
           </p:sp>
           <p:sp>
             <p:nvSpPr>
-              <p:cNvPr id="33" name="Freeform 33"/>
+              <p:cNvPr id="36" name="Freeform 36"/>
               <p:cNvSpPr/>
               <p:nvPr/>
             </p:nvSpPr>
@@ -14174,7 +14874,7 @@
         </p:grpSp>
         <p:sp>
           <p:nvSpPr>
-            <p:cNvPr id="35" name="TextBox 35"/>
+            <p:cNvPr id="38" name="TextBox 38"/>
             <p:cNvSpPr txBox="1"/>
             <p:nvPr/>
           </p:nvSpPr>
@@ -14214,7 +14914,7 @@
         </p:sp>
         <p:grpSp>
           <p:nvGrpSpPr>
-            <p:cNvPr id="38" name="Group 38"/>
+            <p:cNvPr id="41" name="Group 41"/>
             <p:cNvGrpSpPr/>
             <p:nvPr/>
           </p:nvGrpSpPr>
@@ -14228,7 +14928,7 @@
           </p:grpSpPr>
           <p:sp>
             <p:nvSpPr>
-              <p:cNvPr id="36" name="Freeform 36"/>
+              <p:cNvPr id="39" name="Freeform 39"/>
               <p:cNvSpPr/>
               <p:nvPr/>
             </p:nvSpPr>
@@ -14296,7 +14996,7 @@
           </p:sp>
           <p:sp>
             <p:nvSpPr>
-              <p:cNvPr id="37" name="Freeform 37"/>
+              <p:cNvPr id="40" name="Freeform 40"/>
               <p:cNvSpPr/>
               <p:nvPr/>
             </p:nvSpPr>
@@ -14420,7 +15120,7 @@
         </p:grpSp>
         <p:sp>
           <p:nvSpPr>
-            <p:cNvPr id="39" name="TextBox 39"/>
+            <p:cNvPr id="42" name="TextBox 42"/>
             <p:cNvSpPr txBox="1"/>
             <p:nvPr/>
           </p:nvSpPr>
@@ -14460,7 +15160,7 @@
         </p:sp>
         <p:grpSp>
           <p:nvGrpSpPr>
-            <p:cNvPr id="42" name="Group 42"/>
+            <p:cNvPr id="45" name="Group 45"/>
             <p:cNvGrpSpPr/>
             <p:nvPr/>
           </p:nvGrpSpPr>
@@ -14474,7 +15174,7 @@
           </p:grpSpPr>
           <p:sp>
             <p:nvSpPr>
-              <p:cNvPr id="40" name="Freeform 40"/>
+              <p:cNvPr id="43" name="Freeform 43"/>
               <p:cNvSpPr/>
               <p:nvPr/>
             </p:nvSpPr>
@@ -14574,7 +15274,7 @@
           </p:sp>
           <p:sp>
             <p:nvSpPr>
-              <p:cNvPr id="41" name="Freeform 41"/>
+              <p:cNvPr id="44" name="Freeform 44"/>
               <p:cNvSpPr/>
               <p:nvPr/>
             </p:nvSpPr>
@@ -14854,7 +15554,7 @@
         </p:grpSp>
         <p:sp>
           <p:nvSpPr>
-            <p:cNvPr id="43" name="TextBox 43"/>
+            <p:cNvPr id="46" name="TextBox 46"/>
             <p:cNvSpPr txBox="1"/>
             <p:nvPr/>
           </p:nvSpPr>
@@ -14894,7 +15594,7 @@
         </p:sp>
         <p:grpSp>
           <p:nvGrpSpPr>
-            <p:cNvPr id="46" name="Group 46"/>
+            <p:cNvPr id="49" name="Group 49"/>
             <p:cNvGrpSpPr/>
             <p:nvPr/>
           </p:nvGrpSpPr>
@@ -14908,7 +15608,7 @@
           </p:grpSpPr>
           <p:sp>
             <p:nvSpPr>
-              <p:cNvPr id="44" name="Freeform 44"/>
+              <p:cNvPr id="47" name="Freeform 47"/>
               <p:cNvSpPr/>
               <p:nvPr/>
             </p:nvSpPr>
@@ -14976,7 +15676,7 @@
           </p:sp>
           <p:sp>
             <p:nvSpPr>
-              <p:cNvPr id="45" name="Freeform 45"/>
+              <p:cNvPr id="48" name="Freeform 48"/>
               <p:cNvSpPr/>
               <p:nvPr/>
             </p:nvSpPr>
@@ -15106,7 +15806,7 @@
         </p:grpSp>
         <p:sp>
           <p:nvSpPr>
-            <p:cNvPr id="47" name="TextBox 47"/>
+            <p:cNvPr id="50" name="TextBox 50"/>
             <p:cNvSpPr txBox="1"/>
             <p:nvPr/>
           </p:nvSpPr>
@@ -15146,7 +15846,7 @@
         </p:sp>
         <p:grpSp>
           <p:nvGrpSpPr>
-            <p:cNvPr id="50" name="Group 50"/>
+            <p:cNvPr id="53" name="Group 53"/>
             <p:cNvGrpSpPr/>
             <p:nvPr/>
           </p:nvGrpSpPr>
@@ -15160,7 +15860,7 @@
           </p:grpSpPr>
           <p:sp>
             <p:nvSpPr>
-              <p:cNvPr id="48" name="Freeform 48"/>
+              <p:cNvPr id="51" name="Freeform 51"/>
               <p:cNvSpPr/>
               <p:nvPr/>
             </p:nvSpPr>
@@ -15276,7 +15976,7 @@
           </p:sp>
           <p:sp>
             <p:nvSpPr>
-              <p:cNvPr id="49" name="Freeform 49"/>
+              <p:cNvPr id="52" name="Freeform 52"/>
               <p:cNvSpPr/>
               <p:nvPr/>
             </p:nvSpPr>
@@ -15691,7 +16391,7 @@
         </p:grpSp>
         <p:sp>
           <p:nvSpPr>
-            <p:cNvPr id="51" name="TextBox 51"/>
+            <p:cNvPr id="54" name="TextBox 54"/>
             <p:cNvSpPr txBox="1"/>
             <p:nvPr/>
           </p:nvSpPr>

</xml_diff>

<commit_message>
Deepen the gradient so the slides read more formal.
</commit_message>
<xml_diff>
--- a/docs/Wealth-Symposium-Activity.pptx
+++ b/docs/Wealth-Symposium-Activity.pptx
@@ -1162,13 +1162,13 @@
         <a:gradFill>
           <a:gsLst>
             <a:gs pos="0">
-              <a:srgbClr val="FFE4F2"/>
+              <a:srgbClr val="E2C2CE"/>
             </a:gs>
             <a:gs pos="46000">
-              <a:srgbClr val="E4DCFF"/>
+              <a:srgbClr val="C8B6DE"/>
             </a:gs>
             <a:gs pos="100000">
-              <a:srgbClr val="DCEBFF"/>
+              <a:srgbClr val="B4C3D6"/>
             </a:gs>
           </a:gsLst>
           <a:lin ang="2700000" scaled="1"/>
@@ -1207,14 +1207,14 @@
           <a:gradFill>
             <a:gsLst>
               <a:gs pos="0">
-                <a:srgbClr val="FF4D6A">
-                  <a:alpha val="72000"/>
-                </a:srgbClr>
+                <a:schemeClr val="accent2">
+                  <a:alpha val="42000"/>
+                </a:schemeClr>
               </a:gs>
               <a:gs pos="100000">
-                <a:srgbClr val="FF4D6A">
+                <a:schemeClr val="accent2">
                   <a:alpha val="0"/>
-                </a:srgbClr>
+                </a:schemeClr>
               </a:gs>
             </a:gsLst>
             <a:path path="circle">
@@ -1243,12 +1243,12 @@
           <a:gradFill>
             <a:gsLst>
               <a:gs pos="0">
-                <a:srgbClr val="6E63FF">
-                  <a:alpha val="62000"/>
+                <a:srgbClr val="3C348C">
+                  <a:alpha val="40000"/>
                 </a:srgbClr>
               </a:gs>
               <a:gs pos="100000">
-                <a:srgbClr val="6E63FF">
+                <a:srgbClr val="3C348C">
                   <a:alpha val="0"/>
                 </a:srgbClr>
               </a:gs>
@@ -1280,7 +1280,7 @@
             <a:gsLst>
               <a:gs pos="0">
                 <a:srgbClr val="FFFFFF">
-                  <a:alpha val="85000"/>
+                  <a:alpha val="28000"/>
                 </a:srgbClr>
               </a:gs>
               <a:gs pos="100000">
@@ -3348,13 +3348,13 @@
         <a:gradFill>
           <a:gsLst>
             <a:gs pos="0">
-              <a:srgbClr val="FFE4F2"/>
+              <a:srgbClr val="E2C2CE"/>
             </a:gs>
             <a:gs pos="46000">
-              <a:srgbClr val="E4DCFF"/>
+              <a:srgbClr val="C8B6DE"/>
             </a:gs>
             <a:gs pos="100000">
-              <a:srgbClr val="DCEBFF"/>
+              <a:srgbClr val="B4C3D6"/>
             </a:gs>
           </a:gsLst>
           <a:lin ang="2700000" scaled="1"/>
@@ -3393,14 +3393,14 @@
           <a:gradFill>
             <a:gsLst>
               <a:gs pos="0">
-                <a:srgbClr val="FF4D6A">
-                  <a:alpha val="72000"/>
-                </a:srgbClr>
+                <a:schemeClr val="accent2">
+                  <a:alpha val="42000"/>
+                </a:schemeClr>
               </a:gs>
               <a:gs pos="100000">
-                <a:srgbClr val="FF4D6A">
+                <a:schemeClr val="accent2">
                   <a:alpha val="0"/>
-                </a:srgbClr>
+                </a:schemeClr>
               </a:gs>
             </a:gsLst>
             <a:path path="circle">
@@ -3429,12 +3429,12 @@
           <a:gradFill>
             <a:gsLst>
               <a:gs pos="0">
-                <a:srgbClr val="6E63FF">
-                  <a:alpha val="62000"/>
+                <a:srgbClr val="3C348C">
+                  <a:alpha val="40000"/>
                 </a:srgbClr>
               </a:gs>
               <a:gs pos="100000">
-                <a:srgbClr val="6E63FF">
+                <a:srgbClr val="3C348C">
                   <a:alpha val="0"/>
                 </a:srgbClr>
               </a:gs>
@@ -3466,7 +3466,7 @@
             <a:gsLst>
               <a:gs pos="0">
                 <a:srgbClr val="FFFFFF">
-                  <a:alpha val="85000"/>
+                  <a:alpha val="28000"/>
                 </a:srgbClr>
               </a:gs>
               <a:gs pos="100000">
@@ -6340,13 +6340,13 @@
         <a:gradFill>
           <a:gsLst>
             <a:gs pos="0">
-              <a:srgbClr val="FFE4F2"/>
+              <a:srgbClr val="E2C2CE"/>
             </a:gs>
             <a:gs pos="46000">
-              <a:srgbClr val="E4DCFF"/>
+              <a:srgbClr val="C8B6DE"/>
             </a:gs>
             <a:gs pos="100000">
-              <a:srgbClr val="DCEBFF"/>
+              <a:srgbClr val="B4C3D6"/>
             </a:gs>
           </a:gsLst>
           <a:lin ang="2700000" scaled="1"/>
@@ -6385,14 +6385,14 @@
           <a:gradFill>
             <a:gsLst>
               <a:gs pos="0">
-                <a:srgbClr val="FF4D6A">
-                  <a:alpha val="72000"/>
-                </a:srgbClr>
+                <a:schemeClr val="accent2">
+                  <a:alpha val="42000"/>
+                </a:schemeClr>
               </a:gs>
               <a:gs pos="100000">
-                <a:srgbClr val="FF4D6A">
+                <a:schemeClr val="accent2">
                   <a:alpha val="0"/>
-                </a:srgbClr>
+                </a:schemeClr>
               </a:gs>
             </a:gsLst>
             <a:path path="circle">
@@ -6421,12 +6421,12 @@
           <a:gradFill>
             <a:gsLst>
               <a:gs pos="0">
-                <a:srgbClr val="6E63FF">
-                  <a:alpha val="62000"/>
+                <a:srgbClr val="3C348C">
+                  <a:alpha val="40000"/>
                 </a:srgbClr>
               </a:gs>
               <a:gs pos="100000">
-                <a:srgbClr val="6E63FF">
+                <a:srgbClr val="3C348C">
                   <a:alpha val="0"/>
                 </a:srgbClr>
               </a:gs>
@@ -6458,7 +6458,7 @@
             <a:gsLst>
               <a:gs pos="0">
                 <a:srgbClr val="FFFFFF">
-                  <a:alpha val="85000"/>
+                  <a:alpha val="28000"/>
                 </a:srgbClr>
               </a:gs>
               <a:gs pos="100000">
@@ -8550,13 +8550,13 @@
         <a:gradFill>
           <a:gsLst>
             <a:gs pos="0">
-              <a:srgbClr val="FFE4F2"/>
+              <a:srgbClr val="E2C2CE"/>
             </a:gs>
             <a:gs pos="46000">
-              <a:srgbClr val="E4DCFF"/>
+              <a:srgbClr val="C8B6DE"/>
             </a:gs>
             <a:gs pos="100000">
-              <a:srgbClr val="DCEBFF"/>
+              <a:srgbClr val="B4C3D6"/>
             </a:gs>
           </a:gsLst>
           <a:lin ang="2700000" scaled="1"/>
@@ -8595,14 +8595,14 @@
           <a:gradFill>
             <a:gsLst>
               <a:gs pos="0">
-                <a:srgbClr val="FF4D6A">
-                  <a:alpha val="72000"/>
-                </a:srgbClr>
+                <a:schemeClr val="accent2">
+                  <a:alpha val="42000"/>
+                </a:schemeClr>
               </a:gs>
               <a:gs pos="100000">
-                <a:srgbClr val="FF4D6A">
+                <a:schemeClr val="accent2">
                   <a:alpha val="0"/>
-                </a:srgbClr>
+                </a:schemeClr>
               </a:gs>
             </a:gsLst>
             <a:path path="circle">
@@ -8631,12 +8631,12 @@
           <a:gradFill>
             <a:gsLst>
               <a:gs pos="0">
-                <a:srgbClr val="6E63FF">
-                  <a:alpha val="62000"/>
+                <a:srgbClr val="3C348C">
+                  <a:alpha val="40000"/>
                 </a:srgbClr>
               </a:gs>
               <a:gs pos="100000">
-                <a:srgbClr val="6E63FF">
+                <a:srgbClr val="3C348C">
                   <a:alpha val="0"/>
                 </a:srgbClr>
               </a:gs>
@@ -8668,7 +8668,7 @@
             <a:gsLst>
               <a:gs pos="0">
                 <a:srgbClr val="FFFFFF">
-                  <a:alpha val="85000"/>
+                  <a:alpha val="28000"/>
                 </a:srgbClr>
               </a:gs>
               <a:gs pos="100000">
@@ -11212,13 +11212,13 @@
         <a:gradFill>
           <a:gsLst>
             <a:gs pos="0">
-              <a:srgbClr val="FFE4F2"/>
+              <a:srgbClr val="E2C2CE"/>
             </a:gs>
             <a:gs pos="46000">
-              <a:srgbClr val="E4DCFF"/>
+              <a:srgbClr val="C8B6DE"/>
             </a:gs>
             <a:gs pos="100000">
-              <a:srgbClr val="DCEBFF"/>
+              <a:srgbClr val="B4C3D6"/>
             </a:gs>
           </a:gsLst>
           <a:lin ang="2700000" scaled="1"/>
@@ -11257,14 +11257,14 @@
           <a:gradFill>
             <a:gsLst>
               <a:gs pos="0">
-                <a:srgbClr val="FF4D6A">
-                  <a:alpha val="72000"/>
-                </a:srgbClr>
+                <a:schemeClr val="accent2">
+                  <a:alpha val="42000"/>
+                </a:schemeClr>
               </a:gs>
               <a:gs pos="100000">
-                <a:srgbClr val="FF4D6A">
+                <a:schemeClr val="accent2">
                   <a:alpha val="0"/>
-                </a:srgbClr>
+                </a:schemeClr>
               </a:gs>
             </a:gsLst>
             <a:path path="circle">
@@ -11293,12 +11293,12 @@
           <a:gradFill>
             <a:gsLst>
               <a:gs pos="0">
-                <a:srgbClr val="6E63FF">
-                  <a:alpha val="62000"/>
+                <a:srgbClr val="3C348C">
+                  <a:alpha val="40000"/>
                 </a:srgbClr>
               </a:gs>
               <a:gs pos="100000">
-                <a:srgbClr val="6E63FF">
+                <a:srgbClr val="3C348C">
                   <a:alpha val="0"/>
                 </a:srgbClr>
               </a:gs>
@@ -11330,7 +11330,7 @@
             <a:gsLst>
               <a:gs pos="0">
                 <a:srgbClr val="FFFFFF">
-                  <a:alpha val="85000"/>
+                  <a:alpha val="28000"/>
                 </a:srgbClr>
               </a:gs>
               <a:gs pos="100000">
@@ -13064,13 +13064,13 @@
         <a:gradFill>
           <a:gsLst>
             <a:gs pos="0">
-              <a:srgbClr val="FFE4F2"/>
+              <a:srgbClr val="E2C2CE"/>
             </a:gs>
             <a:gs pos="46000">
-              <a:srgbClr val="E4DCFF"/>
+              <a:srgbClr val="C8B6DE"/>
             </a:gs>
             <a:gs pos="100000">
-              <a:srgbClr val="DCEBFF"/>
+              <a:srgbClr val="B4C3D6"/>
             </a:gs>
           </a:gsLst>
           <a:lin ang="2700000" scaled="1"/>
@@ -13109,14 +13109,14 @@
           <a:gradFill>
             <a:gsLst>
               <a:gs pos="0">
-                <a:srgbClr val="FF4D6A">
-                  <a:alpha val="72000"/>
-                </a:srgbClr>
+                <a:schemeClr val="accent2">
+                  <a:alpha val="42000"/>
+                </a:schemeClr>
               </a:gs>
               <a:gs pos="100000">
-                <a:srgbClr val="FF4D6A">
+                <a:schemeClr val="accent2">
                   <a:alpha val="0"/>
-                </a:srgbClr>
+                </a:schemeClr>
               </a:gs>
             </a:gsLst>
             <a:path path="circle">
@@ -13145,12 +13145,12 @@
           <a:gradFill>
             <a:gsLst>
               <a:gs pos="0">
-                <a:srgbClr val="6E63FF">
-                  <a:alpha val="62000"/>
+                <a:srgbClr val="3C348C">
+                  <a:alpha val="40000"/>
                 </a:srgbClr>
               </a:gs>
               <a:gs pos="100000">
-                <a:srgbClr val="6E63FF">
+                <a:srgbClr val="3C348C">
                   <a:alpha val="0"/>
                 </a:srgbClr>
               </a:gs>
@@ -13182,7 +13182,7 @@
             <a:gsLst>
               <a:gs pos="0">
                 <a:srgbClr val="FFFFFF">
-                  <a:alpha val="85000"/>
+                  <a:alpha val="28000"/>
                 </a:srgbClr>
               </a:gs>
               <a:gs pos="100000">

</xml_diff>